<commit_message>
feat: update workshop to showcase Azure DevOps integration (CLI Skill + MCP)
Replaced GitHub-centric MCP examples with ADO-specific content based on
internal Copilot-Wiki ADO integration guide. Pillar 5 now covers both
CLI Skill (recommended, on-demand) and MCP Server (88 tools, heavy usage)
approaches side-by-side. Updated opening demo, capstone, and PPTX.

Co-Authored-By: Claude Opus 4.6 (1M context) <noreply@anthropic.com>
</commit_message>
<xml_diff>
--- a/WORKSHOP-PRESENTATION.pptx
+++ b/WORKSHOP-PRESENTATION.pptx
@@ -3217,7 +3217,7 @@
                 <a:ea typeface="Arial Black" pitchFamily="34" charset="-122"/>
                 <a:cs typeface="Arial Black" pitchFamily="34" charset="-120"/>
               </a:rPr>
-              <a:t>MCP (Model Context Protocol)</a:t>
+              <a:t>MCP &amp; External Integrations</a:t>
             </a:r>
             <a:endParaRPr lang="en-US" sz="2800" dirty="0"/>
           </a:p>
@@ -3256,7 +3256,7 @@
                 <a:ea typeface="Calibri" pitchFamily="34" charset="-122"/>
                 <a:cs typeface="Calibri" pitchFamily="34" charset="-120"/>
               </a:rPr>
-              <a:t>How AI reaches external systems — browser extensions for Copilot</a:t>
+              <a:t>Two ways to connect AI to Azure DevOps</a:t>
             </a:r>
             <a:endParaRPr lang="en-US" sz="1400" dirty="0"/>
           </a:p>
@@ -3271,7 +3271,7 @@
         <p:spPr>
           <a:xfrm>
             <a:off x="731520" y="1417320"/>
-            <a:ext cx="2468880" cy="1188720"/>
+            <a:ext cx="3749040" cy="2011680"/>
           </a:xfrm>
           <a:prstGeom prst="rect">
             <a:avLst/>
@@ -3298,13 +3298,13 @@
         <p:spPr>
           <a:xfrm>
             <a:off x="731520" y="1417320"/>
-            <a:ext cx="2468880" cy="54864"/>
+            <a:ext cx="3749040" cy="54864"/>
           </a:xfrm>
           <a:prstGeom prst="rect">
             <a:avLst/>
           </a:prstGeom>
           <a:solidFill>
-            <a:srgbClr val="0EA5E9"/>
+            <a:srgbClr val="10B981"/>
           </a:solidFill>
           <a:ln/>
         </p:spPr>
@@ -3317,8 +3317,8 @@
         </p:nvSpPr>
         <p:spPr>
           <a:xfrm>
-            <a:off x="914400" y="1554480"/>
-            <a:ext cx="2103120" cy="274320"/>
+            <a:off x="1005840" y="1554480"/>
+            <a:ext cx="3200400" cy="228600"/>
           </a:xfrm>
           <a:prstGeom prst="rect">
             <a:avLst/>
@@ -3334,7 +3334,50 @@
               <a:buNone/>
             </a:pPr>
             <a:r>
-              <a:rPr lang="en-US" sz="1400" b="1" dirty="0">
+              <a:rPr lang="en-US" sz="1000" b="1" spc="200" kern="0" dirty="0">
+                <a:solidFill>
+                  <a:srgbClr val="10B981"/>
+                </a:solidFill>
+                <a:latin typeface="Calibri" pitchFamily="34" charset="0"/>
+                <a:ea typeface="Calibri" pitchFamily="34" charset="-122"/>
+                <a:cs typeface="Calibri" pitchFamily="34" charset="-120"/>
+              </a:rPr>
+              <a:t>CLI SKILL (RECOMMENDED)</a:t>
+            </a:r>
+            <a:endParaRPr lang="en-US" sz="1000" dirty="0"/>
+          </a:p>
+        </p:txBody>
+      </p:sp>
+      <p:sp>
+        <p:nvSpPr>
+          <p:cNvPr id="9" name="Text 7"/>
+          <p:cNvSpPr/>
+          <p:nvPr/>
+        </p:nvSpPr>
+        <p:spPr>
+          <a:xfrm>
+            <a:off x="1005840" y="1828800"/>
+            <a:ext cx="3200400" cy="1463040"/>
+          </a:xfrm>
+          <a:prstGeom prst="rect">
+            <a:avLst/>
+          </a:prstGeom>
+          <a:noFill/>
+          <a:ln/>
+        </p:spPr>
+        <p:txBody>
+          <a:bodyPr wrap="square" lIns="0" tIns="0" rIns="0" bIns="0" rtlCol="0" anchor="ctr"/>
+          <a:lstStyle/>
+          <a:p>
+            <a:pPr marL="342900" indent="-342900">
+              <a:spcAft>
+                <a:spcPts val="400"/>
+              </a:spcAft>
+              <a:buSzPct val="100000"/>
+              <a:buChar char="•"/>
+            </a:pPr>
+            <a:r>
+              <a:rPr lang="en-US" sz="1100" dirty="0">
                 <a:solidFill>
                   <a:srgbClr val="1E293B"/>
                 </a:solidFill>
@@ -3342,100 +3385,127 @@
                 <a:ea typeface="Calibri" pitchFamily="34" charset="-122"/>
                 <a:cs typeface="Calibri" pitchFamily="34" charset="-120"/>
               </a:rPr>
-              <a:t>GitHub</a:t>
-            </a:r>
-            <a:endParaRPr lang="en-US" sz="1400" dirty="0"/>
-          </a:p>
-        </p:txBody>
-      </p:sp>
-      <p:sp>
-        <p:nvSpPr>
-          <p:cNvPr id="9" name="Text 7"/>
-          <p:cNvSpPr/>
-          <p:nvPr/>
-        </p:nvSpPr>
-        <p:spPr>
-          <a:xfrm>
-            <a:off x="914400" y="1828800"/>
-            <a:ext cx="2103120" cy="274320"/>
-          </a:xfrm>
-          <a:prstGeom prst="rect">
-            <a:avLst/>
-          </a:prstGeom>
-          <a:noFill/>
-          <a:ln/>
-        </p:spPr>
-        <p:txBody>
-          <a:bodyPr wrap="square" lIns="0" tIns="0" rIns="0" bIns="0" rtlCol="0" anchor="ctr"/>
-          <a:lstStyle/>
-          <a:p>
-            <a:pPr indent="0" marL="0">
-              <a:buNone/>
+              <a:t>Loads on-demand — context stays clean</a:t>
+            </a:r>
+            <a:endParaRPr lang="en-US" sz="1100" dirty="0"/>
+          </a:p>
+          <a:p>
+            <a:pPr marL="342900" indent="-342900">
+              <a:spcAft>
+                <a:spcPts val="400"/>
+              </a:spcAft>
+              <a:buSzPct val="100000"/>
+              <a:buChar char="•"/>
             </a:pPr>
             <a:r>
               <a:rPr lang="en-US" sz="1100" dirty="0">
                 <a:solidFill>
-                  <a:srgbClr val="475569"/>
-                </a:solidFill>
-                <a:latin typeface="Calibri" pitchFamily="34" charset="0"/>
-                <a:ea typeface="Calibri" pitchFamily="34" charset="-122"/>
-                <a:cs typeface="Calibri" pitchFamily="34" charset="-120"/>
-              </a:rPr>
-              <a:t>Issues, PRs, commits, repos</a:t>
+                  <a:srgbClr val="1E293B"/>
+                </a:solidFill>
+                <a:latin typeface="Calibri" pitchFamily="34" charset="0"/>
+                <a:ea typeface="Calibri" pitchFamily="34" charset="-122"/>
+                <a:cs typeface="Calibri" pitchFamily="34" charset="-120"/>
+              </a:rPr>
+              <a:t>Uses az CLI under the hood</a:t>
             </a:r>
             <a:endParaRPr lang="en-US" sz="1100" dirty="0"/>
           </a:p>
-        </p:txBody>
-      </p:sp>
-      <p:sp>
-        <p:nvSpPr>
-          <p:cNvPr id="10" name="Text 8"/>
-          <p:cNvSpPr/>
-          <p:nvPr/>
-        </p:nvSpPr>
-        <p:spPr>
-          <a:xfrm>
-            <a:off x="914400" y="2148840"/>
-            <a:ext cx="2103120" cy="274320"/>
-          </a:xfrm>
-          <a:prstGeom prst="rect">
-            <a:avLst/>
-          </a:prstGeom>
-          <a:noFill/>
-          <a:ln/>
-        </p:spPr>
-        <p:txBody>
-          <a:bodyPr wrap="square" lIns="0" tIns="0" rIns="0" bIns="0" rtlCol="0" anchor="ctr"/>
-          <a:lstStyle/>
-          <a:p>
-            <a:pPr indent="0" marL="0">
-              <a:buNone/>
-            </a:pPr>
-            <a:r>
-              <a:rPr lang="en-US" sz="1000" i="1" dirty="0">
-                <a:solidFill>
-                  <a:srgbClr val="0EA5E9"/>
-                </a:solidFill>
-                <a:latin typeface="Calibri" pitchFamily="34" charset="0"/>
-                <a:ea typeface="Calibri" pitchFamily="34" charset="-122"/>
-                <a:cs typeface="Calibri" pitchFamily="34" charset="-120"/>
-              </a:rPr>
-              <a:t>Built-in — just /login</a:t>
-            </a:r>
-            <a:endParaRPr lang="en-US" sz="1000" dirty="0"/>
-          </a:p>
-        </p:txBody>
-      </p:sp>
-      <p:sp>
-        <p:nvSpPr>
-          <p:cNvPr id="11" name="Shape 9"/>
-          <p:cNvSpPr/>
-          <p:nvPr/>
-        </p:nvSpPr>
-        <p:spPr>
-          <a:xfrm>
-            <a:off x="3383280" y="1417320"/>
-            <a:ext cx="2468880" cy="1188720"/>
+          <a:p>
+            <a:pPr marL="342900" indent="-342900">
+              <a:spcAft>
+                <a:spcPts val="400"/>
+              </a:spcAft>
+              <a:buSzPct val="100000"/>
+              <a:buChar char="•"/>
+            </a:pPr>
+            <a:r>
+              <a:rPr lang="en-US" sz="1100" dirty="0">
+                <a:solidFill>
+                  <a:srgbClr val="1E293B"/>
+                </a:solidFill>
+                <a:latin typeface="Calibri" pitchFamily="34" charset="0"/>
+                <a:ea typeface="Calibri" pitchFamily="34" charset="-122"/>
+                <a:cs typeface="Calibri" pitchFamily="34" charset="-120"/>
+              </a:rPr>
+              <a:t>Covers: work items, PRs, pipelines,</a:t>
+            </a:r>
+            <a:endParaRPr lang="en-US" sz="1100" dirty="0"/>
+          </a:p>
+          <a:p>
+            <a:pPr marL="342900" indent="-342900">
+              <a:spcAft>
+                <a:spcPts val="400"/>
+              </a:spcAft>
+              <a:buSzPct val="100000"/>
+              <a:buChar char="•"/>
+            </a:pPr>
+            <a:r>
+              <a:rPr lang="en-US" sz="1100" dirty="0">
+                <a:solidFill>
+                  <a:srgbClr val="1E293B"/>
+                </a:solidFill>
+                <a:latin typeface="Calibri" pitchFamily="34" charset="0"/>
+                <a:ea typeface="Calibri" pitchFamily="34" charset="-122"/>
+                <a:cs typeface="Calibri" pitchFamily="34" charset="-120"/>
+              </a:rPr>
+              <a:t>  wiki, releases, artifacts, security/admin</a:t>
+            </a:r>
+            <a:endParaRPr lang="en-US" sz="1100" dirty="0"/>
+          </a:p>
+          <a:p>
+            <a:pPr marL="342900" indent="-342900">
+              <a:spcAft>
+                <a:spcPts val="400"/>
+              </a:spcAft>
+              <a:buSzPct val="100000"/>
+              <a:buChar char="•"/>
+            </a:pPr>
+            <a:r>
+              <a:rPr lang="en-US" sz="1100" dirty="0">
+                <a:solidFill>
+                  <a:srgbClr val="1E293B"/>
+                </a:solidFill>
+                <a:latin typeface="Calibri" pitchFamily="34" charset="0"/>
+                <a:ea typeface="Calibri" pitchFamily="34" charset="-122"/>
+                <a:cs typeface="Calibri" pitchFamily="34" charset="-120"/>
+              </a:rPr>
+              <a:t>Install: npx skills add ... --skill</a:t>
+            </a:r>
+            <a:endParaRPr lang="en-US" sz="1100" dirty="0"/>
+          </a:p>
+          <a:p>
+            <a:pPr marL="342900" indent="-342900">
+              <a:spcAft>
+                <a:spcPts val="400"/>
+              </a:spcAft>
+              <a:buSzPct val="100000"/>
+              <a:buChar char="•"/>
+            </a:pPr>
+            <a:r>
+              <a:rPr lang="en-US" sz="1100" dirty="0">
+                <a:solidFill>
+                  <a:srgbClr val="1E293B"/>
+                </a:solidFill>
+                <a:latin typeface="Calibri" pitchFamily="34" charset="0"/>
+                <a:ea typeface="Calibri" pitchFamily="34" charset="-122"/>
+                <a:cs typeface="Calibri" pitchFamily="34" charset="-120"/>
+              </a:rPr>
+              <a:t>  azure-devops-cli</a:t>
+            </a:r>
+            <a:endParaRPr lang="en-US" sz="1100" dirty="0"/>
+          </a:p>
+        </p:txBody>
+      </p:sp>
+      <p:sp>
+        <p:nvSpPr>
+          <p:cNvPr id="10" name="Shape 8"/>
+          <p:cNvSpPr/>
+          <p:nvPr/>
+        </p:nvSpPr>
+        <p:spPr>
+          <a:xfrm>
+            <a:off x="4663440" y="1417320"/>
+            <a:ext cx="3749040" cy="2011680"/>
           </a:xfrm>
           <a:prstGeom prst="rect">
             <a:avLst/>
@@ -3455,14 +3525,14 @@
       </p:sp>
       <p:sp>
         <p:nvSpPr>
-          <p:cNvPr id="12" name="Shape 10"/>
-          <p:cNvSpPr/>
-          <p:nvPr/>
-        </p:nvSpPr>
-        <p:spPr>
-          <a:xfrm>
-            <a:off x="3383280" y="1417320"/>
-            <a:ext cx="2468880" cy="54864"/>
+          <p:cNvPr id="11" name="Shape 9"/>
+          <p:cNvSpPr/>
+          <p:nvPr/>
+        </p:nvSpPr>
+        <p:spPr>
+          <a:xfrm>
+            <a:off x="4663440" y="1417320"/>
+            <a:ext cx="3749040" cy="54864"/>
           </a:xfrm>
           <a:prstGeom prst="rect">
             <a:avLst/>
@@ -3475,14 +3545,53 @@
       </p:sp>
       <p:sp>
         <p:nvSpPr>
+          <p:cNvPr id="12" name="Text 10"/>
+          <p:cNvSpPr/>
+          <p:nvPr/>
+        </p:nvSpPr>
+        <p:spPr>
+          <a:xfrm>
+            <a:off x="4937760" y="1554480"/>
+            <a:ext cx="3200400" cy="228600"/>
+          </a:xfrm>
+          <a:prstGeom prst="rect">
+            <a:avLst/>
+          </a:prstGeom>
+          <a:noFill/>
+          <a:ln/>
+        </p:spPr>
+        <p:txBody>
+          <a:bodyPr wrap="square" lIns="0" tIns="0" rIns="0" bIns="0" rtlCol="0" anchor="ctr"/>
+          <a:lstStyle/>
+          <a:p>
+            <a:pPr indent="0" marL="0">
+              <a:buNone/>
+            </a:pPr>
+            <a:r>
+              <a:rPr lang="en-US" sz="1000" b="1" spc="200" kern="0" dirty="0">
+                <a:solidFill>
+                  <a:srgbClr val="0EA5E9"/>
+                </a:solidFill>
+                <a:latin typeface="Calibri" pitchFamily="34" charset="0"/>
+                <a:ea typeface="Calibri" pitchFamily="34" charset="-122"/>
+                <a:cs typeface="Calibri" pitchFamily="34" charset="-120"/>
+              </a:rPr>
+              <a:t>MCP SERVER</a:t>
+            </a:r>
+            <a:endParaRPr lang="en-US" sz="1000" dirty="0"/>
+          </a:p>
+        </p:txBody>
+      </p:sp>
+      <p:sp>
+        <p:nvSpPr>
           <p:cNvPr id="13" name="Text 11"/>
           <p:cNvSpPr/>
           <p:nvPr/>
         </p:nvSpPr>
         <p:spPr>
           <a:xfrm>
-            <a:off x="3566160" y="1554480"/>
-            <a:ext cx="2103120" cy="274320"/>
+            <a:off x="4937760" y="1828800"/>
+            <a:ext cx="3200400" cy="1463040"/>
           </a:xfrm>
           <a:prstGeom prst="rect">
             <a:avLst/>
@@ -3494,11 +3603,15 @@
           <a:bodyPr wrap="square" lIns="0" tIns="0" rIns="0" bIns="0" rtlCol="0" anchor="ctr"/>
           <a:lstStyle/>
           <a:p>
-            <a:pPr indent="0" marL="0">
-              <a:buNone/>
-            </a:pPr>
-            <a:r>
-              <a:rPr lang="en-US" sz="1400" b="1" dirty="0">
+            <a:pPr marL="342900" indent="-342900">
+              <a:spcAft>
+                <a:spcPts val="400"/>
+              </a:spcAft>
+              <a:buSzPct val="100000"/>
+              <a:buChar char="•"/>
+            </a:pPr>
+            <a:r>
+              <a:rPr lang="en-US" sz="1100" dirty="0">
                 <a:solidFill>
                   <a:srgbClr val="1E293B"/>
                 </a:solidFill>
@@ -3506,163 +3619,41 @@
                 <a:ea typeface="Calibri" pitchFamily="34" charset="-122"/>
                 <a:cs typeface="Calibri" pitchFamily="34" charset="-120"/>
               </a:rPr>
-              <a:t>Filesystem</a:t>
-            </a:r>
-            <a:endParaRPr lang="en-US" sz="1400" dirty="0"/>
-          </a:p>
-        </p:txBody>
-      </p:sp>
-      <p:sp>
-        <p:nvSpPr>
-          <p:cNvPr id="14" name="Text 12"/>
-          <p:cNvSpPr/>
-          <p:nvPr/>
-        </p:nvSpPr>
-        <p:spPr>
-          <a:xfrm>
-            <a:off x="3566160" y="1828800"/>
-            <a:ext cx="2103120" cy="274320"/>
-          </a:xfrm>
-          <a:prstGeom prst="rect">
-            <a:avLst/>
-          </a:prstGeom>
-          <a:noFill/>
-          <a:ln/>
-        </p:spPr>
-        <p:txBody>
-          <a:bodyPr wrap="square" lIns="0" tIns="0" rIns="0" bIns="0" rtlCol="0" anchor="ctr"/>
-          <a:lstStyle/>
-          <a:p>
-            <a:pPr indent="0" marL="0">
-              <a:buNone/>
+              <a:t>88 tools registered at startup</a:t>
+            </a:r>
+            <a:endParaRPr lang="en-US" sz="1100" dirty="0"/>
+          </a:p>
+          <a:p>
+            <a:pPr marL="342900" indent="-342900">
+              <a:spcAft>
+                <a:spcPts val="400"/>
+              </a:spcAft>
+              <a:buSzPct val="100000"/>
+              <a:buChar char="•"/>
             </a:pPr>
             <a:r>
               <a:rPr lang="en-US" sz="1100" dirty="0">
                 <a:solidFill>
-                  <a:srgbClr val="475569"/>
-                </a:solidFill>
-                <a:latin typeface="Calibri" pitchFamily="34" charset="0"/>
-                <a:ea typeface="Calibri" pitchFamily="34" charset="-122"/>
-                <a:cs typeface="Calibri" pitchFamily="34" charset="-120"/>
-              </a:rPr>
-              <a:t>Local files beyond @ refs</a:t>
+                  <a:srgbClr val="1E293B"/>
+                </a:solidFill>
+                <a:latin typeface="Calibri" pitchFamily="34" charset="0"/>
+                <a:ea typeface="Calibri" pitchFamily="34" charset="-122"/>
+                <a:cs typeface="Calibri" pitchFamily="34" charset="-120"/>
+              </a:rPr>
+              <a:t>Rich: test plans, code search,</a:t>
             </a:r>
             <a:endParaRPr lang="en-US" sz="1100" dirty="0"/>
           </a:p>
-        </p:txBody>
-      </p:sp>
-      <p:sp>
-        <p:nvSpPr>
-          <p:cNvPr id="15" name="Text 13"/>
-          <p:cNvSpPr/>
-          <p:nvPr/>
-        </p:nvSpPr>
-        <p:spPr>
-          <a:xfrm>
-            <a:off x="3566160" y="2148840"/>
-            <a:ext cx="2103120" cy="274320"/>
-          </a:xfrm>
-          <a:prstGeom prst="rect">
-            <a:avLst/>
-          </a:prstGeom>
-          <a:noFill/>
-          <a:ln/>
-        </p:spPr>
-        <p:txBody>
-          <a:bodyPr wrap="square" lIns="0" tIns="0" rIns="0" bIns="0" rtlCol="0" anchor="ctr"/>
-          <a:lstStyle/>
-          <a:p>
-            <a:pPr indent="0" marL="0">
-              <a:buNone/>
-            </a:pPr>
-            <a:r>
-              <a:rPr lang="en-US" sz="1000" i="1" dirty="0">
-                <a:solidFill>
-                  <a:srgbClr val="0EA5E9"/>
-                </a:solidFill>
-                <a:latin typeface="Calibri" pitchFamily="34" charset="0"/>
-                <a:ea typeface="Calibri" pitchFamily="34" charset="-122"/>
-                <a:cs typeface="Calibri" pitchFamily="34" charset="-120"/>
-              </a:rPr>
-              <a:t>Config file</a:t>
-            </a:r>
-            <a:endParaRPr lang="en-US" sz="1000" dirty="0"/>
-          </a:p>
-        </p:txBody>
-      </p:sp>
-      <p:sp>
-        <p:nvSpPr>
-          <p:cNvPr id="16" name="Shape 14"/>
-          <p:cNvSpPr/>
-          <p:nvPr/>
-        </p:nvSpPr>
-        <p:spPr>
-          <a:xfrm>
-            <a:off x="6035040" y="1417320"/>
-            <a:ext cx="2468880" cy="1188720"/>
-          </a:xfrm>
-          <a:prstGeom prst="rect">
-            <a:avLst/>
-          </a:prstGeom>
-          <a:solidFill>
-            <a:srgbClr val="FFFFFF"/>
-          </a:solidFill>
-          <a:ln/>
-          <a:effectLst>
-            <a:outerShdw sx="100000" sy="100000" kx="0" ky="0" algn="bl" rotWithShape="0" blurRad="50800" dist="25400" dir="8100000">
-              <a:srgbClr val="000000">
-                <a:alpha val="8000"/>
-              </a:srgbClr>
-            </a:outerShdw>
-          </a:effectLst>
-        </p:spPr>
-      </p:sp>
-      <p:sp>
-        <p:nvSpPr>
-          <p:cNvPr id="17" name="Shape 15"/>
-          <p:cNvSpPr/>
-          <p:nvPr/>
-        </p:nvSpPr>
-        <p:spPr>
-          <a:xfrm>
-            <a:off x="6035040" y="1417320"/>
-            <a:ext cx="2468880" cy="54864"/>
-          </a:xfrm>
-          <a:prstGeom prst="rect">
-            <a:avLst/>
-          </a:prstGeom>
-          <a:solidFill>
-            <a:srgbClr val="0EA5E9"/>
-          </a:solidFill>
-          <a:ln/>
-        </p:spPr>
-      </p:sp>
-      <p:sp>
-        <p:nvSpPr>
-          <p:cNvPr id="18" name="Text 16"/>
-          <p:cNvSpPr/>
-          <p:nvPr/>
-        </p:nvSpPr>
-        <p:spPr>
-          <a:xfrm>
-            <a:off x="6217920" y="1554480"/>
-            <a:ext cx="2103120" cy="274320"/>
-          </a:xfrm>
-          <a:prstGeom prst="rect">
-            <a:avLst/>
-          </a:prstGeom>
-          <a:noFill/>
-          <a:ln/>
-        </p:spPr>
-        <p:txBody>
-          <a:bodyPr wrap="square" lIns="0" tIns="0" rIns="0" bIns="0" rtlCol="0" anchor="ctr"/>
-          <a:lstStyle/>
-          <a:p>
-            <a:pPr indent="0" marL="0">
-              <a:buNone/>
-            </a:pPr>
-            <a:r>
-              <a:rPr lang="en-US" sz="1400" b="1" dirty="0">
+          <a:p>
+            <a:pPr marL="342900" indent="-342900">
+              <a:spcAft>
+                <a:spcPts val="400"/>
+              </a:spcAft>
+              <a:buSzPct val="100000"/>
+              <a:buChar char="•"/>
+            </a:pPr>
+            <a:r>
+              <a:rPr lang="en-US" sz="1100" dirty="0">
                 <a:solidFill>
                   <a:srgbClr val="1E293B"/>
                 </a:solidFill>
@@ -3670,100 +3661,106 @@
                 <a:ea typeface="Calibri" pitchFamily="34" charset="-122"/>
                 <a:cs typeface="Calibri" pitchFamily="34" charset="-120"/>
               </a:rPr>
-              <a:t>Context7</a:t>
-            </a:r>
-            <a:endParaRPr lang="en-US" sz="1400" dirty="0"/>
-          </a:p>
-        </p:txBody>
-      </p:sp>
-      <p:sp>
-        <p:nvSpPr>
-          <p:cNvPr id="19" name="Text 17"/>
-          <p:cNvSpPr/>
-          <p:nvPr/>
-        </p:nvSpPr>
-        <p:spPr>
-          <a:xfrm>
-            <a:off x="6217920" y="1828800"/>
-            <a:ext cx="2103120" cy="274320"/>
-          </a:xfrm>
-          <a:prstGeom prst="rect">
-            <a:avLst/>
-          </a:prstGeom>
-          <a:noFill/>
-          <a:ln/>
-        </p:spPr>
-        <p:txBody>
-          <a:bodyPr wrap="square" lIns="0" tIns="0" rIns="0" bIns="0" rtlCol="0" anchor="ctr"/>
-          <a:lstStyle/>
-          <a:p>
-            <a:pPr indent="0" marL="0">
-              <a:buNone/>
+              <a:t>  advanced security</a:t>
+            </a:r>
+            <a:endParaRPr lang="en-US" sz="1100" dirty="0"/>
+          </a:p>
+          <a:p>
+            <a:pPr marL="342900" indent="-342900">
+              <a:spcAft>
+                <a:spcPts val="400"/>
+              </a:spcAft>
+              <a:buSzPct val="100000"/>
+              <a:buChar char="•"/>
             </a:pPr>
             <a:r>
               <a:rPr lang="en-US" sz="1100" dirty="0">
                 <a:solidFill>
-                  <a:srgbClr val="475569"/>
-                </a:solidFill>
-                <a:latin typeface="Calibri" pitchFamily="34" charset="0"/>
-                <a:ea typeface="Calibri" pitchFamily="34" charset="-122"/>
-                <a:cs typeface="Calibri" pitchFamily="34" charset="-120"/>
-              </a:rPr>
-              <a:t>Live library documentation</a:t>
+                  <a:srgbClr val="1E293B"/>
+                </a:solidFill>
+                <a:latin typeface="Calibri" pitchFamily="34" charset="0"/>
+                <a:ea typeface="Calibri" pitchFamily="34" charset="-122"/>
+                <a:cs typeface="Calibri" pitchFamily="34" charset="-120"/>
+              </a:rPr>
+              <a:t>Higher context cost — use domains</a:t>
             </a:r>
             <a:endParaRPr lang="en-US" sz="1100" dirty="0"/>
           </a:p>
-        </p:txBody>
-      </p:sp>
-      <p:sp>
-        <p:nvSpPr>
-          <p:cNvPr id="20" name="Text 18"/>
-          <p:cNvSpPr/>
-          <p:nvPr/>
-        </p:nvSpPr>
-        <p:spPr>
-          <a:xfrm>
-            <a:off x="6217920" y="2148840"/>
-            <a:ext cx="2103120" cy="274320"/>
-          </a:xfrm>
-          <a:prstGeom prst="rect">
-            <a:avLst/>
-          </a:prstGeom>
-          <a:noFill/>
-          <a:ln/>
-        </p:spPr>
-        <p:txBody>
-          <a:bodyPr wrap="square" lIns="0" tIns="0" rIns="0" bIns="0" rtlCol="0" anchor="ctr"/>
-          <a:lstStyle/>
-          <a:p>
-            <a:pPr indent="0" marL="0">
-              <a:buNone/>
-            </a:pPr>
-            <a:r>
-              <a:rPr lang="en-US" sz="1000" i="1" dirty="0">
-                <a:solidFill>
-                  <a:srgbClr val="0EA5E9"/>
-                </a:solidFill>
-                <a:latin typeface="Calibri" pitchFamily="34" charset="0"/>
-                <a:ea typeface="Calibri" pitchFamily="34" charset="-122"/>
-                <a:cs typeface="Calibri" pitchFamily="34" charset="-120"/>
-              </a:rPr>
-              <a:t>Config file</a:t>
-            </a:r>
-            <a:endParaRPr lang="en-US" sz="1000" dirty="0"/>
-          </a:p>
-        </p:txBody>
-      </p:sp>
-      <p:sp>
-        <p:nvSpPr>
-          <p:cNvPr id="21" name="Shape 19"/>
-          <p:cNvSpPr/>
-          <p:nvPr/>
-        </p:nvSpPr>
-        <p:spPr>
-          <a:xfrm>
-            <a:off x="731520" y="2880360"/>
-            <a:ext cx="7680960" cy="1645920"/>
+          <a:p>
+            <a:pPr marL="342900" indent="-342900">
+              <a:spcAft>
+                <a:spcPts val="400"/>
+              </a:spcAft>
+              <a:buSzPct val="100000"/>
+              <a:buChar char="•"/>
+            </a:pPr>
+            <a:r>
+              <a:rPr lang="en-US" sz="1100" dirty="0">
+                <a:solidFill>
+                  <a:srgbClr val="1E293B"/>
+                </a:solidFill>
+                <a:latin typeface="Calibri" pitchFamily="34" charset="0"/>
+                <a:ea typeface="Calibri" pitchFamily="34" charset="-122"/>
+                <a:cs typeface="Calibri" pitchFamily="34" charset="-120"/>
+              </a:rPr>
+              <a:t>  to limit</a:t>
+            </a:r>
+            <a:endParaRPr lang="en-US" sz="1100" dirty="0"/>
+          </a:p>
+          <a:p>
+            <a:pPr marL="342900" indent="-342900">
+              <a:spcAft>
+                <a:spcPts val="400"/>
+              </a:spcAft>
+              <a:buSzPct val="100000"/>
+              <a:buChar char="•"/>
+            </a:pPr>
+            <a:r>
+              <a:rPr lang="en-US" sz="1100" dirty="0">
+                <a:solidFill>
+                  <a:srgbClr val="1E293B"/>
+                </a:solidFill>
+                <a:latin typeface="Calibri" pitchFamily="34" charset="0"/>
+                <a:ea typeface="Calibri" pitchFamily="34" charset="-122"/>
+                <a:cs typeface="Calibri" pitchFamily="34" charset="-120"/>
+              </a:rPr>
+              <a:t>Microsoft-maintained</a:t>
+            </a:r>
+            <a:endParaRPr lang="en-US" sz="1100" dirty="0"/>
+          </a:p>
+          <a:p>
+            <a:pPr marL="342900" indent="-342900">
+              <a:spcAft>
+                <a:spcPts val="400"/>
+              </a:spcAft>
+              <a:buSzPct val="100000"/>
+              <a:buChar char="•"/>
+            </a:pPr>
+            <a:r>
+              <a:rPr lang="en-US" sz="1100" dirty="0">
+                <a:solidFill>
+                  <a:srgbClr val="1E293B"/>
+                </a:solidFill>
+                <a:latin typeface="Calibri" pitchFamily="34" charset="0"/>
+                <a:ea typeface="Calibri" pitchFamily="34" charset="-122"/>
+                <a:cs typeface="Calibri" pitchFamily="34" charset="-120"/>
+              </a:rPr>
+              <a:t>  (@azure-devops/mcp)</a:t>
+            </a:r>
+            <a:endParaRPr lang="en-US" sz="1100" dirty="0"/>
+          </a:p>
+        </p:txBody>
+      </p:sp>
+      <p:sp>
+        <p:nvSpPr>
+          <p:cNvPr id="14" name="Shape 12"/>
+          <p:cNvSpPr/>
+          <p:nvPr/>
+        </p:nvSpPr>
+        <p:spPr>
+          <a:xfrm>
+            <a:off x="731520" y="3657600"/>
+            <a:ext cx="7680960" cy="457200"/>
           </a:xfrm>
           <a:prstGeom prst="rect">
             <a:avLst/>
@@ -3776,14 +3773,14 @@
       </p:sp>
       <p:sp>
         <p:nvSpPr>
-          <p:cNvPr id="22" name="Text 20"/>
-          <p:cNvSpPr/>
-          <p:nvPr/>
-        </p:nvSpPr>
-        <p:spPr>
-          <a:xfrm>
-            <a:off x="1005840" y="2971800"/>
-            <a:ext cx="2743200" cy="228600"/>
+          <p:cNvPr id="15" name="Text 13"/>
+          <p:cNvSpPr/>
+          <p:nvPr/>
+        </p:nvSpPr>
+        <p:spPr>
+          <a:xfrm>
+            <a:off x="914400" y="3657600"/>
+            <a:ext cx="7315200" cy="457200"/>
           </a:xfrm>
           <a:prstGeom prst="rect">
             <a:avLst/>
@@ -3799,7 +3796,66 @@
               <a:buNone/>
             </a:pPr>
             <a:r>
-              <a:rPr lang="en-US" sz="1000" b="1" spc="300" kern="0" dirty="0">
+              <a:rPr lang="en-US" sz="1200" b="1" dirty="0">
+                <a:solidFill>
+                  <a:srgbClr val="FFFFFF"/>
+                </a:solidFill>
+                <a:latin typeface="Calibri" pitchFamily="34" charset="0"/>
+                <a:ea typeface="Calibri" pitchFamily="34" charset="-122"/>
+                <a:cs typeface="Calibri" pitchFamily="34" charset="-120"/>
+              </a:rPr>
+              <a:t>CLI Skill = occasional ADO during coding  |  MCP = heavy, continuous ADO interaction</a:t>
+            </a:r>
+            <a:endParaRPr lang="en-US" sz="1200" dirty="0"/>
+          </a:p>
+        </p:txBody>
+      </p:sp>
+      <p:sp>
+        <p:nvSpPr>
+          <p:cNvPr id="16" name="Shape 14"/>
+          <p:cNvSpPr/>
+          <p:nvPr/>
+        </p:nvSpPr>
+        <p:spPr>
+          <a:xfrm>
+            <a:off x="731520" y="4297680"/>
+            <a:ext cx="7680960" cy="777240"/>
+          </a:xfrm>
+          <a:prstGeom prst="rect">
+            <a:avLst/>
+          </a:prstGeom>
+          <a:solidFill>
+            <a:srgbClr val="1E293B"/>
+          </a:solidFill>
+          <a:ln/>
+        </p:spPr>
+      </p:sp>
+      <p:sp>
+        <p:nvSpPr>
+          <p:cNvPr id="17" name="Text 15"/>
+          <p:cNvSpPr/>
+          <p:nvPr/>
+        </p:nvSpPr>
+        <p:spPr>
+          <a:xfrm>
+            <a:off x="1005840" y="4315968"/>
+            <a:ext cx="2743200" cy="182880"/>
+          </a:xfrm>
+          <a:prstGeom prst="rect">
+            <a:avLst/>
+          </a:prstGeom>
+          <a:noFill/>
+          <a:ln/>
+        </p:spPr>
+        <p:txBody>
+          <a:bodyPr wrap="square" lIns="0" tIns="0" rIns="0" bIns="0" rtlCol="0" anchor="ctr"/>
+          <a:lstStyle/>
+          <a:p>
+            <a:pPr indent="0" marL="0">
+              <a:buNone/>
+            </a:pPr>
+            <a:r>
+              <a:rPr lang="en-US" sz="900" b="1" spc="300" kern="0" dirty="0">
                 <a:solidFill>
                   <a:srgbClr val="38BDF8"/>
                 </a:solidFill>
@@ -3809,20 +3865,20 @@
               </a:rPr>
               <a:t>HANDS-ON</a:t>
             </a:r>
-            <a:endParaRPr lang="en-US" sz="1000" dirty="0"/>
-          </a:p>
-        </p:txBody>
-      </p:sp>
-      <p:sp>
-        <p:nvSpPr>
-          <p:cNvPr id="23" name="Text 21"/>
-          <p:cNvSpPr/>
-          <p:nvPr/>
-        </p:nvSpPr>
-        <p:spPr>
-          <a:xfrm>
-            <a:off x="1005840" y="3246120"/>
-            <a:ext cx="7132320" cy="1188720"/>
+            <a:endParaRPr lang="en-US" sz="900" dirty="0"/>
+          </a:p>
+        </p:txBody>
+      </p:sp>
+      <p:sp>
+        <p:nvSpPr>
+          <p:cNvPr id="18" name="Text 16"/>
+          <p:cNvSpPr/>
+          <p:nvPr/>
+        </p:nvSpPr>
+        <p:spPr>
+          <a:xfrm>
+            <a:off x="1005840" y="4526280"/>
+            <a:ext cx="7132320" cy="502920"/>
           </a:xfrm>
           <a:prstGeom prst="rect">
             <a:avLst/>
@@ -3835,13 +3891,10 @@
           <a:lstStyle/>
           <a:p>
             <a:pPr indent="0" marL="0">
-              <a:spcAft>
-                <a:spcPts val="400"/>
-              </a:spcAft>
-              <a:buNone/>
-            </a:pPr>
-            <a:r>
-              <a:rPr lang="en-US" sz="1100" dirty="0">
+              <a:buNone/>
+            </a:pPr>
+            <a:r>
+              <a:rPr lang="en-US" sz="1000" dirty="0">
                 <a:solidFill>
                   <a:srgbClr val="38BDF8"/>
                 </a:solidFill>
@@ -3849,19 +3902,16 @@
                 <a:ea typeface="Consolas" pitchFamily="34" charset="-122"/>
                 <a:cs typeface="Consolas" pitchFamily="34" charset="-120"/>
               </a:rPr>
-              <a:t>&gt; List the 5 most recent commits</a:t>
-            </a:r>
-            <a:endParaRPr lang="en-US" sz="1100" dirty="0"/>
-          </a:p>
-          <a:p>
-            <a:pPr indent="0" marL="0">
-              <a:spcAft>
-                <a:spcPts val="400"/>
-              </a:spcAft>
-              <a:buNone/>
-            </a:pPr>
-            <a:r>
-              <a:rPr lang="en-US" sz="1100" dirty="0">
+              <a:t>&gt; Show me my active work items in Azure DevOps</a:t>
+            </a:r>
+            <a:endParaRPr lang="en-US" sz="1000" dirty="0"/>
+          </a:p>
+          <a:p>
+            <a:pPr indent="0" marL="0">
+              <a:buNone/>
+            </a:pPr>
+            <a:r>
+              <a:rPr lang="en-US" sz="1000" dirty="0">
                 <a:solidFill>
                   <a:srgbClr val="38BDF8"/>
                 </a:solidFill>
@@ -3869,19 +3919,16 @@
                 <a:ea typeface="Consolas" pitchFamily="34" charset="-122"/>
                 <a:cs typeface="Consolas" pitchFamily="34" charset="-120"/>
               </a:rPr>
-              <a:t>&gt; Show me the open issues</a:t>
-            </a:r>
-            <a:endParaRPr lang="en-US" sz="1100" dirty="0"/>
-          </a:p>
-          <a:p>
-            <a:pPr indent="0" marL="0">
-              <a:spcAft>
-                <a:spcPts val="400"/>
-              </a:spcAft>
-              <a:buNone/>
-            </a:pPr>
-            <a:r>
-              <a:rPr lang="en-US" sz="1100" dirty="0">
+              <a:t>&gt; List active PRs in the Copilot-Wiki repo</a:t>
+            </a:r>
+            <a:endParaRPr lang="en-US" sz="1000" dirty="0"/>
+          </a:p>
+          <a:p>
+            <a:pPr indent="0" marL="0">
+              <a:buNone/>
+            </a:pPr>
+            <a:r>
+              <a:rPr lang="en-US" sz="1000" dirty="0">
                 <a:solidFill>
                   <a:srgbClr val="38BDF8"/>
                 </a:solidFill>
@@ -3889,112 +3936,9 @@
                 <a:ea typeface="Consolas" pitchFamily="34" charset="-122"/>
                 <a:cs typeface="Consolas" pitchFamily="34" charset="-120"/>
               </a:rPr>
-              <a:t>&gt; Based on issue #X, create a technical plan</a:t>
-            </a:r>
-            <a:endParaRPr lang="en-US" sz="1100" dirty="0"/>
-          </a:p>
-          <a:p>
-            <a:pPr indent="0" marL="0">
-              <a:spcAft>
-                <a:spcPts val="400"/>
-              </a:spcAft>
-              <a:buNone/>
-            </a:pPr>
-            <a:r>
-              <a:rPr lang="en-US" sz="1100" dirty="0">
-                <a:solidFill>
-                  <a:srgbClr val="38BDF8"/>
-                </a:solidFill>
-                <a:latin typeface="Consolas" pitchFamily="34" charset="0"/>
-                <a:ea typeface="Consolas" pitchFamily="34" charset="-122"/>
-                <a:cs typeface="Consolas" pitchFamily="34" charset="-120"/>
-              </a:rPr>
-              <a:t>&gt; /agent security-reviewer</a:t>
-            </a:r>
-            <a:endParaRPr lang="en-US" sz="1100" dirty="0"/>
-          </a:p>
-          <a:p>
-            <a:pPr indent="0" marL="0">
-              <a:spcAft>
-                <a:spcPts val="400"/>
-              </a:spcAft>
-              <a:buNone/>
-            </a:pPr>
-            <a:r>
-              <a:rPr lang="en-US" sz="1100" dirty="0">
-                <a:solidFill>
-                  <a:srgbClr val="38BDF8"/>
-                </a:solidFill>
-                <a:latin typeface="Consolas" pitchFamily="34" charset="0"/>
-                <a:ea typeface="Consolas" pitchFamily="34" charset="-122"/>
-                <a:cs typeface="Consolas" pitchFamily="34" charset="-120"/>
-              </a:rPr>
-              <a:t>&gt; Review the changes in the most recent PR</a:t>
-            </a:r>
-            <a:endParaRPr lang="en-US" sz="1100" dirty="0"/>
-          </a:p>
-        </p:txBody>
-      </p:sp>
-      <p:pic>
-        <p:nvPicPr>
-          <p:cNvPr id="24" name="Image 0" descr="preencoded.png">    </p:cNvPr>
-          <p:cNvPicPr>
-            <a:picLocks noChangeAspect="1"/>
-          </p:cNvPicPr>
-          <p:nvPr/>
-        </p:nvPicPr>
-        <p:blipFill>
-          <a:blip r:embed="rId1"/>
-          <a:stretch>
-            <a:fillRect/>
-          </a:stretch>
-        </p:blipFill>
-        <p:spPr>
-          <a:xfrm>
-            <a:off x="731520" y="4709160"/>
-            <a:ext cx="274320" cy="274320"/>
-          </a:xfrm>
-          <a:prstGeom prst="rect">
-            <a:avLst/>
-          </a:prstGeom>
-        </p:spPr>
-      </p:pic>
-      <p:sp>
-        <p:nvSpPr>
-          <p:cNvPr id="25" name="Text 22"/>
-          <p:cNvSpPr/>
-          <p:nvPr/>
-        </p:nvSpPr>
-        <p:spPr>
-          <a:xfrm>
-            <a:off x="1097280" y="4709160"/>
-            <a:ext cx="6858000" cy="320040"/>
-          </a:xfrm>
-          <a:prstGeom prst="rect">
-            <a:avLst/>
-          </a:prstGeom>
-          <a:noFill/>
-          <a:ln/>
-        </p:spPr>
-        <p:txBody>
-          <a:bodyPr wrap="square" lIns="0" tIns="0" rIns="0" bIns="0" rtlCol="0" anchor="ctr"/>
-          <a:lstStyle/>
-          <a:p>
-            <a:pPr indent="0" marL="0">
-              <a:buNone/>
-            </a:pPr>
-            <a:r>
-              <a:rPr lang="en-US" sz="1300" b="1" dirty="0">
-                <a:solidFill>
-                  <a:srgbClr val="0EA5E9"/>
-                </a:solidFill>
-                <a:latin typeface="Calibri" pitchFamily="34" charset="0"/>
-                <a:ea typeface="Calibri" pitchFamily="34" charset="-122"/>
-                <a:cs typeface="Calibri" pitchFamily="34" charset="-120"/>
-              </a:rPr>
-              <a:t>Live data, no context-switching, no copy-paste — all from the terminal.</a:t>
-            </a:r>
-            <a:endParaRPr lang="en-US" sz="1300" dirty="0"/>
+              <a:t>&gt; Based on work item #576684, create a technical plan</a:t>
+            </a:r>
+            <a:endParaRPr lang="en-US" sz="1000" dirty="0"/>
           </a:p>
         </p:txBody>
       </p:sp>
@@ -5345,7 +5289,7 @@
                 <a:ea typeface="Calibri" pitchFamily="34" charset="-122"/>
                 <a:cs typeface="Calibri" pitchFamily="34" charset="-120"/>
               </a:rPr>
-              <a:t>MCP context → /plan → Review the plan</a:t>
+              <a:t>ADO context → /plan → Review the plan</a:t>
             </a:r>
             <a:endParaRPr lang="en-US" sz="1100" dirty="0"/>
           </a:p>
@@ -9517,7 +9461,27 @@
                 <a:ea typeface="Calibri" pitchFamily="34" charset="-122"/>
                 <a:cs typeface="Calibri" pitchFamily="34" charset="-120"/>
               </a:rPr>
-              <a:t>MCP</a:t>
+              <a:t>MCP &amp;</a:t>
+            </a:r>
+            <a:endParaRPr lang="en-US" sz="1200" dirty="0"/>
+          </a:p>
+          <a:p>
+            <a:pPr algn="ctr" indent="0" marL="0">
+              <a:lnSpc>
+                <a:spcPct val="115000"/>
+              </a:lnSpc>
+              <a:buNone/>
+            </a:pPr>
+            <a:r>
+              <a:rPr lang="en-US" sz="1200" b="1" dirty="0">
+                <a:solidFill>
+                  <a:srgbClr val="FFFFFF"/>
+                </a:solidFill>
+                <a:latin typeface="Calibri" pitchFamily="34" charset="0"/>
+                <a:ea typeface="Calibri" pitchFamily="34" charset="-122"/>
+                <a:cs typeface="Calibri" pitchFamily="34" charset="-120"/>
+              </a:rPr>
+              <a:t>Integrations</a:t>
             </a:r>
             <a:endParaRPr lang="en-US" sz="1200" dirty="0"/>
           </a:p>
@@ -11133,7 +11097,7 @@
                           <a:ea typeface="Calibri" pitchFamily="34" charset="-122"/>
                           <a:cs typeface="Calibri" pitchFamily="34" charset="-120"/>
                         </a:rPr>
-                        <a:t>MCP</a:t>
+                        <a:t>MCP &amp; External Integrations (ADO)</a:t>
                       </a:r>
                       <a:endParaRPr lang="en-US" sz="1100" dirty="0">
                         <a:latin typeface="Calibri" charset="0"/>
@@ -12165,7 +12129,7 @@
                 <a:ea typeface="Calibri" pitchFamily="34" charset="-122"/>
                 <a:cs typeface="Calibri" pitchFamily="34" charset="-120"/>
               </a:rPr>
-              <a:t>Live demo: user story → merged PR in one terminal session</a:t>
+              <a:t>Live demo: work item → merged PR in one terminal session</a:t>
             </a:r>
             <a:endParaRPr lang="en-US" sz="1400" dirty="0"/>
           </a:p>
@@ -12263,7 +12227,7 @@
                 <a:ea typeface="Calibri" pitchFamily="34" charset="-122"/>
                 <a:cs typeface="Calibri" pitchFamily="34" charset="-120"/>
               </a:rPr>
-              <a:t>Pull GitHub issue via MCP</a:t>
+              <a:t>Pull work item from ADO</a:t>
             </a:r>
             <a:endParaRPr lang="en-US" sz="1300" dirty="0"/>
           </a:p>
@@ -12322,7 +12286,7 @@
                 <a:ea typeface="Consolas" pitchFamily="34" charset="-122"/>
                 <a:cs typeface="Consolas" pitchFamily="34" charset="-120"/>
               </a:rPr>
-              <a:t>"List open issues in this repo"</a:t>
+              <a:t>"Show me work item #576684"</a:t>
             </a:r>
             <a:endParaRPr lang="en-US" sz="1100" dirty="0"/>
           </a:p>
@@ -14029,7 +13993,7 @@
                 <a:ea typeface="Calibri" pitchFamily="34" charset="-122"/>
                 <a:cs typeface="Calibri" pitchFamily="34" charset="-120"/>
               </a:rPr>
-              <a:t>"You write your coding standards once in AGENTS.md. From that moment, every Copilot session in your repo follows them — for new hires, contractors, and senior engineers alike."</a:t>
+              <a:t>"You write your coding standards once in AGENTS.md. From that moment, every session in your repo follows them — for new hires, contractors, and senior engineers alike."</a:t>
             </a:r>
             <a:endParaRPr lang="en-US" sz="1300" dirty="0"/>
           </a:p>

</xml_diff>

<commit_message>
feat: show project vs user scope for agents and skills
Annotate Pillar 3 (Agents) and Pillar 4 (Skills — What & How) slides
with both .github/ (project) and ~/.copilot/ (user) paths so the
audience sees when to share via repo vs keep local across all repos.

Co-Authored-By: Claude Opus 4.6 (1M context) <noreply@anthropic.com>
</commit_message>
<xml_diff>
--- a/WORKSHOP-PRESENTATION.pptx
+++ b/WORKSHOP-PRESENTATION.pptx
@@ -2855,7 +2855,7 @@
       </p:sp>
       <p:pic>
         <p:nvPicPr>
-          <p:cNvPr id="3" name="Image 0" descr="preencoded.png">    </p:cNvPr>
+          <p:cNvPr id="3" name="Image 0" descr="preencoded.png"/>
           <p:cNvPicPr>
             <a:picLocks noChangeAspect="1"/>
           </p:cNvPicPr>
@@ -3470,7 +3470,7 @@
       </p:sp>
       <p:pic>
         <p:nvPicPr>
-          <p:cNvPr id="13" name="Image 0" descr="preencoded.png">    </p:cNvPr>
+          <p:cNvPr id="13" name="Image 0" descr="preencoded.png"/>
           <p:cNvPicPr>
             <a:picLocks noChangeAspect="1"/>
           </p:cNvPicPr>
@@ -4334,7 +4334,7 @@
       </p:sp>
       <p:pic>
         <p:nvPicPr>
-          <p:cNvPr id="37" name="Image 1" descr="preencoded.png">    </p:cNvPr>
+          <p:cNvPr id="37" name="Image 1" descr="preencoded.png"/>
           <p:cNvPicPr>
             <a:picLocks noChangeAspect="1"/>
           </p:cNvPicPr>
@@ -5022,7 +5022,7 @@
       </p:sp>
       <p:pic>
         <p:nvPicPr>
-          <p:cNvPr id="14" name="Image 0" descr="preencoded.png">    </p:cNvPr>
+          <p:cNvPr id="14" name="Image 0" descr="preencoded.png"/>
           <p:cNvPicPr>
             <a:picLocks noChangeAspect="1"/>
           </p:cNvPicPr>
@@ -5405,28 +5405,16 @@
               </a:rPr>
               <a:t>.github/skills/pr-review/SKILL.md</a:t>
             </a:r>
-            <a:endParaRPr lang="en-US" sz="1000" dirty="0"/>
-          </a:p>
-          <a:p>
-            <a:pPr indent="0" marL="0">
-              <a:buNone/>
-            </a:pPr>
-            <a:endParaRPr lang="en-US" sz="1000" dirty="0"/>
-          </a:p>
-          <a:p>
-            <a:pPr indent="0" marL="0">
-              <a:buNone/>
-            </a:pPr>
-            <a:r>
-              <a:rPr lang="en-US" sz="1000" dirty="0">
-                <a:solidFill>
-                  <a:srgbClr val="38BDF8"/>
+            <a:r>
+              <a:rPr lang="en-US" sz="900" i="1" dirty="0">
+                <a:solidFill>
+                  <a:srgbClr val="10B981"/>
                 </a:solidFill>
                 <a:latin typeface="Consolas" pitchFamily="34" charset="0"/>
                 <a:ea typeface="Consolas" pitchFamily="34" charset="-122"/>
                 <a:cs typeface="Consolas" pitchFamily="34" charset="-120"/>
               </a:rPr>
-              <a:t>name: pr-review</a:t>
+              <a:t xml:space="preserve">   ← project</a:t>
             </a:r>
             <a:endParaRPr lang="en-US" sz="1000" dirty="0"/>
           </a:p>
@@ -5437,30 +5425,75 @@
             <a:r>
               <a:rPr lang="en-US" sz="1000" dirty="0">
                 <a:solidFill>
-                  <a:srgbClr val="38BDF8"/>
+                  <a:srgbClr val="94A3B8"/>
                 </a:solidFill>
                 <a:latin typeface="Consolas" pitchFamily="34" charset="0"/>
                 <a:ea typeface="Consolas" pitchFamily="34" charset="-122"/>
                 <a:cs typeface="Consolas" pitchFamily="34" charset="-120"/>
               </a:rPr>
-              <a:t>description: "Review a PR for quality"</a:t>
-            </a:r>
-            <a:endParaRPr lang="en-US" sz="1000" dirty="0"/>
-          </a:p>
-          <a:p>
-            <a:pPr indent="0" marL="0">
-              <a:buNone/>
-            </a:pPr>
+              <a:t>~/.copilot/skills/pr-review/SKILL.md</a:t>
+            </a:r>
             <a:r>
               <a:rPr lang="en-US" sz="900" i="1" dirty="0">
                 <a:solidFill>
-                  <a:srgbClr val="94A3B8"/>
+                  <a:srgbClr val="F59E0B"/>
                 </a:solidFill>
                 <a:latin typeface="Consolas" pitchFamily="34" charset="0"/>
                 <a:ea typeface="Consolas" pitchFamily="34" charset="-122"/>
                 <a:cs typeface="Consolas" pitchFamily="34" charset="-120"/>
               </a:rPr>
-              <a:t>  ← matched against user's prompt</a:t>
+              <a:t xml:space="preserve">   ← user</a:t>
+            </a:r>
+            <a:endParaRPr lang="en-US" sz="1000" dirty="0"/>
+          </a:p>
+          <a:p>
+            <a:pPr indent="0" marL="0">
+              <a:buNone/>
+            </a:pPr>
+            <a:r>
+              <a:rPr lang="en-US" sz="1000" dirty="0">
+                <a:solidFill>
+                  <a:srgbClr val="38BDF8"/>
+                </a:solidFill>
+                <a:latin typeface="Consolas" pitchFamily="34" charset="0"/>
+                <a:ea typeface="Consolas" pitchFamily="34" charset="-122"/>
+                <a:cs typeface="Consolas" pitchFamily="34" charset="-120"/>
+              </a:rPr>
+              <a:t>name: pr-review</a:t>
+            </a:r>
+            <a:endParaRPr lang="en-US" sz="1000" dirty="0"/>
+          </a:p>
+          <a:p>
+            <a:pPr indent="0" marL="0">
+              <a:buNone/>
+            </a:pPr>
+            <a:r>
+              <a:rPr lang="en-US" sz="1000" dirty="0">
+                <a:solidFill>
+                  <a:srgbClr val="38BDF8"/>
+                </a:solidFill>
+                <a:latin typeface="Consolas" pitchFamily="34" charset="0"/>
+                <a:ea typeface="Consolas" pitchFamily="34" charset="-122"/>
+                <a:cs typeface="Consolas" pitchFamily="34" charset="-120"/>
+              </a:rPr>
+              <a:t>description: "Review a PR for quality"</a:t>
+            </a:r>
+            <a:endParaRPr lang="en-US" sz="1000" dirty="0"/>
+          </a:p>
+          <a:p>
+            <a:pPr indent="0" marL="0">
+              <a:buNone/>
+            </a:pPr>
+            <a:r>
+              <a:rPr lang="en-US" sz="900" i="1" dirty="0">
+                <a:solidFill>
+                  <a:srgbClr val="94A3B8"/>
+                </a:solidFill>
+                <a:latin typeface="Consolas" pitchFamily="34" charset="0"/>
+                <a:ea typeface="Consolas" pitchFamily="34" charset="-122"/>
+                <a:cs typeface="Consolas" pitchFamily="34" charset="-120"/>
+              </a:rPr>
+              <a:t xml:space="preserve">  ← matched against user's prompt</a:t>
             </a:r>
             <a:endParaRPr lang="en-US" sz="1000" dirty="0"/>
           </a:p>
@@ -6161,7 +6194,7 @@
       </p:sp>
       <p:pic>
         <p:nvPicPr>
-          <p:cNvPr id="11" name="Image 0" descr="preencoded.png">    </p:cNvPr>
+          <p:cNvPr id="11" name="Image 0" descr="preencoded.png"/>
           <p:cNvPicPr>
             <a:picLocks noChangeAspect="1"/>
           </p:cNvPicPr>
@@ -6352,7 +6385,7 @@
       </p:sp>
       <p:pic>
         <p:nvPicPr>
-          <p:cNvPr id="17" name="Image 1" descr="preencoded.png">    </p:cNvPr>
+          <p:cNvPr id="17" name="Image 1" descr="preencoded.png"/>
           <p:cNvPicPr>
             <a:picLocks noChangeAspect="1"/>
           </p:cNvPicPr>
@@ -6543,7 +6576,7 @@
       </p:sp>
       <p:pic>
         <p:nvPicPr>
-          <p:cNvPr id="23" name="Image 2" descr="preencoded.png">    </p:cNvPr>
+          <p:cNvPr id="23" name="Image 2" descr="preencoded.png"/>
           <p:cNvPicPr>
             <a:picLocks noChangeAspect="1"/>
           </p:cNvPicPr>
@@ -6734,7 +6767,7 @@
       </p:sp>
       <p:pic>
         <p:nvPicPr>
-          <p:cNvPr id="29" name="Image 3" descr="preencoded.png">    </p:cNvPr>
+          <p:cNvPr id="29" name="Image 3" descr="preencoded.png"/>
           <p:cNvPicPr>
             <a:picLocks noChangeAspect="1"/>
           </p:cNvPicPr>
@@ -7268,7 +7301,7 @@
       </p:sp>
       <p:pic>
         <p:nvPicPr>
-          <p:cNvPr id="45" name="Image 4" descr="preencoded.png">    </p:cNvPr>
+          <p:cNvPr id="45" name="Image 4" descr="preencoded.png"/>
           <p:cNvPicPr>
             <a:picLocks noChangeAspect="1"/>
           </p:cNvPicPr>
@@ -7559,7 +7592,7 @@
       </p:sp>
       <p:pic>
         <p:nvPicPr>
-          <p:cNvPr id="7" name="Image 0" descr="preencoded.png">    </p:cNvPr>
+          <p:cNvPr id="7" name="Image 0" descr="preencoded.png"/>
           <p:cNvPicPr>
             <a:picLocks noChangeAspect="1"/>
           </p:cNvPicPr>
@@ -7831,7 +7864,7 @@
       </p:sp>
       <p:pic>
         <p:nvPicPr>
-          <p:cNvPr id="15" name="Image 1" descr="preencoded.png">    </p:cNvPr>
+          <p:cNvPr id="15" name="Image 1" descr="preencoded.png"/>
           <p:cNvPicPr>
             <a:picLocks noChangeAspect="1"/>
           </p:cNvPicPr>
@@ -8022,7 +8055,7 @@
       </p:sp>
       <p:pic>
         <p:nvPicPr>
-          <p:cNvPr id="21" name="Image 2" descr="preencoded.png">    </p:cNvPr>
+          <p:cNvPr id="21" name="Image 2" descr="preencoded.png"/>
           <p:cNvPicPr>
             <a:picLocks noChangeAspect="1"/>
           </p:cNvPicPr>
@@ -8213,7 +8246,7 @@
       </p:sp>
       <p:pic>
         <p:nvPicPr>
-          <p:cNvPr id="27" name="Image 3" descr="preencoded.png">    </p:cNvPr>
+          <p:cNvPr id="27" name="Image 3" descr="preencoded.png"/>
           <p:cNvPicPr>
             <a:picLocks noChangeAspect="1"/>
           </p:cNvPicPr>
@@ -8424,7 +8457,7 @@
       </p:sp>
       <p:pic>
         <p:nvPicPr>
-          <p:cNvPr id="34" name="Image 4" descr="preencoded.png">    </p:cNvPr>
+          <p:cNvPr id="34" name="Image 4" descr="preencoded.png"/>
           <p:cNvPicPr>
             <a:picLocks noChangeAspect="1"/>
           </p:cNvPicPr>
@@ -8529,7 +8562,7 @@
       </p:sp>
       <p:pic>
         <p:nvPicPr>
-          <p:cNvPr id="37" name="Image 5" descr="preencoded.png">    </p:cNvPr>
+          <p:cNvPr id="37" name="Image 5" descr="preencoded.png"/>
           <p:cNvPicPr>
             <a:picLocks noChangeAspect="1"/>
           </p:cNvPicPr>
@@ -8945,7 +8978,7 @@
                 <a:ea typeface="Calibri" pitchFamily="34" charset="-122"/>
                 <a:cs typeface="Calibri" pitchFamily="34" charset="-120"/>
               </a:rPr>
-              <a:t>  releases, artifacts, security/admin</a:t>
+              <a:t xml:space="preserve">  releases, artifacts, security/admin</a:t>
             </a:r>
             <a:endParaRPr lang="en-US" sz="1100" dirty="0"/>
           </a:p>
@@ -9137,7 +9170,7 @@
                 <a:ea typeface="Calibri" pitchFamily="34" charset="-122"/>
                 <a:cs typeface="Calibri" pitchFamily="34" charset="-120"/>
               </a:rPr>
-              <a:t>  advanced security alerts</a:t>
+              <a:t xml:space="preserve">  advanced security alerts</a:t>
             </a:r>
             <a:endParaRPr lang="en-US" sz="1100" dirty="0"/>
           </a:p>
@@ -9246,7 +9279,7 @@
       </p:sp>
       <p:pic>
         <p:nvPicPr>
-          <p:cNvPr id="16" name="Image 0" descr="preencoded.png">    </p:cNvPr>
+          <p:cNvPr id="16" name="Image 0" descr="preencoded.png"/>
           <p:cNvPicPr>
             <a:picLocks noChangeAspect="1"/>
           </p:cNvPicPr>
@@ -9743,7 +9776,7 @@
       </p:sp>
       <p:pic>
         <p:nvPicPr>
-          <p:cNvPr id="14" name="Image 0" descr="preencoded.png">    </p:cNvPr>
+          <p:cNvPr id="14" name="Image 0" descr="preencoded.png"/>
           <p:cNvPicPr>
             <a:picLocks noChangeAspect="1"/>
           </p:cNvPicPr>
@@ -9934,7 +9967,7 @@
       </p:sp>
       <p:pic>
         <p:nvPicPr>
-          <p:cNvPr id="20" name="Image 1" descr="preencoded.png">    </p:cNvPr>
+          <p:cNvPr id="20" name="Image 1" descr="preencoded.png"/>
           <p:cNvPicPr>
             <a:picLocks noChangeAspect="1"/>
           </p:cNvPicPr>
@@ -10125,7 +10158,7 @@
       </p:sp>
       <p:pic>
         <p:nvPicPr>
-          <p:cNvPr id="26" name="Image 2" descr="preencoded.png">    </p:cNvPr>
+          <p:cNvPr id="26" name="Image 2" descr="preencoded.png"/>
           <p:cNvPicPr>
             <a:picLocks noChangeAspect="1"/>
           </p:cNvPicPr>
@@ -10316,7 +10349,7 @@
       </p:sp>
       <p:pic>
         <p:nvPicPr>
-          <p:cNvPr id="32" name="Image 3" descr="preencoded.png">    </p:cNvPr>
+          <p:cNvPr id="32" name="Image 3" descr="preencoded.png"/>
           <p:cNvPicPr>
             <a:picLocks noChangeAspect="1"/>
           </p:cNvPicPr>
@@ -11523,7 +11556,7 @@
       </p:sp>
       <p:pic>
         <p:nvPicPr>
-          <p:cNvPr id="10" name="Image 0" descr="preencoded.png">    </p:cNvPr>
+          <p:cNvPr id="10" name="Image 0" descr="preencoded.png"/>
           <p:cNvPicPr>
             <a:picLocks noChangeAspect="1"/>
           </p:cNvPicPr>
@@ -13759,7 +13792,7 @@
       </p:sp>
       <p:pic>
         <p:nvPicPr>
-          <p:cNvPr id="8" name="Image 0" descr="preencoded.png">    </p:cNvPr>
+          <p:cNvPr id="8" name="Image 0" descr="preencoded.png"/>
           <p:cNvPicPr>
             <a:picLocks noChangeAspect="1"/>
           </p:cNvPicPr>
@@ -13991,7 +14024,7 @@
       </p:sp>
       <p:pic>
         <p:nvPicPr>
-          <p:cNvPr id="14" name="Image 1" descr="preencoded.png">    </p:cNvPr>
+          <p:cNvPr id="14" name="Image 1" descr="preencoded.png"/>
           <p:cNvPicPr>
             <a:picLocks noChangeAspect="1"/>
           </p:cNvPicPr>
@@ -15280,7 +15313,7 @@
       </p:sp>
       <p:pic>
         <p:nvPicPr>
-          <p:cNvPr id="15" name="Image 0" descr="preencoded.png">    </p:cNvPr>
+          <p:cNvPr id="15" name="Image 0" descr="preencoded.png"/>
           <p:cNvPicPr>
             <a:picLocks noChangeAspect="1"/>
           </p:cNvPicPr>
@@ -15382,7 +15415,7 @@
       </p:sp>
       <p:pic>
         <p:nvPicPr>
-          <p:cNvPr id="18" name="Image 1" descr="preencoded.png">    </p:cNvPr>
+          <p:cNvPr id="18" name="Image 1" descr="preencoded.png"/>
           <p:cNvPicPr>
             <a:picLocks noChangeAspect="1"/>
           </p:cNvPicPr>
@@ -16577,7 +16610,7 @@
       </p:sp>
       <p:pic>
         <p:nvPicPr>
-          <p:cNvPr id="3" name="Image 0" descr="preencoded.png">    </p:cNvPr>
+          <p:cNvPr id="3" name="Image 0" descr="preencoded.png"/>
           <p:cNvPicPr>
             <a:picLocks noChangeAspect="1"/>
           </p:cNvPicPr>
@@ -16902,7 +16935,7 @@
       </p:sp>
       <p:pic>
         <p:nvPicPr>
-          <p:cNvPr id="6" name="Image 0" descr="preencoded.png">    </p:cNvPr>
+          <p:cNvPr id="6" name="Image 0" descr="preencoded.png"/>
           <p:cNvPicPr>
             <a:picLocks noChangeAspect="1"/>
           </p:cNvPicPr>
@@ -17012,7 +17045,7 @@
       </p:sp>
       <p:pic>
         <p:nvPicPr>
-          <p:cNvPr id="10" name="Image 1" descr="preencoded.png">    </p:cNvPr>
+          <p:cNvPr id="10" name="Image 1" descr="preencoded.png"/>
           <p:cNvPicPr>
             <a:picLocks noChangeAspect="1"/>
           </p:cNvPicPr>
@@ -17122,7 +17155,7 @@
       </p:sp>
       <p:pic>
         <p:nvPicPr>
-          <p:cNvPr id="14" name="Image 2" descr="preencoded.png">    </p:cNvPr>
+          <p:cNvPr id="14" name="Image 2" descr="preencoded.png"/>
           <p:cNvPicPr>
             <a:picLocks noChangeAspect="1"/>
           </p:cNvPicPr>
@@ -17232,7 +17265,7 @@
       </p:sp>
       <p:pic>
         <p:nvPicPr>
-          <p:cNvPr id="18" name="Image 3" descr="preencoded.png">    </p:cNvPr>
+          <p:cNvPr id="18" name="Image 3" descr="preencoded.png"/>
           <p:cNvPicPr>
             <a:picLocks noChangeAspect="1"/>
           </p:cNvPicPr>
@@ -17342,7 +17375,7 @@
       </p:sp>
       <p:pic>
         <p:nvPicPr>
-          <p:cNvPr id="22" name="Image 4" descr="preencoded.png">    </p:cNvPr>
+          <p:cNvPr id="22" name="Image 4" descr="preencoded.png"/>
           <p:cNvPicPr>
             <a:picLocks noChangeAspect="1"/>
           </p:cNvPicPr>
@@ -21295,7 +21328,7 @@
       </p:sp>
       <p:pic>
         <p:nvPicPr>
-          <p:cNvPr id="13" name="Image 0" descr="preencoded.png">    </p:cNvPr>
+          <p:cNvPr id="13" name="Image 0" descr="preencoded.png"/>
           <p:cNvPicPr>
             <a:picLocks noChangeAspect="1"/>
           </p:cNvPicPr>
@@ -21910,7 +21943,7 @@
       </p:sp>
       <p:pic>
         <p:nvPicPr>
-          <p:cNvPr id="13" name="Image 0" descr="preencoded.png">    </p:cNvPr>
+          <p:cNvPr id="13" name="Image 0" descr="preencoded.png"/>
           <p:cNvPicPr>
             <a:picLocks noChangeAspect="1"/>
           </p:cNvPicPr>
@@ -22652,7 +22685,7 @@
       </p:sp>
       <p:pic>
         <p:nvPicPr>
-          <p:cNvPr id="15" name="Image 0" descr="preencoded.png">    </p:cNvPr>
+          <p:cNvPr id="15" name="Image 0" descr="preencoded.png"/>
           <p:cNvPicPr>
             <a:picLocks noChangeAspect="1"/>
           </p:cNvPicPr>
@@ -23241,7 +23274,7 @@
                 <a:ea typeface="Calibri" pitchFamily="34" charset="-122"/>
                 <a:cs typeface="Calibri" pitchFamily="34" charset="-120"/>
               </a:rPr>
-              <a:t>    dependency injection patterns</a:t>
+              <a:t xml:space="preserve">    dependency injection patterns</a:t>
             </a:r>
             <a:endParaRPr lang="en-US" sz="1200" dirty="0"/>
           </a:p>
@@ -23400,28 +23433,16 @@
               </a:rPr>
               <a:t>.github/agents/csharp-reviewer.agent.md</a:t>
             </a:r>
-            <a:endParaRPr lang="en-US" sz="1000" dirty="0"/>
-          </a:p>
-          <a:p>
-            <a:pPr indent="0" marL="0">
-              <a:buNone/>
-            </a:pPr>
-            <a:endParaRPr lang="en-US" sz="1000" dirty="0"/>
-          </a:p>
-          <a:p>
-            <a:pPr indent="0" marL="0">
-              <a:buNone/>
-            </a:pPr>
-            <a:r>
-              <a:rPr lang="en-US" sz="1000" dirty="0">
-                <a:solidFill>
-                  <a:srgbClr val="38BDF8"/>
+            <a:r>
+              <a:rPr lang="en-US" sz="1000" i="1" dirty="0">
+                <a:solidFill>
+                  <a:srgbClr val="10B981"/>
                 </a:solidFill>
                 <a:latin typeface="Consolas" pitchFamily="34" charset="0"/>
                 <a:ea typeface="Consolas" pitchFamily="34" charset="-122"/>
                 <a:cs typeface="Consolas" pitchFamily="34" charset="-120"/>
               </a:rPr>
-              <a:t>description: "Reviews C# for team conventions"</a:t>
+              <a:t xml:space="preserve">   ← project scope · committed · team-shared</a:t>
             </a:r>
             <a:endParaRPr lang="en-US" sz="1000" dirty="0"/>
           </a:p>
@@ -23432,30 +23453,64 @@
             <a:r>
               <a:rPr lang="en-US" sz="1000" dirty="0">
                 <a:solidFill>
-                  <a:srgbClr val="38BDF8"/>
+                  <a:srgbClr val="94A3B8"/>
                 </a:solidFill>
                 <a:latin typeface="Consolas" pitchFamily="34" charset="0"/>
                 <a:ea typeface="Consolas" pitchFamily="34" charset="-122"/>
                 <a:cs typeface="Consolas" pitchFamily="34" charset="-120"/>
               </a:rPr>
-              <a:t>→ Enforces nullable refs, async patterns, DI</a:t>
-            </a:r>
-            <a:endParaRPr lang="en-US" sz="1000" dirty="0"/>
-          </a:p>
-          <a:p>
-            <a:pPr indent="0" marL="0">
-              <a:buNone/>
-            </a:pPr>
-            <a:r>
-              <a:rPr lang="en-US" sz="1000" dirty="0">
-                <a:solidFill>
-                  <a:srgbClr val="38BDF8"/>
+              <a:t>~/.copilot/agents/csharp-reviewer.agent.md</a:t>
+            </a:r>
+            <a:r>
+              <a:rPr lang="en-US" sz="1000" i="1" dirty="0">
+                <a:solidFill>
+                  <a:srgbClr val="F59E0B"/>
                 </a:solidFill>
                 <a:latin typeface="Consolas" pitchFamily="34" charset="0"/>
                 <a:ea typeface="Consolas" pitchFamily="34" charset="-122"/>
                 <a:cs typeface="Consolas" pitchFamily="34" charset="-120"/>
               </a:rPr>
-              <a:t>→ Flags: exceptions as control flow, sync-over-async</a:t>
+              <a:t xml:space="preserve">      ← user scope · personal · all your repos</a:t>
+            </a:r>
+            <a:endParaRPr lang="en-US" sz="1000" dirty="0"/>
+          </a:p>
+          <a:p>
+            <a:pPr indent="0" marL="0">
+              <a:buNone/>
+            </a:pPr>
+            <a:endParaRPr lang="en-US" sz="1000" dirty="0"/>
+          </a:p>
+          <a:p>
+            <a:pPr indent="0" marL="0">
+              <a:buNone/>
+            </a:pPr>
+            <a:r>
+              <a:rPr lang="en-US" sz="1000" dirty="0">
+                <a:solidFill>
+                  <a:srgbClr val="38BDF8"/>
+                </a:solidFill>
+                <a:latin typeface="Consolas" pitchFamily="34" charset="0"/>
+                <a:ea typeface="Consolas" pitchFamily="34" charset="-122"/>
+                <a:cs typeface="Consolas" pitchFamily="34" charset="-120"/>
+              </a:rPr>
+              <a:t>description: "Reviews C# for team conventions"</a:t>
+            </a:r>
+            <a:endParaRPr lang="en-US" sz="1000" dirty="0"/>
+          </a:p>
+          <a:p>
+            <a:pPr indent="0" marL="0">
+              <a:buNone/>
+            </a:pPr>
+            <a:r>
+              <a:rPr lang="en-US" sz="1000" dirty="0">
+                <a:solidFill>
+                  <a:srgbClr val="38BDF8"/>
+                </a:solidFill>
+                <a:latin typeface="Consolas" pitchFamily="34" charset="0"/>
+                <a:ea typeface="Consolas" pitchFamily="34" charset="-122"/>
+                <a:cs typeface="Consolas" pitchFamily="34" charset="-120"/>
+              </a:rPr>
+              <a:t>→ Enforces nullable refs, async patterns, DI</a:t>
             </a:r>
             <a:endParaRPr lang="en-US" sz="1000" dirty="0"/>
           </a:p>

</xml_diff>

<commit_message>
feat: workshop v4 — guided tour of the code-review plugin
Restructures the deck around the code-review plugin as a running
reference. Opening demo installs and runs the plugin live. Pillars 2-5
cite its real files (SKILL.md + checks/, the code-reviewer agent,
.mcp.json, plugin.json). A new composition slide shows plugin.json as
the mental-model payoff. Removes Pillar 6 (CI automation) as a
standalone segment and folds it into the playbook. Adds
samples/capstone-plugin-template/ for attendees to fork during the
35-min capstone.

Implements docs/superpowers/specs/2026-04-15-workshop-v4-design.md per
docs/superpowers/plans/2026-04-15-workshop-v4-implementation.md.

Slide count: 23 → 22 (Pillar 6 + Distribution slides removed; new
Composition slide added).

Co-Authored-By: Claude Opus 4.6 (1M context) <noreply@anthropic.com>
</commit_message>
<xml_diff>
--- a/WORKSHOP-PRESENTATION.pptx
+++ b/WORKSHOP-PRESENTATION.pptx
@@ -20,12 +20,11 @@
     <p:sldId id="268" r:id="rId14"/>
     <p:sldId id="269" r:id="rId15"/>
     <p:sldId id="270" r:id="rId16"/>
-    <p:sldId id="271" r:id="rId17"/>
+    <p:sldId id="279" r:id="rId30"/>
     <p:sldId id="272" r:id="rId18"/>
     <p:sldId id="273" r:id="rId19"/>
     <p:sldId id="274" r:id="rId20"/>
     <p:sldId id="275" r:id="rId21"/>
-    <p:sldId id="276" r:id="rId22"/>
     <p:sldId id="277" r:id="rId23"/>
     <p:sldId id="278" r:id="rId24"/>
   </p:sldIdLst>
@@ -1094,94 +1093,6 @@
 </p:notes>
 </file>
 
-<file path=ppt/notesSlides/notesSlide16.xml><?xml version="1.0" encoding="utf-8"?>
-<p:notes xmlns:a="http://schemas.openxmlformats.org/drawingml/2006/main" xmlns:r="http://schemas.openxmlformats.org/officeDocument/2006/relationships" xmlns:p="http://schemas.openxmlformats.org/presentationml/2006/main">
-  <p:cSld>
-    <p:spTree>
-      <p:nvGrpSpPr>
-        <p:cNvPr id="1" name=""/>
-        <p:cNvGrpSpPr/>
-        <p:nvPr/>
-      </p:nvGrpSpPr>
-      <p:grpSpPr>
-        <a:xfrm>
-          <a:off x="0" y="0"/>
-          <a:ext cx="0" cy="0"/>
-          <a:chOff x="0" y="0"/>
-          <a:chExt cx="0" cy="0"/>
-        </a:xfrm>
-      </p:grpSpPr>
-      <p:sp>
-        <p:nvSpPr>
-          <p:cNvPr id="2" name="Slide Image Placeholder 1"/>
-          <p:cNvSpPr>
-            <a:spLocks noGrp="1" noRot="1" noChangeAspect="1"/>
-          </p:cNvSpPr>
-          <p:nvPr>
-            <p:ph type="sldImg"/>
-          </p:nvPr>
-        </p:nvSpPr>
-        <p:spPr/>
-      </p:sp>
-      <p:sp>
-        <p:nvSpPr>
-          <p:cNvPr id="3" name="Notes Placeholder 2"/>
-          <p:cNvSpPr>
-            <a:spLocks noGrp="1"/>
-          </p:cNvSpPr>
-          <p:nvPr>
-            <p:ph type="body" idx="1"/>
-          </p:nvPr>
-        </p:nvSpPr>
-        <p:spPr/>
-        <p:txBody>
-          <a:bodyPr/>
-          <a:lstStyle/>
-          <a:p>
-            <a:r>
-              <a:rPr lang="en-US" dirty="0"/>
-              <a:t/>
-            </a:r>
-            <a:endParaRPr lang="en-US" dirty="0"/>
-          </a:p>
-        </p:txBody>
-      </p:sp>
-      <p:sp>
-        <p:nvSpPr>
-          <p:cNvPr id="4" name="Slide Number Placeholder 3"/>
-          <p:cNvSpPr>
-            <a:spLocks noGrp="1"/>
-          </p:cNvSpPr>
-          <p:nvPr>
-            <p:ph type="sldNum" sz="quarter" idx="10"/>
-          </p:nvPr>
-        </p:nvSpPr>
-        <p:spPr/>
-        <p:txBody>
-          <a:bodyPr/>
-          <a:lstStyle/>
-          <a:p>
-            <a:fld id="{F7021451-1387-4CA6-816F-3879F97B5CBC}" type="slidenum">
-              <a:rPr lang="en-US"/>
-              <a:t>16</a:t>
-            </a:fld>
-            <a:endParaRPr lang="en-US"/>
-          </a:p>
-        </p:txBody>
-      </p:sp>
-    </p:spTree>
-    <p:extLst>
-      <p:ext uri="{BB962C8B-B14F-4D97-AF65-F5344CB8AC3E}">
-        <p14:creationId xmlns:p14="http://schemas.microsoft.com/office/powerpoint/2010/main" val="1024086991"/>
-      </p:ext>
-    </p:extLst>
-  </p:cSld>
-  <p:clrMapOvr>
-    <a:masterClrMapping/>
-  </p:clrMapOvr>
-</p:notes>
-</file>
-
 <file path=ppt/notesSlides/notesSlide17.xml><?xml version="1.0" encoding="utf-8"?>
 <p:notes xmlns:a="http://schemas.openxmlformats.org/drawingml/2006/main" xmlns:r="http://schemas.openxmlformats.org/officeDocument/2006/relationships" xmlns:p="http://schemas.openxmlformats.org/presentationml/2006/main">
   <p:cSld>
@@ -1604,94 +1515,6 @@
             <a:fld id="{F7021451-1387-4CA6-816F-3879F97B5CBC}" type="slidenum">
               <a:rPr lang="en-US"/>
               <a:t>20</a:t>
-            </a:fld>
-            <a:endParaRPr lang="en-US"/>
-          </a:p>
-        </p:txBody>
-      </p:sp>
-    </p:spTree>
-    <p:extLst>
-      <p:ext uri="{BB962C8B-B14F-4D97-AF65-F5344CB8AC3E}">
-        <p14:creationId xmlns:p14="http://schemas.microsoft.com/office/powerpoint/2010/main" val="1024086991"/>
-      </p:ext>
-    </p:extLst>
-  </p:cSld>
-  <p:clrMapOvr>
-    <a:masterClrMapping/>
-  </p:clrMapOvr>
-</p:notes>
-</file>
-
-<file path=ppt/notesSlides/notesSlide21.xml><?xml version="1.0" encoding="utf-8"?>
-<p:notes xmlns:a="http://schemas.openxmlformats.org/drawingml/2006/main" xmlns:r="http://schemas.openxmlformats.org/officeDocument/2006/relationships" xmlns:p="http://schemas.openxmlformats.org/presentationml/2006/main">
-  <p:cSld>
-    <p:spTree>
-      <p:nvGrpSpPr>
-        <p:cNvPr id="1" name=""/>
-        <p:cNvGrpSpPr/>
-        <p:nvPr/>
-      </p:nvGrpSpPr>
-      <p:grpSpPr>
-        <a:xfrm>
-          <a:off x="0" y="0"/>
-          <a:ext cx="0" cy="0"/>
-          <a:chOff x="0" y="0"/>
-          <a:chExt cx="0" cy="0"/>
-        </a:xfrm>
-      </p:grpSpPr>
-      <p:sp>
-        <p:nvSpPr>
-          <p:cNvPr id="2" name="Slide Image Placeholder 1"/>
-          <p:cNvSpPr>
-            <a:spLocks noGrp="1" noRot="1" noChangeAspect="1"/>
-          </p:cNvSpPr>
-          <p:nvPr>
-            <p:ph type="sldImg"/>
-          </p:nvPr>
-        </p:nvSpPr>
-        <p:spPr/>
-      </p:sp>
-      <p:sp>
-        <p:nvSpPr>
-          <p:cNvPr id="3" name="Notes Placeholder 2"/>
-          <p:cNvSpPr>
-            <a:spLocks noGrp="1"/>
-          </p:cNvSpPr>
-          <p:nvPr>
-            <p:ph type="body" idx="1"/>
-          </p:nvPr>
-        </p:nvSpPr>
-        <p:spPr/>
-        <p:txBody>
-          <a:bodyPr/>
-          <a:lstStyle/>
-          <a:p>
-            <a:r>
-              <a:rPr lang="en-US" dirty="0"/>
-              <a:t/>
-            </a:r>
-            <a:endParaRPr lang="en-US" dirty="0"/>
-          </a:p>
-        </p:txBody>
-      </p:sp>
-      <p:sp>
-        <p:nvSpPr>
-          <p:cNvPr id="4" name="Slide Number Placeholder 3"/>
-          <p:cNvSpPr>
-            <a:spLocks noGrp="1"/>
-          </p:cNvSpPr>
-          <p:nvPr>
-            <p:ph type="sldNum" sz="quarter" idx="10"/>
-          </p:nvPr>
-        </p:nvSpPr>
-        <p:spPr/>
-        <p:txBody>
-          <a:bodyPr/>
-          <a:lstStyle/>
-          <a:p>
-            <a:fld id="{F7021451-1387-4CA6-816F-3879F97B5CBC}" type="slidenum">
-              <a:rPr lang="en-US"/>
-              <a:t>21</a:t>
             </a:fld>
             <a:endParaRPr lang="en-US"/>
           </a:p>
@@ -3200,7 +3023,7 @@
                 <a:ea typeface="Calibri" pitchFamily="34" charset="-122"/>
                 <a:cs typeface="Calibri" pitchFamily="34" charset="-120"/>
               </a:rPr>
-              <a:t>Agents calling agents — specialized workers, isolated context, composed workflows</a:t>
+              <a:t>Agents calling agents — exactly as the code-review plugin does for 4+ policies</a:t>
             </a:r>
             <a:endParaRPr lang="en-US" sz="1300" dirty="0"/>
           </a:p>
@@ -3380,7 +3203,7 @@
                 <a:ea typeface="Calibri" pitchFamily="34" charset="-122"/>
                 <a:cs typeface="Calibri" pitchFamily="34" charset="-120"/>
               </a:rPr>
-              <a:t>Planner</a:t>
+              <a:t>code-reviewer</a:t>
             </a:r>
             <a:endParaRPr lang="en-US" sz="1200" dirty="0"/>
           </a:p>
@@ -3400,7 +3223,7 @@
                 <a:ea typeface="Calibri" pitchFamily="34" charset="-122"/>
                 <a:cs typeface="Calibri" pitchFamily="34" charset="-120"/>
               </a:rPr>
-              <a:t>Agent</a:t>
+              <a:t>(fetches diff)</a:t>
             </a:r>
             <a:endParaRPr lang="en-US" sz="1200" dirty="0"/>
           </a:p>
@@ -3442,7 +3265,7 @@
                 <a:ea typeface="Calibri" pitchFamily="34" charset="-122"/>
                 <a:cs typeface="Calibri" pitchFamily="34" charset="-120"/>
               </a:rPr>
-              <a:t>Breaks task into</a:t>
+              <a:t>Receives PR number</a:t>
             </a:r>
             <a:endParaRPr lang="en-US" sz="900" dirty="0"/>
           </a:p>
@@ -3462,7 +3285,7 @@
                 <a:ea typeface="Calibri" pitchFamily="34" charset="-122"/>
                 <a:cs typeface="Calibri" pitchFamily="34" charset="-120"/>
               </a:rPr>
-              <a:t>subtasks</a:t>
+              <a:t>Dispatches policies</a:t>
             </a:r>
             <a:endParaRPr lang="en-US" sz="900" dirty="0"/>
           </a:p>
@@ -3604,7 +3427,7 @@
                 <a:ea typeface="Calibri" pitchFamily="34" charset="-122"/>
                 <a:cs typeface="Calibri" pitchFamily="34" charset="-120"/>
               </a:rPr>
-              <a:t>Researcher</a:t>
+              <a:t>security</a:t>
             </a:r>
             <a:endParaRPr lang="en-US" sz="1200" dirty="0"/>
           </a:p>
@@ -3646,7 +3469,7 @@
                 <a:ea typeface="Calibri" pitchFamily="34" charset="-122"/>
                 <a:cs typeface="Calibri" pitchFamily="34" charset="-120"/>
               </a:rPr>
-              <a:t>Understands codebase</a:t>
+              <a:t>hims-ads checks</a:t>
             </a:r>
             <a:endParaRPr lang="en-US" sz="900" dirty="0"/>
           </a:p>
@@ -3764,7 +3587,7 @@
                 <a:ea typeface="Calibri" pitchFamily="34" charset="-122"/>
                 <a:cs typeface="Calibri" pitchFamily="34" charset="-120"/>
               </a:rPr>
-              <a:t>Implementer</a:t>
+              <a:t>quality</a:t>
             </a:r>
             <a:endParaRPr lang="en-US" sz="1200" dirty="0"/>
           </a:p>
@@ -3806,7 +3629,7 @@
                 <a:ea typeface="Calibri" pitchFamily="34" charset="-122"/>
                 <a:cs typeface="Calibri" pitchFamily="34" charset="-120"/>
               </a:rPr>
-              <a:t>Writes changes</a:t>
+              <a:t>best-practices + design</a:t>
             </a:r>
             <a:endParaRPr lang="en-US" sz="900" dirty="0"/>
           </a:p>
@@ -3924,7 +3747,7 @@
                 <a:ea typeface="Calibri" pitchFamily="34" charset="-122"/>
                 <a:cs typeface="Calibri" pitchFamily="34" charset="-120"/>
               </a:rPr>
-              <a:t>Reviewer</a:t>
+              <a:t>performance</a:t>
             </a:r>
             <a:endParaRPr lang="en-US" sz="1200" dirty="0"/>
           </a:p>
@@ -3966,7 +3789,7 @@
                 <a:ea typeface="Calibri" pitchFamily="34" charset="-122"/>
                 <a:cs typeface="Calibri" pitchFamily="34" charset="-120"/>
               </a:rPr>
-              <a:t>Checks output</a:t>
+              <a:t>algo + DB + memory</a:t>
             </a:r>
             <a:endParaRPr lang="en-US" sz="900" dirty="0"/>
           </a:p>
@@ -4098,7 +3921,7 @@
                 <a:ea typeface="Calibri" pitchFamily="34" charset="-122"/>
                 <a:cs typeface="Calibri" pitchFamily="34" charset="-120"/>
               </a:rPr>
-              <a:t>Context isolation — each agent sees only what it needs</a:t>
+              <a:t>Context isolation — each policy sees only its checks/*.md</a:t>
             </a:r>
             <a:endParaRPr lang="en-US" sz="1100" dirty="0"/>
           </a:p>
@@ -4122,7 +3945,7 @@
                 <a:ea typeface="Calibri" pitchFamily="34" charset="-122"/>
                 <a:cs typeface="Calibri" pitchFamily="34" charset="-120"/>
               </a:rPr>
-              <a:t>Specialization — better outputs from focused workers</a:t>
+              <a:t>Specialization — domain expertise per policy</a:t>
             </a:r>
             <a:endParaRPr lang="en-US" sz="1100" dirty="0"/>
           </a:p>
@@ -4146,7 +3969,7 @@
                 <a:ea typeface="Calibri" pitchFamily="34" charset="-122"/>
                 <a:cs typeface="Calibri" pitchFamily="34" charset="-120"/>
               </a:rPr>
-              <a:t>Parallelism — agents work independently</a:t>
+              <a:t>Parallelism — 4+ policies run concurrently</a:t>
             </a:r>
             <a:endParaRPr lang="en-US" sz="1100" dirty="0"/>
           </a:p>
@@ -4389,7 +4212,7 @@
                 <a:ea typeface="Calibri" pitchFamily="34" charset="-122"/>
                 <a:cs typeface="Calibri" pitchFamily="34" charset="-120"/>
               </a:rPr>
-              <a:t>Start with one agent. Add sub-agents when complexity exceeds what a single context can hold.</a:t>
+              <a:t>See the code-review plugin README — "Subagent orchestration" section — for the actual orchestration logic.</a:t>
             </a:r>
             <a:endParaRPr lang="en-US" sz="1300" dirty="0"/>
           </a:p>
@@ -5403,7 +5226,7 @@
                 <a:ea typeface="Consolas" pitchFamily="34" charset="-122"/>
                 <a:cs typeface="Consolas" pitchFamily="34" charset="-120"/>
               </a:rPr>
-              <a:t>.github/skills/pr-review/SKILL.md</a:t>
+              <a:t>.github/skills/design-patterns/SKILL.md</a:t>
             </a:r>
             <a:r>
               <a:rPr lang="en-US" sz="900" i="1" dirty="0">
@@ -5431,7 +5254,7 @@
                 <a:ea typeface="Consolas" pitchFamily="34" charset="-122"/>
                 <a:cs typeface="Consolas" pitchFamily="34" charset="-120"/>
               </a:rPr>
-              <a:t>~/.copilot/skills/pr-review/SKILL.md</a:t>
+              <a:t>~/.copilot/skills/design-patterns/SKILL.md</a:t>
             </a:r>
             <a:r>
               <a:rPr lang="en-US" sz="900" i="1" dirty="0">
@@ -5459,7 +5282,7 @@
                 <a:ea typeface="Consolas" pitchFamily="34" charset="-122"/>
                 <a:cs typeface="Consolas" pitchFamily="34" charset="-120"/>
               </a:rPr>
-              <a:t>name: pr-review</a:t>
+              <a:t>name: design-patterns</a:t>
             </a:r>
             <a:endParaRPr lang="en-US" sz="1000" dirty="0"/>
           </a:p>
@@ -5476,7 +5299,7 @@
                 <a:ea typeface="Consolas" pitchFamily="34" charset="-122"/>
                 <a:cs typeface="Consolas" pitchFamily="34" charset="-120"/>
               </a:rPr>
-              <a:t>description: "Review a PR for quality"</a:t>
+              <a:t>description: "Design-pattern review — arch &amp; anti-pattern"</a:t>
             </a:r>
             <a:endParaRPr lang="en-US" sz="1000" dirty="0"/>
           </a:p>
@@ -5516,7 +5339,7 @@
                 <a:ea typeface="Consolas" pitchFamily="34" charset="-122"/>
                 <a:cs typeface="Consolas" pitchFamily="34" charset="-120"/>
               </a:rPr>
-              <a:t>## Steps</a:t>
+              <a:t>## Inputs · Activation · Severity</a:t>
             </a:r>
             <a:endParaRPr lang="en-US" sz="1000" dirty="0"/>
           </a:p>
@@ -5533,7 +5356,7 @@
                 <a:ea typeface="Consolas" pitchFamily="34" charset="-122"/>
                 <a:cs typeface="Consolas" pitchFamily="34" charset="-120"/>
               </a:rPr>
-              <a:t>1. Check tests cover the changes</a:t>
+              <a:t>Inputs: architecture type, language, focus</a:t>
             </a:r>
             <a:endParaRPr lang="en-US" sz="1000" dirty="0"/>
           </a:p>
@@ -5550,7 +5373,7 @@
                 <a:ea typeface="Consolas" pitchFamily="34" charset="-122"/>
                 <a:cs typeface="Consolas" pitchFamily="34" charset="-120"/>
               </a:rPr>
-              <a:t>2. Verify naming conventions</a:t>
+              <a:t>Activation: per arch (microservices, event-driven …)</a:t>
             </a:r>
             <a:endParaRPr lang="en-US" sz="1000" dirty="0"/>
           </a:p>
@@ -5567,7 +5390,7 @@
                 <a:ea typeface="Consolas" pitchFamily="34" charset="-122"/>
                 <a:cs typeface="Consolas" pitchFamily="34" charset="-120"/>
               </a:rPr>
-              <a:t>3. Flag security risks</a:t>
+              <a:t>Severity: CRITICAL / HIGH / MEDIUM / INFO</a:t>
             </a:r>
             <a:endParaRPr lang="en-US" sz="1000" dirty="0"/>
           </a:p>
@@ -5584,7 +5407,7 @@
                 <a:ea typeface="Consolas" pitchFamily="34" charset="-122"/>
                 <a:cs typeface="Consolas" pitchFamily="34" charset="-120"/>
               </a:rPr>
-              <a:t>4. Check error handling</a:t>
+              <a:t>Checks index → checks/dp-*.md (creational, structural …)</a:t>
             </a:r>
             <a:endParaRPr lang="en-US" sz="1000" dirty="0"/>
           </a:p>
@@ -5810,7 +5633,7 @@
                 <a:ea typeface="Consolas" pitchFamily="34" charset="-122"/>
                 <a:cs typeface="Consolas" pitchFamily="34" charset="-120"/>
               </a:rPr>
-              <a:t>"Review these changes"</a:t>
+              <a:t>"design pattern review"</a:t>
             </a:r>
             <a:endParaRPr lang="en-US" sz="1000" dirty="0"/>
           </a:p>
@@ -5830,7 +5653,7 @@
                 <a:ea typeface="Consolas" pitchFamily="34" charset="-122"/>
                 <a:cs typeface="Consolas" pitchFamily="34" charset="-120"/>
               </a:rPr>
-              <a:t>"Check the PR for issues"</a:t>
+              <a:t>"architectural review"</a:t>
             </a:r>
             <a:endParaRPr lang="en-US" sz="1000" dirty="0"/>
           </a:p>
@@ -5850,7 +5673,7 @@
                 <a:ea typeface="Consolas" pitchFamily="34" charset="-122"/>
                 <a:cs typeface="Consolas" pitchFamily="34" charset="-120"/>
               </a:rPr>
-              <a:t>"Does this look ready to merge?"</a:t>
+              <a:t>"anti-pattern check"</a:t>
             </a:r>
             <a:endParaRPr lang="en-US" sz="1000" dirty="0"/>
           </a:p>
@@ -6019,7 +5842,7 @@
                 <a:ea typeface="Calibri" pitchFamily="34" charset="-122"/>
                 <a:cs typeface="Calibri" pitchFamily="34" charset="-120"/>
               </a:rPr>
-              <a:t>End-to-end: PR arrives → policy-aware review → auto-generated summary</a:t>
+              <a:t>Opening demo, replayed — every step was a pillar</a:t>
             </a:r>
             <a:endParaRPr lang="en-US" sz="1300" dirty="0"/>
           </a:p>
@@ -6144,7 +5967,7 @@
                 <a:ea typeface="Calibri" pitchFamily="34" charset="-122"/>
                 <a:cs typeface="Calibri" pitchFamily="34" charset="-120"/>
               </a:rPr>
-              <a:t>PR arrives</a:t>
+              <a:t>ADO PR #1234</a:t>
             </a:r>
             <a:endParaRPr lang="en-US" sz="1200" dirty="0"/>
           </a:p>
@@ -6186,7 +6009,7 @@
                 <a:ea typeface="Calibri" pitchFamily="34" charset="-122"/>
                 <a:cs typeface="Calibri" pitchFamily="34" charset="-120"/>
               </a:rPr>
-              <a:t>ADO work item with new changes</a:t>
+              <a:t>Pillar 5 — ADO MCP fetches PR</a:t>
             </a:r>
             <a:endParaRPr lang="en-US" sz="900" dirty="0"/>
           </a:p>
@@ -6335,7 +6158,7 @@
                 <a:ea typeface="Calibri" pitchFamily="34" charset="-122"/>
                 <a:cs typeface="Calibri" pitchFamily="34" charset="-120"/>
               </a:rPr>
-              <a:t>Pull context</a:t>
+              <a:t>code review PR #1234</a:t>
             </a:r>
             <a:endParaRPr lang="en-US" sz="1200" dirty="0"/>
           </a:p>
@@ -6377,7 +6200,7 @@
                 <a:ea typeface="Calibri" pitchFamily="34" charset="-122"/>
                 <a:cs typeface="Calibri" pitchFamily="34" charset="-120"/>
               </a:rPr>
-              <a:t>az repos pr show --id 135108</a:t>
+              <a:t>Pillar 3 — agent trigger</a:t>
             </a:r>
             <a:endParaRPr lang="en-US" sz="900" dirty="0"/>
           </a:p>
@@ -6526,7 +6349,7 @@
                 <a:ea typeface="Calibri" pitchFamily="34" charset="-122"/>
                 <a:cs typeface="Calibri" pitchFamily="34" charset="-120"/>
               </a:rPr>
-              <a:t>Skill triggers</a:t>
+              <a:t>design-patterns auto-loads</a:t>
             </a:r>
             <a:endParaRPr lang="en-US" sz="1200" dirty="0"/>
           </a:p>
@@ -6568,7 +6391,7 @@
                 <a:ea typeface="Calibri" pitchFamily="34" charset="-122"/>
                 <a:cs typeface="Calibri" pitchFamily="34" charset="-120"/>
               </a:rPr>
-              <a:t>"Review this PR" → pr-review loads</a:t>
+              <a:t>Pillar 4 — skill auto-loads</a:t>
             </a:r>
             <a:endParaRPr lang="en-US" sz="900" dirty="0"/>
           </a:p>
@@ -6717,7 +6540,7 @@
                 <a:ea typeface="Calibri" pitchFamily="34" charset="-122"/>
                 <a:cs typeface="Calibri" pitchFamily="34" charset="-120"/>
               </a:rPr>
-              <a:t>Policy review</a:t>
+              <a:t>sub-agents run in parallel</a:t>
             </a:r>
             <a:endParaRPr lang="en-US" sz="1200" dirty="0"/>
           </a:p>
@@ -6759,7 +6582,7 @@
                 <a:ea typeface="Calibri" pitchFamily="34" charset="-122"/>
                 <a:cs typeface="Calibri" pitchFamily="34" charset="-120"/>
               </a:rPr>
-              <a:t>Team conventions + security policies</a:t>
+              <a:t>Pillar 3 — 3 policies concurrently</a:t>
             </a:r>
             <a:endParaRPr lang="en-US" sz="900" dirty="0"/>
           </a:p>
@@ -6908,7 +6731,7 @@
                 <a:ea typeface="Calibri" pitchFamily="34" charset="-122"/>
                 <a:cs typeface="Calibri" pitchFamily="34" charset="-120"/>
               </a:rPr>
-              <a:t>Summary output</a:t>
+              <a:t>Inline comments + summary</a:t>
             </a:r>
             <a:endParaRPr lang="en-US" sz="1200" dirty="0"/>
           </a:p>
@@ -6950,7 +6773,7 @@
                 <a:ea typeface="Calibri" pitchFamily="34" charset="-122"/>
                 <a:cs typeface="Calibri" pitchFamily="34" charset="-120"/>
               </a:rPr>
-              <a:t>Checklist + fixes + PR description</a:t>
+              <a:t>Pillar 4 — reporting skill formats output</a:t>
             </a:r>
             <a:endParaRPr lang="en-US" sz="900" dirty="0"/>
           </a:p>
@@ -7078,7 +6901,7 @@
                 <a:ea typeface="Calibri" pitchFamily="34" charset="-122"/>
                 <a:cs typeface="Calibri" pitchFamily="34" charset="-120"/>
               </a:rPr>
-              <a:t>No hardcoded secrets · PII sanitization</a:t>
+              <a:t>hims-ads-code-review-policy checks</a:t>
             </a:r>
             <a:endParaRPr lang="en-US" sz="1100" dirty="0"/>
           </a:p>
@@ -7098,7 +6921,7 @@
                 <a:ea typeface="Calibri" pitchFamily="34" charset="-122"/>
                 <a:cs typeface="Calibri" pitchFamily="34" charset="-120"/>
               </a:rPr>
-              <a:t>Input validation · Auth checks · Conv. commits</a:t>
+              <a:t>design-patterns + general-best-practices checks</a:t>
             </a:r>
             <a:endParaRPr lang="en-US" sz="1100" dirty="0"/>
           </a:p>
@@ -7226,7 +7049,7 @@
                 <a:ea typeface="Calibri" pitchFamily="34" charset="-122"/>
                 <a:cs typeface="Calibri" pitchFamily="34" charset="-120"/>
               </a:rPr>
-              <a:t>PASS/FAIL checklist · Suggested fixes</a:t>
+              <a:t>Threaded comments at file:line</a:t>
             </a:r>
             <a:endParaRPr lang="en-US" sz="1100" dirty="0"/>
           </a:p>
@@ -7246,7 +7069,7 @@
                 <a:ea typeface="Calibri" pitchFamily="34" charset="-122"/>
                 <a:cs typeface="Calibri" pitchFamily="34" charset="-120"/>
               </a:rPr>
-              <a:t>PR description draft · Reviewer summary</a:t>
+              <a:t>Severity-ranked summary in PR</a:t>
             </a:r>
             <a:endParaRPr lang="en-US" sz="1100" dirty="0"/>
           </a:p>
@@ -7356,7 +7179,7 @@
                 <a:ea typeface="Calibri" pitchFamily="34" charset="-122"/>
                 <a:cs typeface="Calibri" pitchFamily="34" charset="-120"/>
               </a:rPr>
-              <a:t>KNOWN LIMIT</a:t>
+              <a:t>WHY MCP, NOT az CLI</a:t>
             </a:r>
             <a:endParaRPr lang="en-US" sz="900" dirty="0"/>
           </a:p>
@@ -7395,7 +7218,7 @@
                 <a:ea typeface="Calibri" pitchFamily="34" charset="-122"/>
                 <a:cs typeface="Calibri" pitchFamily="34" charset="-120"/>
               </a:rPr>
-              <a:t>az CLI can't post inline PR comments yet — summary goes to terminal, paste into ADO or script via REST.</a:t>
+              <a:t>Inline threaded comments need the ADO REST API. The MCP handles it — the plugin bundles this wiring.</a:t>
             </a:r>
             <a:endParaRPr lang="en-US" sz="1000" dirty="0"/>
           </a:p>
@@ -7564,7 +7387,7 @@
                 <a:ea typeface="Calibri" pitchFamily="34" charset="-122"/>
                 <a:cs typeface="Calibri" pitchFamily="34" charset="-120"/>
               </a:rPr>
-              <a:t>Security findings become fixable, not just a long list</a:t>
+              <a:t>Different domain, same structure — see gep_skills/security/ for checkmarx-* skills</a:t>
             </a:r>
             <a:endParaRPr lang="en-US" sz="1300" dirty="0"/>
           </a:p>
@@ -8617,7 +8440,7 @@
                 <a:ea typeface="Calibri" pitchFamily="34" charset="-122"/>
                 <a:cs typeface="Calibri" pitchFamily="34" charset="-120"/>
               </a:rPr>
-              <a:t>Same pattern as pr-review — different domain. Skills compose, don't multiply complexity.</a:t>
+              <a:t>Same pattern as code-review — different domain. Skills compose, don't multiply complexity.</a:t>
             </a:r>
             <a:endParaRPr lang="en-US" sz="1200" dirty="0"/>
           </a:p>
@@ -9191,7 +9014,7 @@
                 <a:ea typeface="Calibri" pitchFamily="34" charset="-122"/>
                 <a:cs typeface="Calibri" pitchFamily="34" charset="-120"/>
               </a:rPr>
-              <a:t>Higher context cost — use domains to limit</a:t>
+              <a:t>Plugin bundles it — just 6 lines in .mcp.json: { "azure-devops": "@azure-devops/mcp IHIS-HIP" }</a:t>
             </a:r>
             <a:endParaRPr lang="en-US" sz="1100" dirty="0"/>
           </a:p>
@@ -9212,7 +9035,7 @@
                 <a:ea typeface="Calibri" pitchFamily="34" charset="-122"/>
                 <a:cs typeface="Calibri" pitchFamily="34" charset="-120"/>
               </a:rPr>
-              <a:t>Microsoft-maintained (@azure-devops/mcp)</a:t>
+              <a:t>Microsoft-maintained · zero manual setup when bundled</a:t>
             </a:r>
             <a:endParaRPr lang="en-US" sz="1100" dirty="0"/>
           </a:p>
@@ -9334,1746 +9157,9 @@
                 <a:ea typeface="Calibri" pitchFamily="34" charset="-122"/>
                 <a:cs typeface="Calibri" pitchFamily="34" charset="-120"/>
               </a:rPr>
-              <a:t>Start with CLI Skill. Graduate to MCP only when the tool surface justifies the context cost.</a:t>
+              <a:t>Plugins declare MCP in .mcp.json — engineers install once, MCP wires automatically.</a:t>
             </a:r>
             <a:endParaRPr lang="en-US" sz="1300" dirty="0"/>
-          </a:p>
-        </p:txBody>
-      </p:sp>
-    </p:spTree>
-  </p:cSld>
-  <p:clrMapOvr>
-    <a:masterClrMapping/>
-  </p:clrMapOvr>
-</p:sld>
-</file>
-
-<file path=ppt/slides/slide16.xml><?xml version="1.0" encoding="utf-8"?>
-<p:sld xmlns:a="http://schemas.openxmlformats.org/drawingml/2006/main" xmlns:r="http://schemas.openxmlformats.org/officeDocument/2006/relationships" xmlns:p="http://schemas.openxmlformats.org/presentationml/2006/main">
-  <p:cSld name="Slide 16">
-    <p:bg>
-      <p:bgPr>
-        <a:solidFill>
-          <a:srgbClr val="F8FAFC"/>
-        </a:solidFill>
-      </p:bgPr>
-    </p:bg>
-    <p:spTree>
-      <p:nvGrpSpPr>
-        <p:cNvPr id="1" name=""/>
-        <p:cNvGrpSpPr/>
-        <p:nvPr/>
-      </p:nvGrpSpPr>
-      <p:grpSpPr>
-        <a:xfrm>
-          <a:off x="0" y="0"/>
-          <a:ext cx="0" cy="0"/>
-          <a:chOff x="0" y="0"/>
-          <a:chExt cx="0" cy="0"/>
-        </a:xfrm>
-      </p:grpSpPr>
-      <p:sp>
-        <p:nvSpPr>
-          <p:cNvPr id="2" name="Shape 0"/>
-          <p:cNvSpPr/>
-          <p:nvPr/>
-        </p:nvSpPr>
-        <p:spPr>
-          <a:xfrm>
-            <a:off x="0" y="0"/>
-            <a:ext cx="9144000" cy="54864"/>
-          </a:xfrm>
-          <a:prstGeom prst="rect">
-            <a:avLst/>
-          </a:prstGeom>
-          <a:solidFill>
-            <a:srgbClr val="0EA5E9"/>
-          </a:solidFill>
-          <a:ln/>
-        </p:spPr>
-      </p:sp>
-      <p:sp>
-        <p:nvSpPr>
-          <p:cNvPr id="3" name="Text 1"/>
-          <p:cNvSpPr/>
-          <p:nvPr/>
-        </p:nvSpPr>
-        <p:spPr>
-          <a:xfrm>
-            <a:off x="731520" y="182880"/>
-            <a:ext cx="1828800" cy="320040"/>
-          </a:xfrm>
-          <a:prstGeom prst="rect">
-            <a:avLst/>
-          </a:prstGeom>
-          <a:noFill/>
-          <a:ln/>
-        </p:spPr>
-        <p:txBody>
-          <a:bodyPr wrap="square" lIns="0" tIns="0" rIns="0" bIns="0" rtlCol="0" anchor="ctr"/>
-          <a:lstStyle/>
-          <a:p>
-            <a:pPr indent="0" marL="0">
-              <a:buNone/>
-            </a:pPr>
-            <a:r>
-              <a:rPr lang="en-US" sz="1200" b="1" spc="300" kern="0" dirty="0">
-                <a:solidFill>
-                  <a:srgbClr val="0EA5E9"/>
-                </a:solidFill>
-                <a:latin typeface="Calibri" pitchFamily="34" charset="0"/>
-                <a:ea typeface="Calibri" pitchFamily="34" charset="-122"/>
-                <a:cs typeface="Calibri" pitchFamily="34" charset="-120"/>
-              </a:rPr>
-              <a:t>Pillar 6</a:t>
-            </a:r>
-            <a:endParaRPr lang="en-US" sz="1200" dirty="0"/>
-          </a:p>
-        </p:txBody>
-      </p:sp>
-      <p:sp>
-        <p:nvSpPr>
-          <p:cNvPr id="4" name="Text 2"/>
-          <p:cNvSpPr/>
-          <p:nvPr/>
-        </p:nvSpPr>
-        <p:spPr>
-          <a:xfrm>
-            <a:off x="731520" y="457200"/>
-            <a:ext cx="7772400" cy="502920"/>
-          </a:xfrm>
-          <a:prstGeom prst="rect">
-            <a:avLst/>
-          </a:prstGeom>
-          <a:noFill/>
-          <a:ln/>
-        </p:spPr>
-        <p:txBody>
-          <a:bodyPr wrap="square" lIns="0" tIns="0" rIns="0" bIns="0" rtlCol="0" anchor="ctr"/>
-          <a:lstStyle/>
-          <a:p>
-            <a:pPr indent="0" marL="0">
-              <a:buNone/>
-            </a:pPr>
-            <a:r>
-              <a:rPr lang="en-US" sz="2600" dirty="0">
-                <a:solidFill>
-                  <a:srgbClr val="1E293B"/>
-                </a:solidFill>
-                <a:latin typeface="Arial Black" pitchFamily="34" charset="0"/>
-                <a:ea typeface="Arial Black" pitchFamily="34" charset="-122"/>
-                <a:cs typeface="Arial Black" pitchFamily="34" charset="-120"/>
-              </a:rPr>
-              <a:t>Automation — In Your Pipeline</a:t>
-            </a:r>
-            <a:endParaRPr lang="en-US" sz="2600" dirty="0"/>
-          </a:p>
-        </p:txBody>
-      </p:sp>
-      <p:sp>
-        <p:nvSpPr>
-          <p:cNvPr id="5" name="Text 3"/>
-          <p:cNvSpPr/>
-          <p:nvPr/>
-        </p:nvSpPr>
-        <p:spPr>
-          <a:xfrm>
-            <a:off x="731520" y="914400"/>
-            <a:ext cx="7772400" cy="274320"/>
-          </a:xfrm>
-          <a:prstGeom prst="rect">
-            <a:avLst/>
-          </a:prstGeom>
-          <a:noFill/>
-          <a:ln/>
-        </p:spPr>
-        <p:txBody>
-          <a:bodyPr wrap="square" lIns="0" tIns="0" rIns="0" bIns="0" rtlCol="0" anchor="ctr"/>
-          <a:lstStyle/>
-          <a:p>
-            <a:pPr indent="0" marL="0">
-              <a:buNone/>
-            </a:pPr>
-            <a:r>
-              <a:rPr lang="en-US" sz="1300" i="1" dirty="0">
-                <a:solidFill>
-                  <a:srgbClr val="475569"/>
-                </a:solidFill>
-                <a:latin typeface="Calibri" pitchFamily="34" charset="0"/>
-                <a:ea typeface="Calibri" pitchFamily="34" charset="-122"/>
-                <a:cs typeface="Calibri" pitchFamily="34" charset="-120"/>
-              </a:rPr>
-              <a:t>AI runs without you — the bridge from tool to pipeline</a:t>
-            </a:r>
-            <a:endParaRPr lang="en-US" sz="1300" dirty="0"/>
-          </a:p>
-        </p:txBody>
-      </p:sp>
-      <p:sp>
-        <p:nvSpPr>
-          <p:cNvPr id="6" name="Shape 4"/>
-          <p:cNvSpPr/>
-          <p:nvPr/>
-        </p:nvSpPr>
-        <p:spPr>
-          <a:xfrm>
-            <a:off x="731520" y="1371600"/>
-            <a:ext cx="7680960" cy="457200"/>
-          </a:xfrm>
-          <a:prstGeom prst="rect">
-            <a:avLst/>
-          </a:prstGeom>
-          <a:solidFill>
-            <a:srgbClr val="1E293B"/>
-          </a:solidFill>
-          <a:ln/>
-        </p:spPr>
-      </p:sp>
-      <p:sp>
-        <p:nvSpPr>
-          <p:cNvPr id="7" name="Text 5"/>
-          <p:cNvSpPr/>
-          <p:nvPr/>
-        </p:nvSpPr>
-        <p:spPr>
-          <a:xfrm>
-            <a:off x="914400" y="1371600"/>
-            <a:ext cx="7315200" cy="457200"/>
-          </a:xfrm>
-          <a:prstGeom prst="rect">
-            <a:avLst/>
-          </a:prstGeom>
-          <a:noFill/>
-          <a:ln/>
-        </p:spPr>
-        <p:txBody>
-          <a:bodyPr wrap="square" lIns="0" tIns="0" rIns="0" bIns="0" rtlCol="0" anchor="ctr"/>
-          <a:lstStyle/>
-          <a:p>
-            <a:pPr indent="0" marL="0">
-              <a:buNone/>
-            </a:pPr>
-            <a:r>
-              <a:rPr lang="en-US" sz="1300" dirty="0">
-                <a:solidFill>
-                  <a:srgbClr val="38BDF8"/>
-                </a:solidFill>
-                <a:latin typeface="Consolas" pitchFamily="34" charset="0"/>
-                <a:ea typeface="Consolas" pitchFamily="34" charset="-122"/>
-                <a:cs typeface="Consolas" pitchFamily="34" charset="-120"/>
-              </a:rPr>
-              <a:t>copilot -p "prompt" — one-shot, no interaction, scriptable</a:t>
-            </a:r>
-            <a:endParaRPr lang="en-US" sz="1300" dirty="0"/>
-          </a:p>
-        </p:txBody>
-      </p:sp>
-      <p:sp>
-        <p:nvSpPr>
-          <p:cNvPr id="8" name="Text 6"/>
-          <p:cNvSpPr/>
-          <p:nvPr/>
-        </p:nvSpPr>
-        <p:spPr>
-          <a:xfrm>
-            <a:off x="731520" y="1965960"/>
-            <a:ext cx="4572000" cy="228600"/>
-          </a:xfrm>
-          <a:prstGeom prst="rect">
-            <a:avLst/>
-          </a:prstGeom>
-          <a:noFill/>
-          <a:ln/>
-        </p:spPr>
-        <p:txBody>
-          <a:bodyPr wrap="square" lIns="0" tIns="0" rIns="0" bIns="0" rtlCol="0" anchor="ctr"/>
-          <a:lstStyle/>
-          <a:p>
-            <a:pPr indent="0" marL="0">
-              <a:buNone/>
-            </a:pPr>
-            <a:r>
-              <a:rPr lang="en-US" sz="1000" b="1" spc="200" kern="0" dirty="0">
-                <a:solidFill>
-                  <a:srgbClr val="0EA5E9"/>
-                </a:solidFill>
-                <a:latin typeface="Calibri" pitchFamily="34" charset="0"/>
-                <a:ea typeface="Calibri" pitchFamily="34" charset="-122"/>
-                <a:cs typeface="Calibri" pitchFamily="34" charset="-120"/>
-              </a:rPr>
-              <a:t>EXAMPLE: AI-AUGMENTED CI STEP</a:t>
-            </a:r>
-            <a:endParaRPr lang="en-US" sz="1000" dirty="0"/>
-          </a:p>
-        </p:txBody>
-      </p:sp>
-      <p:sp>
-        <p:nvSpPr>
-          <p:cNvPr id="9" name="Shape 7"/>
-          <p:cNvSpPr/>
-          <p:nvPr/>
-        </p:nvSpPr>
-        <p:spPr>
-          <a:xfrm>
-            <a:off x="731520" y="2286000"/>
-            <a:ext cx="1417320" cy="1234440"/>
-          </a:xfrm>
-          <a:prstGeom prst="rect">
-            <a:avLst/>
-          </a:prstGeom>
-          <a:solidFill>
-            <a:srgbClr val="FFFFFF"/>
-          </a:solidFill>
-          <a:ln/>
-          <a:effectLst>
-            <a:outerShdw sx="100000" sy="100000" kx="0" ky="0" algn="bl" rotWithShape="0" blurRad="50800" dist="25400" dir="8100000">
-              <a:srgbClr val="000000">
-                <a:alpha val="8000"/>
-              </a:srgbClr>
-            </a:outerShdw>
-          </a:effectLst>
-        </p:spPr>
-      </p:sp>
-      <p:sp>
-        <p:nvSpPr>
-          <p:cNvPr id="10" name="Shape 8"/>
-          <p:cNvSpPr/>
-          <p:nvPr/>
-        </p:nvSpPr>
-        <p:spPr>
-          <a:xfrm>
-            <a:off x="731520" y="2286000"/>
-            <a:ext cx="1417320" cy="54864"/>
-          </a:xfrm>
-          <a:prstGeom prst="rect">
-            <a:avLst/>
-          </a:prstGeom>
-          <a:solidFill>
-            <a:srgbClr val="0EA5E9"/>
-          </a:solidFill>
-          <a:ln/>
-        </p:spPr>
-      </p:sp>
-      <p:sp>
-        <p:nvSpPr>
-          <p:cNvPr id="11" name="Text 9"/>
-          <p:cNvSpPr/>
-          <p:nvPr/>
-        </p:nvSpPr>
-        <p:spPr>
-          <a:xfrm>
-            <a:off x="731520" y="2377440"/>
-            <a:ext cx="1417320" cy="228600"/>
-          </a:xfrm>
-          <a:prstGeom prst="rect">
-            <a:avLst/>
-          </a:prstGeom>
-          <a:noFill/>
-          <a:ln/>
-        </p:spPr>
-        <p:txBody>
-          <a:bodyPr wrap="square" lIns="0" tIns="0" rIns="0" bIns="0" rtlCol="0" anchor="ctr"/>
-          <a:lstStyle/>
-          <a:p>
-            <a:pPr algn="ctr" indent="0" marL="0">
-              <a:buNone/>
-            </a:pPr>
-            <a:r>
-              <a:rPr lang="en-US" sz="1100" b="1" dirty="0">
-                <a:solidFill>
-                  <a:srgbClr val="0EA5E9"/>
-                </a:solidFill>
-                <a:latin typeface="Calibri" pitchFamily="34" charset="0"/>
-                <a:ea typeface="Calibri" pitchFamily="34" charset="-122"/>
-                <a:cs typeface="Calibri" pitchFamily="34" charset="-120"/>
-              </a:rPr>
-              <a:t>1</a:t>
-            </a:r>
-            <a:endParaRPr lang="en-US" sz="1100" dirty="0"/>
-          </a:p>
-        </p:txBody>
-      </p:sp>
-      <p:sp>
-        <p:nvSpPr>
-          <p:cNvPr id="12" name="Text 10"/>
-          <p:cNvSpPr/>
-          <p:nvPr/>
-        </p:nvSpPr>
-        <p:spPr>
-          <a:xfrm>
-            <a:off x="731520" y="2606040"/>
-            <a:ext cx="1417320" cy="274320"/>
-          </a:xfrm>
-          <a:prstGeom prst="rect">
-            <a:avLst/>
-          </a:prstGeom>
-          <a:noFill/>
-          <a:ln/>
-        </p:spPr>
-        <p:txBody>
-          <a:bodyPr wrap="square" lIns="0" tIns="0" rIns="0" bIns="0" rtlCol="0" anchor="ctr"/>
-          <a:lstStyle/>
-          <a:p>
-            <a:pPr algn="ctr" indent="0" marL="0">
-              <a:buNone/>
-            </a:pPr>
-            <a:r>
-              <a:rPr lang="en-US" sz="1200" b="1" dirty="0">
-                <a:solidFill>
-                  <a:srgbClr val="1E293B"/>
-                </a:solidFill>
-                <a:latin typeface="Calibri" pitchFamily="34" charset="0"/>
-                <a:ea typeface="Calibri" pitchFamily="34" charset="-122"/>
-                <a:cs typeface="Calibri" pitchFamily="34" charset="-120"/>
-              </a:rPr>
-              <a:t>Checkout</a:t>
-            </a:r>
-            <a:endParaRPr lang="en-US" sz="1200" dirty="0"/>
-          </a:p>
-        </p:txBody>
-      </p:sp>
-      <p:sp>
-        <p:nvSpPr>
-          <p:cNvPr id="13" name="Text 11"/>
-          <p:cNvSpPr/>
-          <p:nvPr/>
-        </p:nvSpPr>
-        <p:spPr>
-          <a:xfrm>
-            <a:off x="777240" y="2880360"/>
-            <a:ext cx="1325880" cy="594360"/>
-          </a:xfrm>
-          <a:prstGeom prst="rect">
-            <a:avLst/>
-          </a:prstGeom>
-          <a:noFill/>
-          <a:ln/>
-        </p:spPr>
-        <p:txBody>
-          <a:bodyPr wrap="square" lIns="0" tIns="0" rIns="0" bIns="0" rtlCol="0" anchor="ctr"/>
-          <a:lstStyle/>
-          <a:p>
-            <a:pPr algn="ctr" indent="0" marL="0">
-              <a:lnSpc>
-                <a:spcPct val="120000"/>
-              </a:lnSpc>
-              <a:buNone/>
-            </a:pPr>
-            <a:r>
-              <a:rPr lang="en-US" sz="900" dirty="0">
-                <a:solidFill>
-                  <a:srgbClr val="475569"/>
-                </a:solidFill>
-                <a:latin typeface="Consolas" pitchFamily="34" charset="0"/>
-                <a:ea typeface="Consolas" pitchFamily="34" charset="-122"/>
-                <a:cs typeface="Consolas" pitchFamily="34" charset="-120"/>
-              </a:rPr>
-              <a:t>git clone + checkout branch</a:t>
-            </a:r>
-            <a:endParaRPr lang="en-US" sz="900" dirty="0"/>
-          </a:p>
-        </p:txBody>
-      </p:sp>
-      <p:pic>
-        <p:nvPicPr>
-          <p:cNvPr id="14" name="Image 0" descr="preencoded.png"/>
-          <p:cNvPicPr>
-            <a:picLocks noChangeAspect="1"/>
-          </p:cNvPicPr>
-          <p:nvPr/>
-        </p:nvPicPr>
-        <p:blipFill>
-          <a:blip r:embed="rId1"/>
-          <a:stretch>
-            <a:fillRect/>
-          </a:stretch>
-        </p:blipFill>
-        <p:spPr>
-          <a:xfrm>
-            <a:off x="2148840" y="2834640"/>
-            <a:ext cx="155448" cy="155448"/>
-          </a:xfrm>
-          <a:prstGeom prst="rect">
-            <a:avLst/>
-          </a:prstGeom>
-        </p:spPr>
-      </p:pic>
-      <p:sp>
-        <p:nvSpPr>
-          <p:cNvPr id="15" name="Shape 12"/>
-          <p:cNvSpPr/>
-          <p:nvPr/>
-        </p:nvSpPr>
-        <p:spPr>
-          <a:xfrm>
-            <a:off x="2304288" y="2286000"/>
-            <a:ext cx="1417320" cy="1234440"/>
-          </a:xfrm>
-          <a:prstGeom prst="rect">
-            <a:avLst/>
-          </a:prstGeom>
-          <a:solidFill>
-            <a:srgbClr val="FFFFFF"/>
-          </a:solidFill>
-          <a:ln/>
-          <a:effectLst>
-            <a:outerShdw sx="100000" sy="100000" kx="0" ky="0" algn="bl" rotWithShape="0" blurRad="50800" dist="25400" dir="8100000">
-              <a:srgbClr val="000000">
-                <a:alpha val="8000"/>
-              </a:srgbClr>
-            </a:outerShdw>
-          </a:effectLst>
-        </p:spPr>
-      </p:sp>
-      <p:sp>
-        <p:nvSpPr>
-          <p:cNvPr id="16" name="Shape 13"/>
-          <p:cNvSpPr/>
-          <p:nvPr/>
-        </p:nvSpPr>
-        <p:spPr>
-          <a:xfrm>
-            <a:off x="2304288" y="2286000"/>
-            <a:ext cx="1417320" cy="54864"/>
-          </a:xfrm>
-          <a:prstGeom prst="rect">
-            <a:avLst/>
-          </a:prstGeom>
-          <a:solidFill>
-            <a:srgbClr val="0EA5E9"/>
-          </a:solidFill>
-          <a:ln/>
-        </p:spPr>
-      </p:sp>
-      <p:sp>
-        <p:nvSpPr>
-          <p:cNvPr id="17" name="Text 14"/>
-          <p:cNvSpPr/>
-          <p:nvPr/>
-        </p:nvSpPr>
-        <p:spPr>
-          <a:xfrm>
-            <a:off x="2304288" y="2377440"/>
-            <a:ext cx="1417320" cy="228600"/>
-          </a:xfrm>
-          <a:prstGeom prst="rect">
-            <a:avLst/>
-          </a:prstGeom>
-          <a:noFill/>
-          <a:ln/>
-        </p:spPr>
-        <p:txBody>
-          <a:bodyPr wrap="square" lIns="0" tIns="0" rIns="0" bIns="0" rtlCol="0" anchor="ctr"/>
-          <a:lstStyle/>
-          <a:p>
-            <a:pPr algn="ctr" indent="0" marL="0">
-              <a:buNone/>
-            </a:pPr>
-            <a:r>
-              <a:rPr lang="en-US" sz="1100" b="1" dirty="0">
-                <a:solidFill>
-                  <a:srgbClr val="0EA5E9"/>
-                </a:solidFill>
-                <a:latin typeface="Calibri" pitchFamily="34" charset="0"/>
-                <a:ea typeface="Calibri" pitchFamily="34" charset="-122"/>
-                <a:cs typeface="Calibri" pitchFamily="34" charset="-120"/>
-              </a:rPr>
-              <a:t>2</a:t>
-            </a:r>
-            <a:endParaRPr lang="en-US" sz="1100" dirty="0"/>
-          </a:p>
-        </p:txBody>
-      </p:sp>
-      <p:sp>
-        <p:nvSpPr>
-          <p:cNvPr id="18" name="Text 15"/>
-          <p:cNvSpPr/>
-          <p:nvPr/>
-        </p:nvSpPr>
-        <p:spPr>
-          <a:xfrm>
-            <a:off x="2304288" y="2606040"/>
-            <a:ext cx="1417320" cy="274320"/>
-          </a:xfrm>
-          <a:prstGeom prst="rect">
-            <a:avLst/>
-          </a:prstGeom>
-          <a:noFill/>
-          <a:ln/>
-        </p:spPr>
-        <p:txBody>
-          <a:bodyPr wrap="square" lIns="0" tIns="0" rIns="0" bIns="0" rtlCol="0" anchor="ctr"/>
-          <a:lstStyle/>
-          <a:p>
-            <a:pPr algn="ctr" indent="0" marL="0">
-              <a:buNone/>
-            </a:pPr>
-            <a:r>
-              <a:rPr lang="en-US" sz="1200" b="1" dirty="0">
-                <a:solidFill>
-                  <a:srgbClr val="1E293B"/>
-                </a:solidFill>
-                <a:latin typeface="Calibri" pitchFamily="34" charset="0"/>
-                <a:ea typeface="Calibri" pitchFamily="34" charset="-122"/>
-                <a:cs typeface="Calibri" pitchFamily="34" charset="-120"/>
-              </a:rPr>
-              <a:t>Run Agent</a:t>
-            </a:r>
-            <a:endParaRPr lang="en-US" sz="1200" dirty="0"/>
-          </a:p>
-        </p:txBody>
-      </p:sp>
-      <p:sp>
-        <p:nvSpPr>
-          <p:cNvPr id="19" name="Text 16"/>
-          <p:cNvSpPr/>
-          <p:nvPr/>
-        </p:nvSpPr>
-        <p:spPr>
-          <a:xfrm>
-            <a:off x="2350008" y="2880360"/>
-            <a:ext cx="1325880" cy="594360"/>
-          </a:xfrm>
-          <a:prstGeom prst="rect">
-            <a:avLst/>
-          </a:prstGeom>
-          <a:noFill/>
-          <a:ln/>
-        </p:spPr>
-        <p:txBody>
-          <a:bodyPr wrap="square" lIns="0" tIns="0" rIns="0" bIns="0" rtlCol="0" anchor="ctr"/>
-          <a:lstStyle/>
-          <a:p>
-            <a:pPr algn="ctr" indent="0" marL="0">
-              <a:lnSpc>
-                <a:spcPct val="120000"/>
-              </a:lnSpc>
-              <a:buNone/>
-            </a:pPr>
-            <a:r>
-              <a:rPr lang="en-US" sz="900" dirty="0">
-                <a:solidFill>
-                  <a:srgbClr val="475569"/>
-                </a:solidFill>
-                <a:latin typeface="Consolas" pitchFamily="34" charset="0"/>
-                <a:ea typeface="Consolas" pitchFamily="34" charset="-122"/>
-                <a:cs typeface="Consolas" pitchFamily="34" charset="-120"/>
-              </a:rPr>
-              <a:t>copilot -p "Review staged"</a:t>
-            </a:r>
-            <a:endParaRPr lang="en-US" sz="900" dirty="0"/>
-          </a:p>
-        </p:txBody>
-      </p:sp>
-      <p:pic>
-        <p:nvPicPr>
-          <p:cNvPr id="20" name="Image 1" descr="preencoded.png"/>
-          <p:cNvPicPr>
-            <a:picLocks noChangeAspect="1"/>
-          </p:cNvPicPr>
-          <p:nvPr/>
-        </p:nvPicPr>
-        <p:blipFill>
-          <a:blip r:embed="rId2"/>
-          <a:stretch>
-            <a:fillRect/>
-          </a:stretch>
-        </p:blipFill>
-        <p:spPr>
-          <a:xfrm>
-            <a:off x="3721608" y="2834640"/>
-            <a:ext cx="155448" cy="155448"/>
-          </a:xfrm>
-          <a:prstGeom prst="rect">
-            <a:avLst/>
-          </a:prstGeom>
-        </p:spPr>
-      </p:pic>
-      <p:sp>
-        <p:nvSpPr>
-          <p:cNvPr id="21" name="Shape 17"/>
-          <p:cNvSpPr/>
-          <p:nvPr/>
-        </p:nvSpPr>
-        <p:spPr>
-          <a:xfrm>
-            <a:off x="3877056" y="2286000"/>
-            <a:ext cx="1417320" cy="1234440"/>
-          </a:xfrm>
-          <a:prstGeom prst="rect">
-            <a:avLst/>
-          </a:prstGeom>
-          <a:solidFill>
-            <a:srgbClr val="FFFFFF"/>
-          </a:solidFill>
-          <a:ln/>
-          <a:effectLst>
-            <a:outerShdw sx="100000" sy="100000" kx="0" ky="0" algn="bl" rotWithShape="0" blurRad="50800" dist="25400" dir="8100000">
-              <a:srgbClr val="000000">
-                <a:alpha val="8000"/>
-              </a:srgbClr>
-            </a:outerShdw>
-          </a:effectLst>
-        </p:spPr>
-      </p:sp>
-      <p:sp>
-        <p:nvSpPr>
-          <p:cNvPr id="22" name="Shape 18"/>
-          <p:cNvSpPr/>
-          <p:nvPr/>
-        </p:nvSpPr>
-        <p:spPr>
-          <a:xfrm>
-            <a:off x="3877056" y="2286000"/>
-            <a:ext cx="1417320" cy="54864"/>
-          </a:xfrm>
-          <a:prstGeom prst="rect">
-            <a:avLst/>
-          </a:prstGeom>
-          <a:solidFill>
-            <a:srgbClr val="0EA5E9"/>
-          </a:solidFill>
-          <a:ln/>
-        </p:spPr>
-      </p:sp>
-      <p:sp>
-        <p:nvSpPr>
-          <p:cNvPr id="23" name="Text 19"/>
-          <p:cNvSpPr/>
-          <p:nvPr/>
-        </p:nvSpPr>
-        <p:spPr>
-          <a:xfrm>
-            <a:off x="3877056" y="2377440"/>
-            <a:ext cx="1417320" cy="228600"/>
-          </a:xfrm>
-          <a:prstGeom prst="rect">
-            <a:avLst/>
-          </a:prstGeom>
-          <a:noFill/>
-          <a:ln/>
-        </p:spPr>
-        <p:txBody>
-          <a:bodyPr wrap="square" lIns="0" tIns="0" rIns="0" bIns="0" rtlCol="0" anchor="ctr"/>
-          <a:lstStyle/>
-          <a:p>
-            <a:pPr algn="ctr" indent="0" marL="0">
-              <a:buNone/>
-            </a:pPr>
-            <a:r>
-              <a:rPr lang="en-US" sz="1100" b="1" dirty="0">
-                <a:solidFill>
-                  <a:srgbClr val="0EA5E9"/>
-                </a:solidFill>
-                <a:latin typeface="Calibri" pitchFamily="34" charset="0"/>
-                <a:ea typeface="Calibri" pitchFamily="34" charset="-122"/>
-                <a:cs typeface="Calibri" pitchFamily="34" charset="-120"/>
-              </a:rPr>
-              <a:t>3</a:t>
-            </a:r>
-            <a:endParaRPr lang="en-US" sz="1100" dirty="0"/>
-          </a:p>
-        </p:txBody>
-      </p:sp>
-      <p:sp>
-        <p:nvSpPr>
-          <p:cNvPr id="24" name="Text 20"/>
-          <p:cNvSpPr/>
-          <p:nvPr/>
-        </p:nvSpPr>
-        <p:spPr>
-          <a:xfrm>
-            <a:off x="3877056" y="2606040"/>
-            <a:ext cx="1417320" cy="274320"/>
-          </a:xfrm>
-          <a:prstGeom prst="rect">
-            <a:avLst/>
-          </a:prstGeom>
-          <a:noFill/>
-          <a:ln/>
-        </p:spPr>
-        <p:txBody>
-          <a:bodyPr wrap="square" lIns="0" tIns="0" rIns="0" bIns="0" rtlCol="0" anchor="ctr"/>
-          <a:lstStyle/>
-          <a:p>
-            <a:pPr algn="ctr" indent="0" marL="0">
-              <a:buNone/>
-            </a:pPr>
-            <a:r>
-              <a:rPr lang="en-US" sz="1200" b="1" dirty="0">
-                <a:solidFill>
-                  <a:srgbClr val="1E293B"/>
-                </a:solidFill>
-                <a:latin typeface="Calibri" pitchFamily="34" charset="0"/>
-                <a:ea typeface="Calibri" pitchFamily="34" charset="-122"/>
-                <a:cs typeface="Calibri" pitchFamily="34" charset="-120"/>
-              </a:rPr>
-              <a:t>Apply</a:t>
-            </a:r>
-            <a:endParaRPr lang="en-US" sz="1200" dirty="0"/>
-          </a:p>
-        </p:txBody>
-      </p:sp>
-      <p:sp>
-        <p:nvSpPr>
-          <p:cNvPr id="25" name="Text 21"/>
-          <p:cNvSpPr/>
-          <p:nvPr/>
-        </p:nvSpPr>
-        <p:spPr>
-          <a:xfrm>
-            <a:off x="3922776" y="2880360"/>
-            <a:ext cx="1325880" cy="594360"/>
-          </a:xfrm>
-          <a:prstGeom prst="rect">
-            <a:avLst/>
-          </a:prstGeom>
-          <a:noFill/>
-          <a:ln/>
-        </p:spPr>
-        <p:txBody>
-          <a:bodyPr wrap="square" lIns="0" tIns="0" rIns="0" bIns="0" rtlCol="0" anchor="ctr"/>
-          <a:lstStyle/>
-          <a:p>
-            <a:pPr algn="ctr" indent="0" marL="0">
-              <a:lnSpc>
-                <a:spcPct val="120000"/>
-              </a:lnSpc>
-              <a:buNone/>
-            </a:pPr>
-            <a:r>
-              <a:rPr lang="en-US" sz="900" dirty="0">
-                <a:solidFill>
-                  <a:srgbClr val="475569"/>
-                </a:solidFill>
-                <a:latin typeface="Consolas" pitchFamily="34" charset="0"/>
-                <a:ea typeface="Consolas" pitchFamily="34" charset="-122"/>
-                <a:cs typeface="Consolas" pitchFamily="34" charset="-120"/>
-              </a:rPr>
-              <a:t>Write changes / annotations</a:t>
-            </a:r>
-            <a:endParaRPr lang="en-US" sz="900" dirty="0"/>
-          </a:p>
-        </p:txBody>
-      </p:sp>
-      <p:pic>
-        <p:nvPicPr>
-          <p:cNvPr id="26" name="Image 2" descr="preencoded.png"/>
-          <p:cNvPicPr>
-            <a:picLocks noChangeAspect="1"/>
-          </p:cNvPicPr>
-          <p:nvPr/>
-        </p:nvPicPr>
-        <p:blipFill>
-          <a:blip r:embed="rId3"/>
-          <a:stretch>
-            <a:fillRect/>
-          </a:stretch>
-        </p:blipFill>
-        <p:spPr>
-          <a:xfrm>
-            <a:off x="5294376" y="2834640"/>
-            <a:ext cx="155448" cy="155448"/>
-          </a:xfrm>
-          <a:prstGeom prst="rect">
-            <a:avLst/>
-          </a:prstGeom>
-        </p:spPr>
-      </p:pic>
-      <p:sp>
-        <p:nvSpPr>
-          <p:cNvPr id="27" name="Shape 22"/>
-          <p:cNvSpPr/>
-          <p:nvPr/>
-        </p:nvSpPr>
-        <p:spPr>
-          <a:xfrm>
-            <a:off x="5449824" y="2286000"/>
-            <a:ext cx="1417320" cy="1234440"/>
-          </a:xfrm>
-          <a:prstGeom prst="rect">
-            <a:avLst/>
-          </a:prstGeom>
-          <a:solidFill>
-            <a:srgbClr val="FFFFFF"/>
-          </a:solidFill>
-          <a:ln/>
-          <a:effectLst>
-            <a:outerShdw sx="100000" sy="100000" kx="0" ky="0" algn="bl" rotWithShape="0" blurRad="50800" dist="25400" dir="8100000">
-              <a:srgbClr val="000000">
-                <a:alpha val="8000"/>
-              </a:srgbClr>
-            </a:outerShdw>
-          </a:effectLst>
-        </p:spPr>
-      </p:sp>
-      <p:sp>
-        <p:nvSpPr>
-          <p:cNvPr id="28" name="Shape 23"/>
-          <p:cNvSpPr/>
-          <p:nvPr/>
-        </p:nvSpPr>
-        <p:spPr>
-          <a:xfrm>
-            <a:off x="5449824" y="2286000"/>
-            <a:ext cx="1417320" cy="54864"/>
-          </a:xfrm>
-          <a:prstGeom prst="rect">
-            <a:avLst/>
-          </a:prstGeom>
-          <a:solidFill>
-            <a:srgbClr val="0EA5E9"/>
-          </a:solidFill>
-          <a:ln/>
-        </p:spPr>
-      </p:sp>
-      <p:sp>
-        <p:nvSpPr>
-          <p:cNvPr id="29" name="Text 24"/>
-          <p:cNvSpPr/>
-          <p:nvPr/>
-        </p:nvSpPr>
-        <p:spPr>
-          <a:xfrm>
-            <a:off x="5449824" y="2377440"/>
-            <a:ext cx="1417320" cy="228600"/>
-          </a:xfrm>
-          <a:prstGeom prst="rect">
-            <a:avLst/>
-          </a:prstGeom>
-          <a:noFill/>
-          <a:ln/>
-        </p:spPr>
-        <p:txBody>
-          <a:bodyPr wrap="square" lIns="0" tIns="0" rIns="0" bIns="0" rtlCol="0" anchor="ctr"/>
-          <a:lstStyle/>
-          <a:p>
-            <a:pPr algn="ctr" indent="0" marL="0">
-              <a:buNone/>
-            </a:pPr>
-            <a:r>
-              <a:rPr lang="en-US" sz="1100" b="1" dirty="0">
-                <a:solidFill>
-                  <a:srgbClr val="0EA5E9"/>
-                </a:solidFill>
-                <a:latin typeface="Calibri" pitchFamily="34" charset="0"/>
-                <a:ea typeface="Calibri" pitchFamily="34" charset="-122"/>
-                <a:cs typeface="Calibri" pitchFamily="34" charset="-120"/>
-              </a:rPr>
-              <a:t>4</a:t>
-            </a:r>
-            <a:endParaRPr lang="en-US" sz="1100" dirty="0"/>
-          </a:p>
-        </p:txBody>
-      </p:sp>
-      <p:sp>
-        <p:nvSpPr>
-          <p:cNvPr id="30" name="Text 25"/>
-          <p:cNvSpPr/>
-          <p:nvPr/>
-        </p:nvSpPr>
-        <p:spPr>
-          <a:xfrm>
-            <a:off x="5449824" y="2606040"/>
-            <a:ext cx="1417320" cy="274320"/>
-          </a:xfrm>
-          <a:prstGeom prst="rect">
-            <a:avLst/>
-          </a:prstGeom>
-          <a:noFill/>
-          <a:ln/>
-        </p:spPr>
-        <p:txBody>
-          <a:bodyPr wrap="square" lIns="0" tIns="0" rIns="0" bIns="0" rtlCol="0" anchor="ctr"/>
-          <a:lstStyle/>
-          <a:p>
-            <a:pPr algn="ctr" indent="0" marL="0">
-              <a:buNone/>
-            </a:pPr>
-            <a:r>
-              <a:rPr lang="en-US" sz="1200" b="1" dirty="0">
-                <a:solidFill>
-                  <a:srgbClr val="1E293B"/>
-                </a:solidFill>
-                <a:latin typeface="Calibri" pitchFamily="34" charset="0"/>
-                <a:ea typeface="Calibri" pitchFamily="34" charset="-122"/>
-                <a:cs typeface="Calibri" pitchFamily="34" charset="-120"/>
-              </a:rPr>
-              <a:t>Test</a:t>
-            </a:r>
-            <a:endParaRPr lang="en-US" sz="1200" dirty="0"/>
-          </a:p>
-        </p:txBody>
-      </p:sp>
-      <p:sp>
-        <p:nvSpPr>
-          <p:cNvPr id="31" name="Text 26"/>
-          <p:cNvSpPr/>
-          <p:nvPr/>
-        </p:nvSpPr>
-        <p:spPr>
-          <a:xfrm>
-            <a:off x="5495544" y="2880360"/>
-            <a:ext cx="1325880" cy="594360"/>
-          </a:xfrm>
-          <a:prstGeom prst="rect">
-            <a:avLst/>
-          </a:prstGeom>
-          <a:noFill/>
-          <a:ln/>
-        </p:spPr>
-        <p:txBody>
-          <a:bodyPr wrap="square" lIns="0" tIns="0" rIns="0" bIns="0" rtlCol="0" anchor="ctr"/>
-          <a:lstStyle/>
-          <a:p>
-            <a:pPr algn="ctr" indent="0" marL="0">
-              <a:lnSpc>
-                <a:spcPct val="120000"/>
-              </a:lnSpc>
-              <a:buNone/>
-            </a:pPr>
-            <a:r>
-              <a:rPr lang="en-US" sz="900" dirty="0">
-                <a:solidFill>
-                  <a:srgbClr val="475569"/>
-                </a:solidFill>
-                <a:latin typeface="Consolas" pitchFamily="34" charset="0"/>
-                <a:ea typeface="Consolas" pitchFamily="34" charset="-122"/>
-                <a:cs typeface="Consolas" pitchFamily="34" charset="-120"/>
-              </a:rPr>
-              <a:t>dotnet test / npm test</a:t>
-            </a:r>
-            <a:endParaRPr lang="en-US" sz="900" dirty="0"/>
-          </a:p>
-        </p:txBody>
-      </p:sp>
-      <p:pic>
-        <p:nvPicPr>
-          <p:cNvPr id="32" name="Image 3" descr="preencoded.png"/>
-          <p:cNvPicPr>
-            <a:picLocks noChangeAspect="1"/>
-          </p:cNvPicPr>
-          <p:nvPr/>
-        </p:nvPicPr>
-        <p:blipFill>
-          <a:blip r:embed="rId4"/>
-          <a:stretch>
-            <a:fillRect/>
-          </a:stretch>
-        </p:blipFill>
-        <p:spPr>
-          <a:xfrm>
-            <a:off x="6867144" y="2834640"/>
-            <a:ext cx="155448" cy="155448"/>
-          </a:xfrm>
-          <a:prstGeom prst="rect">
-            <a:avLst/>
-          </a:prstGeom>
-        </p:spPr>
-      </p:pic>
-      <p:sp>
-        <p:nvSpPr>
-          <p:cNvPr id="33" name="Shape 27"/>
-          <p:cNvSpPr/>
-          <p:nvPr/>
-        </p:nvSpPr>
-        <p:spPr>
-          <a:xfrm>
-            <a:off x="7022592" y="2286000"/>
-            <a:ext cx="1417320" cy="1234440"/>
-          </a:xfrm>
-          <a:prstGeom prst="rect">
-            <a:avLst/>
-          </a:prstGeom>
-          <a:solidFill>
-            <a:srgbClr val="FFFFFF"/>
-          </a:solidFill>
-          <a:ln/>
-          <a:effectLst>
-            <a:outerShdw sx="100000" sy="100000" kx="0" ky="0" algn="bl" rotWithShape="0" blurRad="50800" dist="25400" dir="8100000">
-              <a:srgbClr val="000000">
-                <a:alpha val="8000"/>
-              </a:srgbClr>
-            </a:outerShdw>
-          </a:effectLst>
-        </p:spPr>
-      </p:sp>
-      <p:sp>
-        <p:nvSpPr>
-          <p:cNvPr id="34" name="Shape 28"/>
-          <p:cNvSpPr/>
-          <p:nvPr/>
-        </p:nvSpPr>
-        <p:spPr>
-          <a:xfrm>
-            <a:off x="7022592" y="2286000"/>
-            <a:ext cx="1417320" cy="54864"/>
-          </a:xfrm>
-          <a:prstGeom prst="rect">
-            <a:avLst/>
-          </a:prstGeom>
-          <a:solidFill>
-            <a:srgbClr val="0EA5E9"/>
-          </a:solidFill>
-          <a:ln/>
-        </p:spPr>
-      </p:sp>
-      <p:sp>
-        <p:nvSpPr>
-          <p:cNvPr id="35" name="Text 29"/>
-          <p:cNvSpPr/>
-          <p:nvPr/>
-        </p:nvSpPr>
-        <p:spPr>
-          <a:xfrm>
-            <a:off x="7022592" y="2377440"/>
-            <a:ext cx="1417320" cy="228600"/>
-          </a:xfrm>
-          <a:prstGeom prst="rect">
-            <a:avLst/>
-          </a:prstGeom>
-          <a:noFill/>
-          <a:ln/>
-        </p:spPr>
-        <p:txBody>
-          <a:bodyPr wrap="square" lIns="0" tIns="0" rIns="0" bIns="0" rtlCol="0" anchor="ctr"/>
-          <a:lstStyle/>
-          <a:p>
-            <a:pPr algn="ctr" indent="0" marL="0">
-              <a:buNone/>
-            </a:pPr>
-            <a:r>
-              <a:rPr lang="en-US" sz="1100" b="1" dirty="0">
-                <a:solidFill>
-                  <a:srgbClr val="0EA5E9"/>
-                </a:solidFill>
-                <a:latin typeface="Calibri" pitchFamily="34" charset="0"/>
-                <a:ea typeface="Calibri" pitchFamily="34" charset="-122"/>
-                <a:cs typeface="Calibri" pitchFamily="34" charset="-120"/>
-              </a:rPr>
-              <a:t>5</a:t>
-            </a:r>
-            <a:endParaRPr lang="en-US" sz="1100" dirty="0"/>
-          </a:p>
-        </p:txBody>
-      </p:sp>
-      <p:sp>
-        <p:nvSpPr>
-          <p:cNvPr id="36" name="Text 30"/>
-          <p:cNvSpPr/>
-          <p:nvPr/>
-        </p:nvSpPr>
-        <p:spPr>
-          <a:xfrm>
-            <a:off x="7022592" y="2606040"/>
-            <a:ext cx="1417320" cy="274320"/>
-          </a:xfrm>
-          <a:prstGeom prst="rect">
-            <a:avLst/>
-          </a:prstGeom>
-          <a:noFill/>
-          <a:ln/>
-        </p:spPr>
-        <p:txBody>
-          <a:bodyPr wrap="square" lIns="0" tIns="0" rIns="0" bIns="0" rtlCol="0" anchor="ctr"/>
-          <a:lstStyle/>
-          <a:p>
-            <a:pPr algn="ctr" indent="0" marL="0">
-              <a:buNone/>
-            </a:pPr>
-            <a:r>
-              <a:rPr lang="en-US" sz="1200" b="1" dirty="0">
-                <a:solidFill>
-                  <a:srgbClr val="1E293B"/>
-                </a:solidFill>
-                <a:latin typeface="Calibri" pitchFamily="34" charset="0"/>
-                <a:ea typeface="Calibri" pitchFamily="34" charset="-122"/>
-                <a:cs typeface="Calibri" pitchFamily="34" charset="-120"/>
-              </a:rPr>
-              <a:t>Ship</a:t>
-            </a:r>
-            <a:endParaRPr lang="en-US" sz="1200" dirty="0"/>
-          </a:p>
-        </p:txBody>
-      </p:sp>
-      <p:sp>
-        <p:nvSpPr>
-          <p:cNvPr id="37" name="Text 31"/>
-          <p:cNvSpPr/>
-          <p:nvPr/>
-        </p:nvSpPr>
-        <p:spPr>
-          <a:xfrm>
-            <a:off x="7068312" y="2880360"/>
-            <a:ext cx="1325880" cy="594360"/>
-          </a:xfrm>
-          <a:prstGeom prst="rect">
-            <a:avLst/>
-          </a:prstGeom>
-          <a:noFill/>
-          <a:ln/>
-        </p:spPr>
-        <p:txBody>
-          <a:bodyPr wrap="square" lIns="0" tIns="0" rIns="0" bIns="0" rtlCol="0" anchor="ctr"/>
-          <a:lstStyle/>
-          <a:p>
-            <a:pPr algn="ctr" indent="0" marL="0">
-              <a:lnSpc>
-                <a:spcPct val="120000"/>
-              </a:lnSpc>
-              <a:buNone/>
-            </a:pPr>
-            <a:r>
-              <a:rPr lang="en-US" sz="900" dirty="0">
-                <a:solidFill>
-                  <a:srgbClr val="475569"/>
-                </a:solidFill>
-                <a:latin typeface="Consolas" pitchFamily="34" charset="0"/>
-                <a:ea typeface="Consolas" pitchFamily="34" charset="-122"/>
-                <a:cs typeface="Consolas" pitchFamily="34" charset="-120"/>
-              </a:rPr>
-              <a:t>commit or fail the build</a:t>
-            </a:r>
-            <a:endParaRPr lang="en-US" sz="900" dirty="0"/>
-          </a:p>
-        </p:txBody>
-      </p:sp>
-      <p:sp>
-        <p:nvSpPr>
-          <p:cNvPr id="38" name="Text 32"/>
-          <p:cNvSpPr/>
-          <p:nvPr/>
-        </p:nvSpPr>
-        <p:spPr>
-          <a:xfrm>
-            <a:off x="731520" y="3794760"/>
-            <a:ext cx="4572000" cy="228600"/>
-          </a:xfrm>
-          <a:prstGeom prst="rect">
-            <a:avLst/>
-          </a:prstGeom>
-          <a:noFill/>
-          <a:ln/>
-        </p:spPr>
-        <p:txBody>
-          <a:bodyPr wrap="square" lIns="0" tIns="0" rIns="0" bIns="0" rtlCol="0" anchor="ctr"/>
-          <a:lstStyle/>
-          <a:p>
-            <a:pPr indent="0" marL="0">
-              <a:buNone/>
-            </a:pPr>
-            <a:r>
-              <a:rPr lang="en-US" sz="1000" b="1" spc="200" kern="0" dirty="0">
-                <a:solidFill>
-                  <a:srgbClr val="0EA5E9"/>
-                </a:solidFill>
-                <a:latin typeface="Calibri" pitchFamily="34" charset="0"/>
-                <a:ea typeface="Calibri" pitchFamily="34" charset="-122"/>
-                <a:cs typeface="Calibri" pitchFamily="34" charset="-120"/>
-              </a:rPr>
-              <a:t>OTHER AUTOMATION EXAMPLES</a:t>
-            </a:r>
-            <a:endParaRPr lang="en-US" sz="1000" dirty="0"/>
-          </a:p>
-        </p:txBody>
-      </p:sp>
-      <p:sp>
-        <p:nvSpPr>
-          <p:cNvPr id="39" name="Shape 33"/>
-          <p:cNvSpPr/>
-          <p:nvPr/>
-        </p:nvSpPr>
-        <p:spPr>
-          <a:xfrm>
-            <a:off x="731520" y="4069080"/>
-            <a:ext cx="1828800" cy="731520"/>
-          </a:xfrm>
-          <a:prstGeom prst="rect">
-            <a:avLst/>
-          </a:prstGeom>
-          <a:solidFill>
-            <a:srgbClr val="FFFFFF"/>
-          </a:solidFill>
-          <a:ln/>
-          <a:effectLst>
-            <a:outerShdw sx="100000" sy="100000" kx="0" ky="0" algn="bl" rotWithShape="0" blurRad="50800" dist="25400" dir="8100000">
-              <a:srgbClr val="000000">
-                <a:alpha val="8000"/>
-              </a:srgbClr>
-            </a:outerShdw>
-          </a:effectLst>
-        </p:spPr>
-      </p:sp>
-      <p:sp>
-        <p:nvSpPr>
-          <p:cNvPr id="40" name="Shape 34"/>
-          <p:cNvSpPr/>
-          <p:nvPr/>
-        </p:nvSpPr>
-        <p:spPr>
-          <a:xfrm>
-            <a:off x="731520" y="4069080"/>
-            <a:ext cx="64008" cy="731520"/>
-          </a:xfrm>
-          <a:prstGeom prst="rect">
-            <a:avLst/>
-          </a:prstGeom>
-          <a:solidFill>
-            <a:srgbClr val="0EA5E9"/>
-          </a:solidFill>
-          <a:ln/>
-        </p:spPr>
-      </p:sp>
-      <p:sp>
-        <p:nvSpPr>
-          <p:cNvPr id="41" name="Text 35"/>
-          <p:cNvSpPr/>
-          <p:nvPr/>
-        </p:nvSpPr>
-        <p:spPr>
-          <a:xfrm>
-            <a:off x="868680" y="4114800"/>
-            <a:ext cx="1645920" cy="274320"/>
-          </a:xfrm>
-          <a:prstGeom prst="rect">
-            <a:avLst/>
-          </a:prstGeom>
-          <a:noFill/>
-          <a:ln/>
-        </p:spPr>
-        <p:txBody>
-          <a:bodyPr wrap="square" lIns="0" tIns="0" rIns="0" bIns="0" rtlCol="0" anchor="ctr"/>
-          <a:lstStyle/>
-          <a:p>
-            <a:pPr indent="0" marL="0">
-              <a:buNone/>
-            </a:pPr>
-            <a:r>
-              <a:rPr lang="en-US" sz="1100" b="1" dirty="0">
-                <a:solidFill>
-                  <a:srgbClr val="1E293B"/>
-                </a:solidFill>
-                <a:latin typeface="Calibri" pitchFamily="34" charset="0"/>
-                <a:ea typeface="Calibri" pitchFamily="34" charset="-122"/>
-                <a:cs typeface="Calibri" pitchFamily="34" charset="-120"/>
-              </a:rPr>
-              <a:t>Commit Messages</a:t>
-            </a:r>
-            <a:endParaRPr lang="en-US" sz="1100" dirty="0"/>
-          </a:p>
-        </p:txBody>
-      </p:sp>
-      <p:sp>
-        <p:nvSpPr>
-          <p:cNvPr id="42" name="Text 36"/>
-          <p:cNvSpPr/>
-          <p:nvPr/>
-        </p:nvSpPr>
-        <p:spPr>
-          <a:xfrm>
-            <a:off x="868680" y="4389120"/>
-            <a:ext cx="1645920" cy="365760"/>
-          </a:xfrm>
-          <a:prstGeom prst="rect">
-            <a:avLst/>
-          </a:prstGeom>
-          <a:noFill/>
-          <a:ln/>
-        </p:spPr>
-        <p:txBody>
-          <a:bodyPr wrap="square" lIns="0" tIns="0" rIns="0" bIns="0" rtlCol="0" anchor="ctr"/>
-          <a:lstStyle/>
-          <a:p>
-            <a:pPr indent="0" marL="0">
-              <a:buNone/>
-            </a:pPr>
-            <a:r>
-              <a:rPr lang="en-US" sz="900" dirty="0">
-                <a:solidFill>
-                  <a:srgbClr val="475569"/>
-                </a:solidFill>
-                <a:latin typeface="Consolas" pitchFamily="34" charset="0"/>
-                <a:ea typeface="Consolas" pitchFamily="34" charset="-122"/>
-                <a:cs typeface="Consolas" pitchFamily="34" charset="-120"/>
-              </a:rPr>
-              <a:t>copilot -p "..." &lt; diff</a:t>
-            </a:r>
-            <a:endParaRPr lang="en-US" sz="900" dirty="0"/>
-          </a:p>
-        </p:txBody>
-      </p:sp>
-      <p:sp>
-        <p:nvSpPr>
-          <p:cNvPr id="43" name="Shape 37"/>
-          <p:cNvSpPr/>
-          <p:nvPr/>
-        </p:nvSpPr>
-        <p:spPr>
-          <a:xfrm>
-            <a:off x="2697480" y="4069080"/>
-            <a:ext cx="1828800" cy="731520"/>
-          </a:xfrm>
-          <a:prstGeom prst="rect">
-            <a:avLst/>
-          </a:prstGeom>
-          <a:solidFill>
-            <a:srgbClr val="FFFFFF"/>
-          </a:solidFill>
-          <a:ln/>
-          <a:effectLst>
-            <a:outerShdw sx="100000" sy="100000" kx="0" ky="0" algn="bl" rotWithShape="0" blurRad="50800" dist="25400" dir="8100000">
-              <a:srgbClr val="000000">
-                <a:alpha val="8000"/>
-              </a:srgbClr>
-            </a:outerShdw>
-          </a:effectLst>
-        </p:spPr>
-      </p:sp>
-      <p:sp>
-        <p:nvSpPr>
-          <p:cNvPr id="44" name="Shape 38"/>
-          <p:cNvSpPr/>
-          <p:nvPr/>
-        </p:nvSpPr>
-        <p:spPr>
-          <a:xfrm>
-            <a:off x="2697480" y="4069080"/>
-            <a:ext cx="64008" cy="731520"/>
-          </a:xfrm>
-          <a:prstGeom prst="rect">
-            <a:avLst/>
-          </a:prstGeom>
-          <a:solidFill>
-            <a:srgbClr val="0EA5E9"/>
-          </a:solidFill>
-          <a:ln/>
-        </p:spPr>
-      </p:sp>
-      <p:sp>
-        <p:nvSpPr>
-          <p:cNvPr id="45" name="Text 39"/>
-          <p:cNvSpPr/>
-          <p:nvPr/>
-        </p:nvSpPr>
-        <p:spPr>
-          <a:xfrm>
-            <a:off x="2834640" y="4114800"/>
-            <a:ext cx="1645920" cy="274320"/>
-          </a:xfrm>
-          <a:prstGeom prst="rect">
-            <a:avLst/>
-          </a:prstGeom>
-          <a:noFill/>
-          <a:ln/>
-        </p:spPr>
-        <p:txBody>
-          <a:bodyPr wrap="square" lIns="0" tIns="0" rIns="0" bIns="0" rtlCol="0" anchor="ctr"/>
-          <a:lstStyle/>
-          <a:p>
-            <a:pPr indent="0" marL="0">
-              <a:buNone/>
-            </a:pPr>
-            <a:r>
-              <a:rPr lang="en-US" sz="1100" b="1" dirty="0">
-                <a:solidFill>
-                  <a:srgbClr val="1E293B"/>
-                </a:solidFill>
-                <a:latin typeface="Calibri" pitchFamily="34" charset="0"/>
-                <a:ea typeface="Calibri" pitchFamily="34" charset="-122"/>
-                <a:cs typeface="Calibri" pitchFamily="34" charset="-120"/>
-              </a:rPr>
-              <a:t>PR Descriptions</a:t>
-            </a:r>
-            <a:endParaRPr lang="en-US" sz="1100" dirty="0"/>
-          </a:p>
-        </p:txBody>
-      </p:sp>
-      <p:sp>
-        <p:nvSpPr>
-          <p:cNvPr id="46" name="Text 40"/>
-          <p:cNvSpPr/>
-          <p:nvPr/>
-        </p:nvSpPr>
-        <p:spPr>
-          <a:xfrm>
-            <a:off x="2834640" y="4389120"/>
-            <a:ext cx="1645920" cy="365760"/>
-          </a:xfrm>
-          <a:prstGeom prst="rect">
-            <a:avLst/>
-          </a:prstGeom>
-          <a:noFill/>
-          <a:ln/>
-        </p:spPr>
-        <p:txBody>
-          <a:bodyPr wrap="square" lIns="0" tIns="0" rIns="0" bIns="0" rtlCol="0" anchor="ctr"/>
-          <a:lstStyle/>
-          <a:p>
-            <a:pPr indent="0" marL="0">
-              <a:buNone/>
-            </a:pPr>
-            <a:r>
-              <a:rPr lang="en-US" sz="900" dirty="0">
-                <a:solidFill>
-                  <a:srgbClr val="475569"/>
-                </a:solidFill>
-                <a:latin typeface="Consolas" pitchFamily="34" charset="0"/>
-                <a:ea typeface="Consolas" pitchFamily="34" charset="-122"/>
-                <a:cs typeface="Consolas" pitchFamily="34" charset="-120"/>
-              </a:rPr>
-              <a:t>git log | copilot -p "..."</a:t>
-            </a:r>
-            <a:endParaRPr lang="en-US" sz="900" dirty="0"/>
-          </a:p>
-        </p:txBody>
-      </p:sp>
-      <p:sp>
-        <p:nvSpPr>
-          <p:cNvPr id="47" name="Shape 41"/>
-          <p:cNvSpPr/>
-          <p:nvPr/>
-        </p:nvSpPr>
-        <p:spPr>
-          <a:xfrm>
-            <a:off x="4663440" y="4069080"/>
-            <a:ext cx="1828800" cy="731520"/>
-          </a:xfrm>
-          <a:prstGeom prst="rect">
-            <a:avLst/>
-          </a:prstGeom>
-          <a:solidFill>
-            <a:srgbClr val="FFFFFF"/>
-          </a:solidFill>
-          <a:ln/>
-          <a:effectLst>
-            <a:outerShdw sx="100000" sy="100000" kx="0" ky="0" algn="bl" rotWithShape="0" blurRad="50800" dist="25400" dir="8100000">
-              <a:srgbClr val="000000">
-                <a:alpha val="8000"/>
-              </a:srgbClr>
-            </a:outerShdw>
-          </a:effectLst>
-        </p:spPr>
-      </p:sp>
-      <p:sp>
-        <p:nvSpPr>
-          <p:cNvPr id="48" name="Shape 42"/>
-          <p:cNvSpPr/>
-          <p:nvPr/>
-        </p:nvSpPr>
-        <p:spPr>
-          <a:xfrm>
-            <a:off x="4663440" y="4069080"/>
-            <a:ext cx="64008" cy="731520"/>
-          </a:xfrm>
-          <a:prstGeom prst="rect">
-            <a:avLst/>
-          </a:prstGeom>
-          <a:solidFill>
-            <a:srgbClr val="0EA5E9"/>
-          </a:solidFill>
-          <a:ln/>
-        </p:spPr>
-      </p:sp>
-      <p:sp>
-        <p:nvSpPr>
-          <p:cNvPr id="49" name="Text 43"/>
-          <p:cNvSpPr/>
-          <p:nvPr/>
-        </p:nvSpPr>
-        <p:spPr>
-          <a:xfrm>
-            <a:off x="4800600" y="4114800"/>
-            <a:ext cx="1645920" cy="274320"/>
-          </a:xfrm>
-          <a:prstGeom prst="rect">
-            <a:avLst/>
-          </a:prstGeom>
-          <a:noFill/>
-          <a:ln/>
-        </p:spPr>
-        <p:txBody>
-          <a:bodyPr wrap="square" lIns="0" tIns="0" rIns="0" bIns="0" rtlCol="0" anchor="ctr"/>
-          <a:lstStyle/>
-          <a:p>
-            <a:pPr indent="0" marL="0">
-              <a:buNone/>
-            </a:pPr>
-            <a:r>
-              <a:rPr lang="en-US" sz="1100" b="1" dirty="0">
-                <a:solidFill>
-                  <a:srgbClr val="1E293B"/>
-                </a:solidFill>
-                <a:latin typeface="Calibri" pitchFamily="34" charset="0"/>
-                <a:ea typeface="Calibri" pitchFamily="34" charset="-122"/>
-                <a:cs typeface="Calibri" pitchFamily="34" charset="-120"/>
-              </a:rPr>
-              <a:t>Pre-commit Checks</a:t>
-            </a:r>
-            <a:endParaRPr lang="en-US" sz="1100" dirty="0"/>
-          </a:p>
-        </p:txBody>
-      </p:sp>
-      <p:sp>
-        <p:nvSpPr>
-          <p:cNvPr id="50" name="Text 44"/>
-          <p:cNvSpPr/>
-          <p:nvPr/>
-        </p:nvSpPr>
-        <p:spPr>
-          <a:xfrm>
-            <a:off x="4800600" y="4389120"/>
-            <a:ext cx="1645920" cy="365760"/>
-          </a:xfrm>
-          <a:prstGeom prst="rect">
-            <a:avLst/>
-          </a:prstGeom>
-          <a:noFill/>
-          <a:ln/>
-        </p:spPr>
-        <p:txBody>
-          <a:bodyPr wrap="square" lIns="0" tIns="0" rIns="0" bIns="0" rtlCol="0" anchor="ctr"/>
-          <a:lstStyle/>
-          <a:p>
-            <a:pPr indent="0" marL="0">
-              <a:buNone/>
-            </a:pPr>
-            <a:r>
-              <a:rPr lang="en-US" sz="900" dirty="0">
-                <a:solidFill>
-                  <a:srgbClr val="475569"/>
-                </a:solidFill>
-                <a:latin typeface="Consolas" pitchFamily="34" charset="0"/>
-                <a:ea typeface="Consolas" pitchFamily="34" charset="-122"/>
-                <a:cs typeface="Consolas" pitchFamily="34" charset="-120"/>
-              </a:rPr>
-              <a:t>hook runs quality skill</a:t>
-            </a:r>
-            <a:endParaRPr lang="en-US" sz="900" dirty="0"/>
-          </a:p>
-        </p:txBody>
-      </p:sp>
-      <p:sp>
-        <p:nvSpPr>
-          <p:cNvPr id="51" name="Shape 45"/>
-          <p:cNvSpPr/>
-          <p:nvPr/>
-        </p:nvSpPr>
-        <p:spPr>
-          <a:xfrm>
-            <a:off x="6629400" y="4069080"/>
-            <a:ext cx="1828800" cy="731520"/>
-          </a:xfrm>
-          <a:prstGeom prst="rect">
-            <a:avLst/>
-          </a:prstGeom>
-          <a:solidFill>
-            <a:srgbClr val="FFFFFF"/>
-          </a:solidFill>
-          <a:ln/>
-          <a:effectLst>
-            <a:outerShdw sx="100000" sy="100000" kx="0" ky="0" algn="bl" rotWithShape="0" blurRad="50800" dist="25400" dir="8100000">
-              <a:srgbClr val="000000">
-                <a:alpha val="8000"/>
-              </a:srgbClr>
-            </a:outerShdw>
-          </a:effectLst>
-        </p:spPr>
-      </p:sp>
-      <p:sp>
-        <p:nvSpPr>
-          <p:cNvPr id="52" name="Shape 46"/>
-          <p:cNvSpPr/>
-          <p:nvPr/>
-        </p:nvSpPr>
-        <p:spPr>
-          <a:xfrm>
-            <a:off x="6629400" y="4069080"/>
-            <a:ext cx="64008" cy="731520"/>
-          </a:xfrm>
-          <a:prstGeom prst="rect">
-            <a:avLst/>
-          </a:prstGeom>
-          <a:solidFill>
-            <a:srgbClr val="0EA5E9"/>
-          </a:solidFill>
-          <a:ln/>
-        </p:spPr>
-      </p:sp>
-      <p:sp>
-        <p:nvSpPr>
-          <p:cNvPr id="53" name="Text 47"/>
-          <p:cNvSpPr/>
-          <p:nvPr/>
-        </p:nvSpPr>
-        <p:spPr>
-          <a:xfrm>
-            <a:off x="6766560" y="4114800"/>
-            <a:ext cx="1645920" cy="274320"/>
-          </a:xfrm>
-          <a:prstGeom prst="rect">
-            <a:avLst/>
-          </a:prstGeom>
-          <a:noFill/>
-          <a:ln/>
-        </p:spPr>
-        <p:txBody>
-          <a:bodyPr wrap="square" lIns="0" tIns="0" rIns="0" bIns="0" rtlCol="0" anchor="ctr"/>
-          <a:lstStyle/>
-          <a:p>
-            <a:pPr indent="0" marL="0">
-              <a:buNone/>
-            </a:pPr>
-            <a:r>
-              <a:rPr lang="en-US" sz="1100" b="1" dirty="0">
-                <a:solidFill>
-                  <a:srgbClr val="1E293B"/>
-                </a:solidFill>
-                <a:latin typeface="Calibri" pitchFamily="34" charset="0"/>
-                <a:ea typeface="Calibri" pitchFamily="34" charset="-122"/>
-                <a:cs typeface="Calibri" pitchFamily="34" charset="-120"/>
-              </a:rPr>
-              <a:t>Release Notes</a:t>
-            </a:r>
-            <a:endParaRPr lang="en-US" sz="1100" dirty="0"/>
-          </a:p>
-        </p:txBody>
-      </p:sp>
-      <p:sp>
-        <p:nvSpPr>
-          <p:cNvPr id="54" name="Text 48"/>
-          <p:cNvSpPr/>
-          <p:nvPr/>
-        </p:nvSpPr>
-        <p:spPr>
-          <a:xfrm>
-            <a:off x="6766560" y="4389120"/>
-            <a:ext cx="1645920" cy="365760"/>
-          </a:xfrm>
-          <a:prstGeom prst="rect">
-            <a:avLst/>
-          </a:prstGeom>
-          <a:noFill/>
-          <a:ln/>
-        </p:spPr>
-        <p:txBody>
-          <a:bodyPr wrap="square" lIns="0" tIns="0" rIns="0" bIns="0" rtlCol="0" anchor="ctr"/>
-          <a:lstStyle/>
-          <a:p>
-            <a:pPr indent="0" marL="0">
-              <a:buNone/>
-            </a:pPr>
-            <a:r>
-              <a:rPr lang="en-US" sz="900" dirty="0">
-                <a:solidFill>
-                  <a:srgbClr val="475569"/>
-                </a:solidFill>
-                <a:latin typeface="Consolas" pitchFamily="34" charset="0"/>
-                <a:ea typeface="Consolas" pitchFamily="34" charset="-122"/>
-                <a:cs typeface="Consolas" pitchFamily="34" charset="-120"/>
-              </a:rPr>
-              <a:t>auto-gen from commits</a:t>
-            </a:r>
-            <a:endParaRPr lang="en-US" sz="900" dirty="0"/>
           </a:p>
         </p:txBody>
       </p:sp>
@@ -11508,7 +9594,7 @@
                 <a:ea typeface="Consolas" pitchFamily="34" charset="-122"/>
                 <a:cs typeface="Consolas" pitchFamily="34" charset="-120"/>
               </a:rPr>
-              <a:t># 4. Start Copilot in the repo</a:t>
+              <a:t># 4. Fork the template &amp; start Copilot</a:t>
             </a:r>
             <a:endParaRPr lang="en-US" sz="1100" dirty="0"/>
           </a:p>
@@ -11528,7 +9614,7 @@
                 <a:ea typeface="Consolas" pitchFamily="34" charset="-122"/>
                 <a:cs typeface="Consolas" pitchFamily="34" charset="-120"/>
               </a:rPr>
-              <a:t>copilot</a:t>
+              <a:t>cp -r samples/capstone-plugin-template my-plugin &amp;&amp; copilot</a:t>
             </a:r>
             <a:endParaRPr lang="en-US" sz="1100" dirty="0"/>
           </a:p>
@@ -11880,7 +9966,7 @@
                 <a:ea typeface="Calibri" pitchFamily="34" charset="-122"/>
                 <a:cs typeface="Calibri" pitchFamily="34" charset="-120"/>
               </a:rPr>
-              <a:t>50 minutes  ·  Facilitator-led  ·  You leave with a working artifact</a:t>
+              <a:t>35 minutes  ·  Facilitator-led  ·  You leave with a working artifact</a:t>
             </a:r>
             <a:endParaRPr lang="en-US" sz="1400" dirty="0"/>
           </a:p>
@@ -12178,7 +10264,7 @@
                 <a:ea typeface="Calibri" pitchFamily="34" charset="-122"/>
                 <a:cs typeface="Calibri" pitchFamily="34" charset="-120"/>
               </a:rPr>
-              <a:t>15 min</a:t>
+              <a:t>10 min</a:t>
             </a:r>
             <a:endParaRPr lang="en-US" sz="1000" dirty="0"/>
           </a:p>
@@ -12696,7 +10782,7 @@
                 <a:ea typeface="Calibri" pitchFamily="34" charset="-122"/>
                 <a:cs typeface="Calibri" pitchFamily="34" charset="-120"/>
               </a:rPr>
-              <a:t>15 min</a:t>
+              <a:t>5 min</a:t>
             </a:r>
             <a:endParaRPr lang="en-US" sz="1000" dirty="0"/>
           </a:p>
@@ -14391,7 +12477,7 @@
                 <a:ea typeface="Calibri" pitchFamily="34" charset="-122"/>
                 <a:cs typeface="Calibri" pitchFamily="34" charset="-120"/>
               </a:rPr>
-              <a:t>A "pr-review" skill that auto-triggers on prompts like "Review this PR" or</a:t>
+              <a:t>A skill (topic is yours) that auto-triggers naturally and enforces</a:t>
             </a:r>
             <a:endParaRPr lang="en-US" sz="1300" dirty="0"/>
           </a:p>
@@ -14411,7 +12497,7 @@
                 <a:ea typeface="Calibri" pitchFamily="34" charset="-122"/>
                 <a:cs typeface="Calibri" pitchFamily="34" charset="-120"/>
               </a:rPr>
-              <a:t>"Is this ready to merge?" — enforcing your team's checklist every single time.</a:t>
+              <a:t>your team's checklist every single time — fork the template, fill in your logic.</a:t>
             </a:r>
             <a:endParaRPr lang="en-US" sz="1300" dirty="0"/>
           </a:p>
@@ -14512,7 +12598,7 @@
                 <a:ea typeface="Consolas" pitchFamily="34" charset="-122"/>
                 <a:cs typeface="Consolas" pitchFamily="34" charset="-120"/>
               </a:rPr>
-              <a:t>mkdir -p .github/skills/pr-review  &amp;&amp;  touch .github/skills/pr-review/SKILL.md</a:t>
+              <a:t>cp -r samples/capstone-plugin-template my-&lt;skill&gt;</a:t>
             </a:r>
             <a:endParaRPr lang="en-US" sz="1100" dirty="0"/>
           </a:p>
@@ -14532,7 +12618,7 @@
                 <a:ea typeface="Consolas" pitchFamily="34" charset="-122"/>
                 <a:cs typeface="Consolas" pitchFamily="34" charset="-120"/>
               </a:rPr>
-              <a:t># Add frontmatter (name, description)</a:t>
+              <a:t># Rename skills/example-skill/ → your skill name</a:t>
             </a:r>
             <a:endParaRPr lang="en-US" sz="1100" dirty="0"/>
           </a:p>
@@ -14552,7 +12638,7 @@
                 <a:ea typeface="Consolas" pitchFamily="34" charset="-122"/>
                 <a:cs typeface="Consolas" pitchFamily="34" charset="-120"/>
               </a:rPr>
-              <a:t># Write the checklist — team-specific, not generic</a:t>
+              <a:t># Edit SKILL.md: description, inputs, checks</a:t>
             </a:r>
             <a:endParaRPr lang="en-US" sz="1100" dirty="0"/>
           </a:p>
@@ -14572,7 +12658,7 @@
                 <a:ea typeface="Consolas" pitchFamily="34" charset="-122"/>
                 <a:cs typeface="Consolas" pitchFamily="34" charset="-120"/>
               </a:rPr>
-              <a:t># Define output format (PASS/FAIL + suggested fixes)</a:t>
+              <a:t># plugin.json is already wired — no change needed</a:t>
             </a:r>
             <a:endParaRPr lang="en-US" sz="1100" dirty="0"/>
           </a:p>
@@ -14601,7 +12687,7 @@
                 <a:ea typeface="Consolas" pitchFamily="34" charset="-122"/>
                 <a:cs typeface="Consolas" pitchFamily="34" charset="-120"/>
               </a:rPr>
-              <a:t>&gt; copilot  →  "Review the changes in this repo for a PR"</a:t>
+              <a:t>&gt; copilot  →  "&lt;your natural trigger&gt;"</a:t>
             </a:r>
             <a:endParaRPr lang="en-US" sz="1100" dirty="0"/>
           </a:p>
@@ -14621,7 +12707,7 @@
                 <a:ea typeface="Consolas" pitchFamily="34" charset="-122"/>
                 <a:cs typeface="Consolas" pitchFamily="34" charset="-120"/>
               </a:rPr>
-              <a:t># Verify the skill auto-triggered. Iterate on description if not.</a:t>
+              <a:t># Verify it auto-triggers. Iterate on description if not.</a:t>
             </a:r>
             <a:endParaRPr lang="en-US" sz="1100" dirty="0"/>
           </a:p>
@@ -14660,817 +12746,7 @@
                 <a:ea typeface="Calibri" pitchFamily="34" charset="-122"/>
                 <a:cs typeface="Calibri" pitchFamily="34" charset="-120"/>
               </a:rPr>
-              <a:t>Output: a committed .github/skills/pr-review/SKILL.md — yours to take to your real repos.</a:t>
-            </a:r>
-            <a:endParaRPr lang="en-US" sz="1200" dirty="0"/>
-          </a:p>
-        </p:txBody>
-      </p:sp>
-    </p:spTree>
-  </p:cSld>
-  <p:clrMapOvr>
-    <a:masterClrMapping/>
-  </p:clrMapOvr>
-</p:sld>
-</file>
-
-<file path=ppt/slides/slide21.xml><?xml version="1.0" encoding="utf-8"?>
-<p:sld xmlns:a="http://schemas.openxmlformats.org/drawingml/2006/main" xmlns:r="http://schemas.openxmlformats.org/officeDocument/2006/relationships" xmlns:p="http://schemas.openxmlformats.org/presentationml/2006/main">
-  <p:cSld name="Slide 21">
-    <p:bg>
-      <p:bgPr>
-        <a:solidFill>
-          <a:srgbClr val="F8FAFC"/>
-        </a:solidFill>
-      </p:bgPr>
-    </p:bg>
-    <p:spTree>
-      <p:nvGrpSpPr>
-        <p:cNvPr id="1" name=""/>
-        <p:cNvGrpSpPr/>
-        <p:nvPr/>
-      </p:nvGrpSpPr>
-      <p:grpSpPr>
-        <a:xfrm>
-          <a:off x="0" y="0"/>
-          <a:ext cx="0" cy="0"/>
-          <a:chOff x="0" y="0"/>
-          <a:chExt cx="0" cy="0"/>
-        </a:xfrm>
-      </p:grpSpPr>
-      <p:sp>
-        <p:nvSpPr>
-          <p:cNvPr id="2" name="Shape 0"/>
-          <p:cNvSpPr/>
-          <p:nvPr/>
-        </p:nvSpPr>
-        <p:spPr>
-          <a:xfrm>
-            <a:off x="0" y="0"/>
-            <a:ext cx="9144000" cy="54864"/>
-          </a:xfrm>
-          <a:prstGeom prst="rect">
-            <a:avLst/>
-          </a:prstGeom>
-          <a:solidFill>
-            <a:srgbClr val="0EA5E9"/>
-          </a:solidFill>
-          <a:ln/>
-        </p:spPr>
-      </p:sp>
-      <p:sp>
-        <p:nvSpPr>
-          <p:cNvPr id="3" name="Text 1"/>
-          <p:cNvSpPr/>
-          <p:nvPr/>
-        </p:nvSpPr>
-        <p:spPr>
-          <a:xfrm>
-            <a:off x="731520" y="182880"/>
-            <a:ext cx="2743200" cy="320040"/>
-          </a:xfrm>
-          <a:prstGeom prst="rect">
-            <a:avLst/>
-          </a:prstGeom>
-          <a:noFill/>
-          <a:ln/>
-        </p:spPr>
-        <p:txBody>
-          <a:bodyPr wrap="square" lIns="0" tIns="0" rIns="0" bIns="0" rtlCol="0" anchor="ctr"/>
-          <a:lstStyle/>
-          <a:p>
-            <a:pPr indent="0" marL="0">
-              <a:buNone/>
-            </a:pPr>
-            <a:r>
-              <a:rPr lang="en-US" sz="1200" b="1" spc="300" kern="0" dirty="0">
-                <a:solidFill>
-                  <a:srgbClr val="0EA5E9"/>
-                </a:solidFill>
-                <a:latin typeface="Calibri" pitchFamily="34" charset="0"/>
-                <a:ea typeface="Calibri" pitchFamily="34" charset="-122"/>
-                <a:cs typeface="Calibri" pitchFamily="34" charset="-120"/>
-              </a:rPr>
-              <a:t>Distribution</a:t>
-            </a:r>
-            <a:endParaRPr lang="en-US" sz="1200" dirty="0"/>
-          </a:p>
-        </p:txBody>
-      </p:sp>
-      <p:sp>
-        <p:nvSpPr>
-          <p:cNvPr id="4" name="Text 2"/>
-          <p:cNvSpPr/>
-          <p:nvPr/>
-        </p:nvSpPr>
-        <p:spPr>
-          <a:xfrm>
-            <a:off x="731520" y="457200"/>
-            <a:ext cx="7772400" cy="502920"/>
-          </a:xfrm>
-          <a:prstGeom prst="rect">
-            <a:avLst/>
-          </a:prstGeom>
-          <a:noFill/>
-          <a:ln/>
-        </p:spPr>
-        <p:txBody>
-          <a:bodyPr wrap="square" lIns="0" tIns="0" rIns="0" bIns="0" rtlCol="0" anchor="ctr"/>
-          <a:lstStyle/>
-          <a:p>
-            <a:pPr indent="0" marL="0">
-              <a:buNone/>
-            </a:pPr>
-            <a:r>
-              <a:rPr lang="en-US" sz="2600" dirty="0">
-                <a:solidFill>
-                  <a:srgbClr val="1E293B"/>
-                </a:solidFill>
-                <a:latin typeface="Arial Black" pitchFamily="34" charset="0"/>
-                <a:ea typeface="Arial Black" pitchFamily="34" charset="-122"/>
-                <a:cs typeface="Arial Black" pitchFamily="34" charset="-120"/>
-              </a:rPr>
-              <a:t>Plugins — Ship It to the Whole Team</a:t>
-            </a:r>
-            <a:endParaRPr lang="en-US" sz="2600" dirty="0"/>
-          </a:p>
-        </p:txBody>
-      </p:sp>
-      <p:sp>
-        <p:nvSpPr>
-          <p:cNvPr id="5" name="Text 3"/>
-          <p:cNvSpPr/>
-          <p:nvPr/>
-        </p:nvSpPr>
-        <p:spPr>
-          <a:xfrm>
-            <a:off x="731520" y="914400"/>
-            <a:ext cx="7772400" cy="274320"/>
-          </a:xfrm>
-          <a:prstGeom prst="rect">
-            <a:avLst/>
-          </a:prstGeom>
-          <a:noFill/>
-          <a:ln/>
-        </p:spPr>
-        <p:txBody>
-          <a:bodyPr wrap="square" lIns="0" tIns="0" rIns="0" bIns="0" rtlCol="0" anchor="ctr"/>
-          <a:lstStyle/>
-          <a:p>
-            <a:pPr indent="0" marL="0">
-              <a:buNone/>
-            </a:pPr>
-            <a:r>
-              <a:rPr lang="en-US" sz="1300" i="1" dirty="0">
-                <a:solidFill>
-                  <a:srgbClr val="475569"/>
-                </a:solidFill>
-                <a:latin typeface="Calibri" pitchFamily="34" charset="0"/>
-                <a:ea typeface="Calibri" pitchFamily="34" charset="-122"/>
-                <a:cs typeface="Calibri" pitchFamily="34" charset="-120"/>
-              </a:rPr>
-              <a:t>One install bundles agents + skills + MCP setup for every engineer</a:t>
-            </a:r>
-            <a:endParaRPr lang="en-US" sz="1300" dirty="0"/>
-          </a:p>
-        </p:txBody>
-      </p:sp>
-      <p:sp>
-        <p:nvSpPr>
-          <p:cNvPr id="6" name="Shape 4"/>
-          <p:cNvSpPr/>
-          <p:nvPr/>
-        </p:nvSpPr>
-        <p:spPr>
-          <a:xfrm>
-            <a:off x="731520" y="1417320"/>
-            <a:ext cx="3749040" cy="2286000"/>
-          </a:xfrm>
-          <a:prstGeom prst="rect">
-            <a:avLst/>
-          </a:prstGeom>
-          <a:solidFill>
-            <a:srgbClr val="FFFFFF"/>
-          </a:solidFill>
-          <a:ln/>
-          <a:effectLst>
-            <a:outerShdw sx="100000" sy="100000" kx="0" ky="0" algn="bl" rotWithShape="0" blurRad="50800" dist="25400" dir="8100000">
-              <a:srgbClr val="000000">
-                <a:alpha val="8000"/>
-              </a:srgbClr>
-            </a:outerShdw>
-          </a:effectLst>
-        </p:spPr>
-      </p:sp>
-      <p:sp>
-        <p:nvSpPr>
-          <p:cNvPr id="7" name="Shape 5"/>
-          <p:cNvSpPr/>
-          <p:nvPr/>
-        </p:nvSpPr>
-        <p:spPr>
-          <a:xfrm>
-            <a:off x="731520" y="1417320"/>
-            <a:ext cx="3749040" cy="54864"/>
-          </a:xfrm>
-          <a:prstGeom prst="rect">
-            <a:avLst/>
-          </a:prstGeom>
-          <a:solidFill>
-            <a:srgbClr val="0EA5E9"/>
-          </a:solidFill>
-          <a:ln/>
-        </p:spPr>
-      </p:sp>
-      <p:sp>
-        <p:nvSpPr>
-          <p:cNvPr id="8" name="Text 6"/>
-          <p:cNvSpPr/>
-          <p:nvPr/>
-        </p:nvSpPr>
-        <p:spPr>
-          <a:xfrm>
-            <a:off x="1005840" y="1554480"/>
-            <a:ext cx="3200400" cy="228600"/>
-          </a:xfrm>
-          <a:prstGeom prst="rect">
-            <a:avLst/>
-          </a:prstGeom>
-          <a:noFill/>
-          <a:ln/>
-        </p:spPr>
-        <p:txBody>
-          <a:bodyPr wrap="square" lIns="0" tIns="0" rIns="0" bIns="0" rtlCol="0" anchor="ctr"/>
-          <a:lstStyle/>
-          <a:p>
-            <a:pPr indent="0" marL="0">
-              <a:buNone/>
-            </a:pPr>
-            <a:r>
-              <a:rPr lang="en-US" sz="1000" b="1" spc="200" kern="0" dirty="0">
-                <a:solidFill>
-                  <a:srgbClr val="0EA5E9"/>
-                </a:solidFill>
-                <a:latin typeface="Calibri" pitchFamily="34" charset="0"/>
-                <a:ea typeface="Calibri" pitchFamily="34" charset="-122"/>
-                <a:cs typeface="Calibri" pitchFamily="34" charset="-120"/>
-              </a:rPr>
-              <a:t>WHAT A PLUGIN BUNDLES</a:t>
-            </a:r>
-            <a:endParaRPr lang="en-US" sz="1000" dirty="0"/>
-          </a:p>
-        </p:txBody>
-      </p:sp>
-      <p:sp>
-        <p:nvSpPr>
-          <p:cNvPr id="9" name="Text 7"/>
-          <p:cNvSpPr/>
-          <p:nvPr/>
-        </p:nvSpPr>
-        <p:spPr>
-          <a:xfrm>
-            <a:off x="1005840" y="1828800"/>
-            <a:ext cx="3200400" cy="1828800"/>
-          </a:xfrm>
-          <a:prstGeom prst="rect">
-            <a:avLst/>
-          </a:prstGeom>
-          <a:noFill/>
-          <a:ln/>
-        </p:spPr>
-        <p:txBody>
-          <a:bodyPr wrap="square" lIns="0" tIns="0" rIns="0" bIns="0" rtlCol="0" anchor="ctr"/>
-          <a:lstStyle/>
-          <a:p>
-            <a:pPr marL="342900" indent="-342900">
-              <a:lnSpc>
-                <a:spcPct val="130000"/>
-              </a:lnSpc>
-              <a:spcAft>
-                <a:spcPts val="600"/>
-              </a:spcAft>
-              <a:buSzPct val="100000"/>
-              <a:buChar char="•"/>
-            </a:pPr>
-            <a:r>
-              <a:rPr lang="en-US" sz="1200" dirty="0">
-                <a:solidFill>
-                  <a:srgbClr val="1E293B"/>
-                </a:solidFill>
-                <a:latin typeface="Calibri" pitchFamily="34" charset="0"/>
-                <a:ea typeface="Calibri" pitchFamily="34" charset="-122"/>
-                <a:cs typeface="Calibri" pitchFamily="34" charset="-120"/>
-              </a:rPr>
-              <a:t>Custom agents (specialists)</a:t>
-            </a:r>
-            <a:endParaRPr lang="en-US" sz="1200" dirty="0"/>
-          </a:p>
-          <a:p>
-            <a:pPr marL="342900" indent="-342900">
-              <a:lnSpc>
-                <a:spcPct val="130000"/>
-              </a:lnSpc>
-              <a:spcAft>
-                <a:spcPts val="600"/>
-              </a:spcAft>
-              <a:buSzPct val="100000"/>
-              <a:buChar char="•"/>
-            </a:pPr>
-            <a:r>
-              <a:rPr lang="en-US" sz="1200" dirty="0">
-                <a:solidFill>
-                  <a:srgbClr val="1E293B"/>
-                </a:solidFill>
-                <a:latin typeface="Calibri" pitchFamily="34" charset="0"/>
-                <a:ea typeface="Calibri" pitchFamily="34" charset="-122"/>
-                <a:cs typeface="Calibri" pitchFamily="34" charset="-120"/>
-              </a:rPr>
-              <a:t>Custom skills (repeatable tasks)</a:t>
-            </a:r>
-            <a:endParaRPr lang="en-US" sz="1200" dirty="0"/>
-          </a:p>
-          <a:p>
-            <a:pPr marL="342900" indent="-342900">
-              <a:lnSpc>
-                <a:spcPct val="130000"/>
-              </a:lnSpc>
-              <a:spcAft>
-                <a:spcPts val="600"/>
-              </a:spcAft>
-              <a:buSzPct val="100000"/>
-              <a:buChar char="•"/>
-            </a:pPr>
-            <a:r>
-              <a:rPr lang="en-US" sz="1200" dirty="0">
-                <a:solidFill>
-                  <a:srgbClr val="1E293B"/>
-                </a:solidFill>
-                <a:latin typeface="Calibri" pitchFamily="34" charset="0"/>
-                <a:ea typeface="Calibri" pitchFamily="34" charset="-122"/>
-                <a:cs typeface="Calibri" pitchFamily="34" charset="-120"/>
-              </a:rPr>
-              <a:t>MCP server configurations</a:t>
-            </a:r>
-            <a:endParaRPr lang="en-US" sz="1200" dirty="0"/>
-          </a:p>
-          <a:p>
-            <a:pPr marL="342900" indent="-342900">
-              <a:lnSpc>
-                <a:spcPct val="130000"/>
-              </a:lnSpc>
-              <a:spcAft>
-                <a:spcPts val="600"/>
-              </a:spcAft>
-              <a:buSzPct val="100000"/>
-              <a:buChar char="•"/>
-            </a:pPr>
-            <a:r>
-              <a:rPr lang="en-US" sz="1200" dirty="0">
-                <a:solidFill>
-                  <a:srgbClr val="1E293B"/>
-                </a:solidFill>
-                <a:latin typeface="Calibri" pitchFamily="34" charset="0"/>
-                <a:ea typeface="Calibri" pitchFamily="34" charset="-122"/>
-                <a:cs typeface="Calibri" pitchFamily="34" charset="-120"/>
-              </a:rPr>
-              <a:t>Commands &amp; hooks</a:t>
-            </a:r>
-            <a:endParaRPr lang="en-US" sz="1200" dirty="0"/>
-          </a:p>
-          <a:p>
-            <a:pPr marL="342900" indent="-342900">
-              <a:lnSpc>
-                <a:spcPct val="130000"/>
-              </a:lnSpc>
-              <a:spcAft>
-                <a:spcPts val="600"/>
-              </a:spcAft>
-              <a:buSzPct val="100000"/>
-              <a:buChar char="•"/>
-            </a:pPr>
-            <a:r>
-              <a:rPr lang="en-US" sz="1200" dirty="0">
-                <a:solidFill>
-                  <a:srgbClr val="1E293B"/>
-                </a:solidFill>
-                <a:latin typeface="Calibri" pitchFamily="34" charset="0"/>
-                <a:ea typeface="Calibri" pitchFamily="34" charset="-122"/>
-                <a:cs typeface="Calibri" pitchFamily="34" charset="-120"/>
-              </a:rPr>
-              <a:t>All version-controlled together</a:t>
-            </a:r>
-            <a:endParaRPr lang="en-US" sz="1200" dirty="0"/>
-          </a:p>
-        </p:txBody>
-      </p:sp>
-      <p:sp>
-        <p:nvSpPr>
-          <p:cNvPr id="10" name="Shape 8"/>
-          <p:cNvSpPr/>
-          <p:nvPr/>
-        </p:nvSpPr>
-        <p:spPr>
-          <a:xfrm>
-            <a:off x="4663440" y="1417320"/>
-            <a:ext cx="3749040" cy="2286000"/>
-          </a:xfrm>
-          <a:prstGeom prst="rect">
-            <a:avLst/>
-          </a:prstGeom>
-          <a:solidFill>
-            <a:srgbClr val="FFFFFF"/>
-          </a:solidFill>
-          <a:ln/>
-          <a:effectLst>
-            <a:outerShdw sx="100000" sy="100000" kx="0" ky="0" algn="bl" rotWithShape="0" blurRad="50800" dist="25400" dir="8100000">
-              <a:srgbClr val="000000">
-                <a:alpha val="8000"/>
-              </a:srgbClr>
-            </a:outerShdw>
-          </a:effectLst>
-        </p:spPr>
-      </p:sp>
-      <p:sp>
-        <p:nvSpPr>
-          <p:cNvPr id="11" name="Shape 9"/>
-          <p:cNvSpPr/>
-          <p:nvPr/>
-        </p:nvSpPr>
-        <p:spPr>
-          <a:xfrm>
-            <a:off x="4663440" y="1417320"/>
-            <a:ext cx="3749040" cy="54864"/>
-          </a:xfrm>
-          <a:prstGeom prst="rect">
-            <a:avLst/>
-          </a:prstGeom>
-          <a:solidFill>
-            <a:srgbClr val="10B981"/>
-          </a:solidFill>
-          <a:ln/>
-        </p:spPr>
-      </p:sp>
-      <p:sp>
-        <p:nvSpPr>
-          <p:cNvPr id="12" name="Text 10"/>
-          <p:cNvSpPr/>
-          <p:nvPr/>
-        </p:nvSpPr>
-        <p:spPr>
-          <a:xfrm>
-            <a:off x="4937760" y="1554480"/>
-            <a:ext cx="3200400" cy="228600"/>
-          </a:xfrm>
-          <a:prstGeom prst="rect">
-            <a:avLst/>
-          </a:prstGeom>
-          <a:noFill/>
-          <a:ln/>
-        </p:spPr>
-        <p:txBody>
-          <a:bodyPr wrap="square" lIns="0" tIns="0" rIns="0" bIns="0" rtlCol="0" anchor="ctr"/>
-          <a:lstStyle/>
-          <a:p>
-            <a:pPr indent="0" marL="0">
-              <a:buNone/>
-            </a:pPr>
-            <a:r>
-              <a:rPr lang="en-US" sz="1000" b="1" spc="200" kern="0" dirty="0">
-                <a:solidFill>
-                  <a:srgbClr val="10B981"/>
-                </a:solidFill>
-                <a:latin typeface="Calibri" pitchFamily="34" charset="0"/>
-                <a:ea typeface="Calibri" pitchFamily="34" charset="-122"/>
-                <a:cs typeface="Calibri" pitchFamily="34" charset="-120"/>
-              </a:rPr>
-              <a:t>WHY IT MATTERS FOR LEADS</a:t>
-            </a:r>
-            <a:endParaRPr lang="en-US" sz="1000" dirty="0"/>
-          </a:p>
-        </p:txBody>
-      </p:sp>
-      <p:sp>
-        <p:nvSpPr>
-          <p:cNvPr id="13" name="Text 11"/>
-          <p:cNvSpPr/>
-          <p:nvPr/>
-        </p:nvSpPr>
-        <p:spPr>
-          <a:xfrm>
-            <a:off x="4937760" y="1828800"/>
-            <a:ext cx="3200400" cy="1828800"/>
-          </a:xfrm>
-          <a:prstGeom prst="rect">
-            <a:avLst/>
-          </a:prstGeom>
-          <a:noFill/>
-          <a:ln/>
-        </p:spPr>
-        <p:txBody>
-          <a:bodyPr wrap="square" lIns="0" tIns="0" rIns="0" bIns="0" rtlCol="0" anchor="ctr"/>
-          <a:lstStyle/>
-          <a:p>
-            <a:pPr marL="342900" indent="-342900">
-              <a:lnSpc>
-                <a:spcPct val="130000"/>
-              </a:lnSpc>
-              <a:spcAft>
-                <a:spcPts val="600"/>
-              </a:spcAft>
-              <a:buSzPct val="100000"/>
-              <a:buChar char="•"/>
-            </a:pPr>
-            <a:r>
-              <a:rPr lang="en-US" sz="1200" dirty="0">
-                <a:solidFill>
-                  <a:srgbClr val="1E293B"/>
-                </a:solidFill>
-                <a:latin typeface="Calibri" pitchFamily="34" charset="0"/>
-                <a:ea typeface="Calibri" pitchFamily="34" charset="-122"/>
-                <a:cs typeface="Calibri" pitchFamily="34" charset="-120"/>
-              </a:rPr>
-              <a:t>Engineers install once — get everything</a:t>
-            </a:r>
-            <a:endParaRPr lang="en-US" sz="1200" dirty="0"/>
-          </a:p>
-          <a:p>
-            <a:pPr marL="342900" indent="-342900">
-              <a:lnSpc>
-                <a:spcPct val="130000"/>
-              </a:lnSpc>
-              <a:spcAft>
-                <a:spcPts val="600"/>
-              </a:spcAft>
-              <a:buSzPct val="100000"/>
-              <a:buChar char="•"/>
-            </a:pPr>
-            <a:r>
-              <a:rPr lang="en-US" sz="1200" dirty="0">
-                <a:solidFill>
-                  <a:srgbClr val="1E293B"/>
-                </a:solidFill>
-                <a:latin typeface="Calibri" pitchFamily="34" charset="0"/>
-                <a:ea typeface="Calibri" pitchFamily="34" charset="-122"/>
-                <a:cs typeface="Calibri" pitchFamily="34" charset="-120"/>
-              </a:rPr>
-              <a:t>No 'did you copy the agent file?' friction</a:t>
-            </a:r>
-            <a:endParaRPr lang="en-US" sz="1200" dirty="0"/>
-          </a:p>
-          <a:p>
-            <a:pPr marL="342900" indent="-342900">
-              <a:lnSpc>
-                <a:spcPct val="130000"/>
-              </a:lnSpc>
-              <a:spcAft>
-                <a:spcPts val="600"/>
-              </a:spcAft>
-              <a:buSzPct val="100000"/>
-              <a:buChar char="•"/>
-            </a:pPr>
-            <a:r>
-              <a:rPr lang="en-US" sz="1200" dirty="0">
-                <a:solidFill>
-                  <a:srgbClr val="1E293B"/>
-                </a:solidFill>
-                <a:latin typeface="Calibri" pitchFamily="34" charset="0"/>
-                <a:ea typeface="Calibri" pitchFamily="34" charset="-122"/>
-                <a:cs typeface="Calibri" pitchFamily="34" charset="-120"/>
-              </a:rPr>
-              <a:t>Updates propagate — fix once, team benefits</a:t>
-            </a:r>
-            <a:endParaRPr lang="en-US" sz="1200" dirty="0"/>
-          </a:p>
-          <a:p>
-            <a:pPr marL="342900" indent="-342900">
-              <a:lnSpc>
-                <a:spcPct val="130000"/>
-              </a:lnSpc>
-              <a:spcAft>
-                <a:spcPts val="600"/>
-              </a:spcAft>
-              <a:buSzPct val="100000"/>
-              <a:buChar char="•"/>
-            </a:pPr>
-            <a:r>
-              <a:rPr lang="en-US" sz="1200" dirty="0">
-                <a:solidFill>
-                  <a:srgbClr val="1E293B"/>
-                </a:solidFill>
-                <a:latin typeface="Calibri" pitchFamily="34" charset="0"/>
-                <a:ea typeface="Calibri" pitchFamily="34" charset="-122"/>
-                <a:cs typeface="Calibri" pitchFamily="34" charset="-120"/>
-              </a:rPr>
-              <a:t>Works across VS Code, Copilot CLI, etc.</a:t>
-            </a:r>
-            <a:endParaRPr lang="en-US" sz="1200" dirty="0"/>
-          </a:p>
-          <a:p>
-            <a:pPr marL="342900" indent="-342900">
-              <a:lnSpc>
-                <a:spcPct val="130000"/>
-              </a:lnSpc>
-              <a:spcAft>
-                <a:spcPts val="600"/>
-              </a:spcAft>
-              <a:buSzPct val="100000"/>
-              <a:buChar char="•"/>
-            </a:pPr>
-            <a:r>
-              <a:rPr lang="en-US" sz="1200" dirty="0">
-                <a:solidFill>
-                  <a:srgbClr val="1E293B"/>
-                </a:solidFill>
-                <a:latin typeface="Calibri" pitchFamily="34" charset="0"/>
-                <a:ea typeface="Calibri" pitchFamily="34" charset="-122"/>
-                <a:cs typeface="Calibri" pitchFamily="34" charset="-120"/>
-              </a:rPr>
-              <a:t>Your team's AI system becomes a product</a:t>
-            </a:r>
-            <a:endParaRPr lang="en-US" sz="1200" dirty="0"/>
-          </a:p>
-        </p:txBody>
-      </p:sp>
-      <p:sp>
-        <p:nvSpPr>
-          <p:cNvPr id="14" name="Shape 12"/>
-          <p:cNvSpPr/>
-          <p:nvPr/>
-        </p:nvSpPr>
-        <p:spPr>
-          <a:xfrm>
-            <a:off x="731520" y="3886200"/>
-            <a:ext cx="7680960" cy="731520"/>
-          </a:xfrm>
-          <a:prstGeom prst="rect">
-            <a:avLst/>
-          </a:prstGeom>
-          <a:solidFill>
-            <a:srgbClr val="1E293B"/>
-          </a:solidFill>
-          <a:ln/>
-        </p:spPr>
-      </p:sp>
-      <p:pic>
-        <p:nvPicPr>
-          <p:cNvPr id="15" name="Image 0" descr="preencoded.png"/>
-          <p:cNvPicPr>
-            <a:picLocks noChangeAspect="1"/>
-          </p:cNvPicPr>
-          <p:nvPr/>
-        </p:nvPicPr>
-        <p:blipFill>
-          <a:blip r:embed="rId1"/>
-          <a:stretch>
-            <a:fillRect/>
-          </a:stretch>
-        </p:blipFill>
-        <p:spPr>
-          <a:xfrm>
-            <a:off x="914400" y="4069080"/>
-            <a:ext cx="365760" cy="365760"/>
-          </a:xfrm>
-          <a:prstGeom prst="rect">
-            <a:avLst/>
-          </a:prstGeom>
-        </p:spPr>
-      </p:pic>
-      <p:sp>
-        <p:nvSpPr>
-          <p:cNvPr id="16" name="Text 13"/>
-          <p:cNvSpPr/>
-          <p:nvPr/>
-        </p:nvSpPr>
-        <p:spPr>
-          <a:xfrm>
-            <a:off x="1417320" y="4023360"/>
-            <a:ext cx="2743200" cy="228600"/>
-          </a:xfrm>
-          <a:prstGeom prst="rect">
-            <a:avLst/>
-          </a:prstGeom>
-          <a:noFill/>
-          <a:ln/>
-        </p:spPr>
-        <p:txBody>
-          <a:bodyPr wrap="square" lIns="0" tIns="0" rIns="0" bIns="0" rtlCol="0" anchor="ctr"/>
-          <a:lstStyle/>
-          <a:p>
-            <a:pPr indent="0" marL="0">
-              <a:buNone/>
-            </a:pPr>
-            <a:r>
-              <a:rPr lang="en-US" sz="1000" b="1" spc="300" kern="0" dirty="0">
-                <a:solidFill>
-                  <a:srgbClr val="38BDF8"/>
-                </a:solidFill>
-                <a:latin typeface="Calibri" pitchFamily="34" charset="0"/>
-                <a:ea typeface="Calibri" pitchFamily="34" charset="-122"/>
-                <a:cs typeface="Calibri" pitchFamily="34" charset="-120"/>
-              </a:rPr>
-              <a:t>LIVE DEMO</a:t>
-            </a:r>
-            <a:endParaRPr lang="en-US" sz="1000" dirty="0"/>
-          </a:p>
-        </p:txBody>
-      </p:sp>
-      <p:sp>
-        <p:nvSpPr>
-          <p:cNvPr id="17" name="Text 14"/>
-          <p:cNvSpPr/>
-          <p:nvPr/>
-        </p:nvSpPr>
-        <p:spPr>
-          <a:xfrm>
-            <a:off x="1417320" y="4251960"/>
-            <a:ext cx="6766560" cy="320040"/>
-          </a:xfrm>
-          <a:prstGeom prst="rect">
-            <a:avLst/>
-          </a:prstGeom>
-          <a:noFill/>
-          <a:ln/>
-        </p:spPr>
-        <p:txBody>
-          <a:bodyPr wrap="square" lIns="0" tIns="0" rIns="0" bIns="0" rtlCol="0" anchor="ctr"/>
-          <a:lstStyle/>
-          <a:p>
-            <a:pPr indent="0" marL="0">
-              <a:buNone/>
-            </a:pPr>
-            <a:r>
-              <a:rPr lang="en-US" sz="1200" dirty="0">
-                <a:solidFill>
-                  <a:srgbClr val="FFFFFF"/>
-                </a:solidFill>
-                <a:latin typeface="Calibri" pitchFamily="34" charset="0"/>
-                <a:ea typeface="Calibri" pitchFamily="34" charset="-122"/>
-                <a:cs typeface="Calibri" pitchFamily="34" charset="-120"/>
-              </a:rPr>
-              <a:t>Install GEP plugin from VS Code UI → agents, skills, MCP appear automatically</a:t>
-            </a:r>
-            <a:endParaRPr lang="en-US" sz="1200" dirty="0"/>
-          </a:p>
-        </p:txBody>
-      </p:sp>
-      <p:pic>
-        <p:nvPicPr>
-          <p:cNvPr id="18" name="Image 1" descr="preencoded.png"/>
-          <p:cNvPicPr>
-            <a:picLocks noChangeAspect="1"/>
-          </p:cNvPicPr>
-          <p:nvPr/>
-        </p:nvPicPr>
-        <p:blipFill>
-          <a:blip r:embed="rId2"/>
-          <a:stretch>
-            <a:fillRect/>
-          </a:stretch>
-        </p:blipFill>
-        <p:spPr>
-          <a:xfrm>
-            <a:off x="731520" y="4709160"/>
-            <a:ext cx="274320" cy="274320"/>
-          </a:xfrm>
-          <a:prstGeom prst="rect">
-            <a:avLst/>
-          </a:prstGeom>
-        </p:spPr>
-      </p:pic>
-      <p:sp>
-        <p:nvSpPr>
-          <p:cNvPr id="19" name="Text 15"/>
-          <p:cNvSpPr/>
-          <p:nvPr/>
-        </p:nvSpPr>
-        <p:spPr>
-          <a:xfrm>
-            <a:off x="1097280" y="4709160"/>
-            <a:ext cx="7132320" cy="320040"/>
-          </a:xfrm>
-          <a:prstGeom prst="rect">
-            <a:avLst/>
-          </a:prstGeom>
-          <a:noFill/>
-          <a:ln/>
-        </p:spPr>
-        <p:txBody>
-          <a:bodyPr wrap="square" lIns="0" tIns="0" rIns="0" bIns="0" rtlCol="0" anchor="ctr"/>
-          <a:lstStyle/>
-          <a:p>
-            <a:pPr indent="0" marL="0">
-              <a:buNone/>
-            </a:pPr>
-            <a:r>
-              <a:rPr lang="en-US" sz="1200" b="1" dirty="0">
-                <a:solidFill>
-                  <a:srgbClr val="0EA5E9"/>
-                </a:solidFill>
-                <a:latin typeface="Calibri" pitchFamily="34" charset="0"/>
-                <a:ea typeface="Calibri" pitchFamily="34" charset="-122"/>
-                <a:cs typeface="Calibri" pitchFamily="34" charset="-120"/>
-              </a:rPr>
-              <a:t>Build once. Ship as plugin. Every engineer benefits from day one.</a:t>
+              <a:t>Output: a forked plugin with one working skill — committable, replicable.</a:t>
             </a:r>
             <a:endParaRPr lang="en-US" sz="1200" dirty="0"/>
           </a:p>
@@ -16409,7 +13685,7 @@
                 <a:ea typeface="Calibri" pitchFamily="34" charset="-122"/>
                 <a:cs typeface="Calibri" pitchFamily="34" charset="-120"/>
               </a:rPr>
-              <a:t>Consider MCP &amp; CI hooks</a:t>
+              <a:t>Add CI automation: copilot -p "…" in pipelines</a:t>
             </a:r>
             <a:endParaRPr lang="en-US" sz="1000" dirty="0"/>
           </a:p>
@@ -16550,7 +13826,7 @@
                 <a:ea typeface="Calibri" pitchFamily="34" charset="-122"/>
                 <a:cs typeface="Calibri" pitchFamily="34" charset="-120"/>
               </a:rPr>
-              <a:t>3.  .github/skills/pr-review/SKILL.md — PR review checklist</a:t>
+              <a:t>3.  samples/capstone-plugin-template — forkable plugin wrapper</a:t>
             </a:r>
             <a:endParaRPr lang="en-US" sz="1100" dirty="0"/>
           </a:p>
@@ -16792,6 +14068,748 @@
               <a:t>Questions?</a:t>
             </a:r>
             <a:endParaRPr lang="en-US" sz="2200" dirty="0"/>
+          </a:p>
+        </p:txBody>
+      </p:sp>
+    </p:spTree>
+  </p:cSld>
+  <p:clrMapOvr>
+    <a:masterClrMapping/>
+  </p:clrMapOvr>
+</p:sld>
+</file>
+
+<file path=ppt/slides/slide24.xml><?xml version="1.0" encoding="utf-8"?>
+<p:sld xmlns:a="http://schemas.openxmlformats.org/drawingml/2006/main" xmlns:r="http://schemas.openxmlformats.org/officeDocument/2006/relationships" xmlns:p="http://schemas.openxmlformats.org/presentationml/2006/main">
+  <p:cSld name="Slide 8">
+    <p:bg>
+      <p:bgPr>
+        <a:solidFill>
+          <a:srgbClr val="F8FAFC"/>
+        </a:solidFill>
+      </p:bgPr>
+    </p:bg>
+    <p:spTree>
+      <p:nvGrpSpPr>
+        <p:cNvPr id="1" name=""/>
+        <p:cNvGrpSpPr/>
+        <p:nvPr/>
+      </p:nvGrpSpPr>
+      <p:grpSpPr>
+        <a:xfrm>
+          <a:off x="0" y="0"/>
+          <a:ext cx="0" cy="0"/>
+          <a:chOff x="0" y="0"/>
+          <a:chExt cx="0" cy="0"/>
+        </a:xfrm>
+      </p:grpSpPr>
+      <p:sp>
+        <p:nvSpPr>
+          <p:cNvPr id="2" name="Shape 0"/>
+          <p:cNvSpPr/>
+          <p:nvPr/>
+        </p:nvSpPr>
+        <p:spPr>
+          <a:xfrm>
+            <a:off x="0" y="0"/>
+            <a:ext cx="9144000" cy="54864"/>
+          </a:xfrm>
+          <a:prstGeom prst="rect">
+            <a:avLst/>
+          </a:prstGeom>
+          <a:solidFill>
+            <a:srgbClr val="0EA5E9"/>
+          </a:solidFill>
+          <a:ln/>
+        </p:spPr>
+      </p:sp>
+      <p:sp>
+        <p:nvSpPr>
+          <p:cNvPr id="3" name="Text 1"/>
+          <p:cNvSpPr/>
+          <p:nvPr/>
+        </p:nvSpPr>
+        <p:spPr>
+          <a:xfrm>
+            <a:off x="731520" y="182880"/>
+            <a:ext cx="2743200" cy="320040"/>
+          </a:xfrm>
+          <a:prstGeom prst="rect">
+            <a:avLst/>
+          </a:prstGeom>
+          <a:noFill/>
+          <a:ln/>
+        </p:spPr>
+        <p:txBody>
+          <a:bodyPr wrap="square" lIns="0" tIns="0" rIns="0" bIns="0" rtlCol="0" anchor="ctr"/>
+          <a:lstStyle/>
+          <a:p>
+            <a:pPr indent="0" marL="0">
+              <a:buNone/>
+            </a:pPr>
+            <a:r>
+              <a:rPr lang="en-US" sz="1200" b="1" spc="300" kern="0" dirty="0">
+                <a:solidFill>
+                  <a:srgbClr val="0EA5E9"/>
+                </a:solidFill>
+                <a:latin typeface="Calibri" pitchFamily="34" charset="0"/>
+                <a:ea typeface="Calibri" pitchFamily="34" charset="-122"/>
+                <a:cs typeface="Calibri" pitchFamily="34" charset="-120"/>
+              </a:rPr>
+              <a:t>Composition</a:t>
+            </a:r>
+            <a:endParaRPr lang="en-US" sz="1200" dirty="0"/>
+          </a:p>
+        </p:txBody>
+      </p:sp>
+      <p:sp>
+        <p:nvSpPr>
+          <p:cNvPr id="4" name="Text 2"/>
+          <p:cNvSpPr/>
+          <p:nvPr/>
+        </p:nvSpPr>
+        <p:spPr>
+          <a:xfrm>
+            <a:off x="731520" y="457200"/>
+            <a:ext cx="7772400" cy="502920"/>
+          </a:xfrm>
+          <a:prstGeom prst="rect">
+            <a:avLst/>
+          </a:prstGeom>
+          <a:noFill/>
+          <a:ln/>
+        </p:spPr>
+        <p:txBody>
+          <a:bodyPr wrap="square" lIns="0" tIns="0" rIns="0" bIns="0" rtlCol="0" anchor="ctr"/>
+          <a:lstStyle/>
+          <a:p>
+            <a:pPr indent="0" marL="0">
+              <a:buNone/>
+            </a:pPr>
+            <a:r>
+              <a:rPr lang="en-US" sz="2600" dirty="0">
+                <a:solidFill>
+                  <a:srgbClr val="1E293B"/>
+                </a:solidFill>
+                <a:latin typeface="Arial Black" pitchFamily="34" charset="0"/>
+                <a:ea typeface="Arial Black" pitchFamily="34" charset="-122"/>
+                <a:cs typeface="Arial Black" pitchFamily="34" charset="-120"/>
+              </a:rPr>
+              <a:t>This IS the mental model</a:t>
+            </a:r>
+            <a:endParaRPr lang="en-US" sz="2600" dirty="0"/>
+          </a:p>
+        </p:txBody>
+      </p:sp>
+      <p:sp>
+        <p:nvSpPr>
+          <p:cNvPr id="5" name="Text 3"/>
+          <p:cNvSpPr/>
+          <p:nvPr/>
+        </p:nvSpPr>
+        <p:spPr>
+          <a:xfrm>
+            <a:off x="731520" y="914400"/>
+            <a:ext cx="7772400" cy="274320"/>
+          </a:xfrm>
+          <a:prstGeom prst="rect">
+            <a:avLst/>
+          </a:prstGeom>
+          <a:noFill/>
+          <a:ln/>
+        </p:spPr>
+        <p:txBody>
+          <a:bodyPr wrap="square" lIns="0" tIns="0" rIns="0" bIns="0" rtlCol="0" anchor="ctr"/>
+          <a:lstStyle/>
+          <a:p>
+            <a:pPr indent="0" marL="0">
+              <a:buNone/>
+            </a:pPr>
+            <a:r>
+              <a:rPr lang="en-US" sz="1300" i="1" dirty="0">
+                <a:solidFill>
+                  <a:srgbClr val="475569"/>
+                </a:solidFill>
+                <a:latin typeface="Calibri" pitchFamily="34" charset="0"/>
+                <a:ea typeface="Calibri" pitchFamily="34" charset="-122"/>
+                <a:cs typeface="Calibri" pitchFamily="34" charset="-120"/>
+              </a:rPr>
+              <a:t>One plugin.json — every pillar in one file</a:t>
+            </a:r>
+            <a:endParaRPr lang="en-US" sz="1300" dirty="0"/>
+          </a:p>
+        </p:txBody>
+      </p:sp>
+      <p:sp>
+        <p:nvSpPr>
+          <p:cNvPr id="6" name="Shape 4"/>
+          <p:cNvSpPr/>
+          <p:nvPr/>
+        </p:nvSpPr>
+        <p:spPr>
+          <a:xfrm>
+            <a:off x="731520" y="1417320"/>
+            <a:ext cx="3657600" cy="3017520"/>
+          </a:xfrm>
+          <a:prstGeom prst="rect">
+            <a:avLst/>
+          </a:prstGeom>
+          <a:solidFill>
+            <a:srgbClr val="FFFFFF"/>
+          </a:solidFill>
+          <a:ln/>
+          <a:effectLst>
+            <a:outerShdw sx="100000" sy="100000" kx="0" ky="0" algn="bl" rotWithShape="0" blurRad="50800" dist="25400" dir="8100000">
+              <a:srgbClr val="000000">
+                <a:alpha val="8000"/>
+              </a:srgbClr>
+            </a:outerShdw>
+          </a:effectLst>
+        </p:spPr>
+      </p:sp>
+      <p:sp>
+        <p:nvSpPr>
+          <p:cNvPr id="7" name="Shape 5"/>
+          <p:cNvSpPr/>
+          <p:nvPr/>
+        </p:nvSpPr>
+        <p:spPr>
+          <a:xfrm>
+            <a:off x="731520" y="1417320"/>
+            <a:ext cx="3657600" cy="54864"/>
+          </a:xfrm>
+          <a:prstGeom prst="rect">
+            <a:avLst/>
+          </a:prstGeom>
+          <a:solidFill>
+            <a:srgbClr val="0EA5E9"/>
+          </a:solidFill>
+          <a:ln/>
+        </p:spPr>
+      </p:sp>
+      <p:sp>
+        <p:nvSpPr>
+          <p:cNvPr id="8" name="Text 6"/>
+          <p:cNvSpPr/>
+          <p:nvPr/>
+        </p:nvSpPr>
+        <p:spPr>
+          <a:xfrm>
+            <a:off x="960120" y="1554480"/>
+            <a:ext cx="3200400" cy="228600"/>
+          </a:xfrm>
+          <a:prstGeom prst="rect">
+            <a:avLst/>
+          </a:prstGeom>
+          <a:noFill/>
+          <a:ln/>
+        </p:spPr>
+        <p:txBody>
+          <a:bodyPr wrap="square" lIns="0" tIns="0" rIns="0" bIns="0" rtlCol="0" anchor="ctr"/>
+          <a:lstStyle/>
+          <a:p>
+            <a:pPr indent="0" marL="0">
+              <a:buNone/>
+            </a:pPr>
+            <a:r>
+              <a:rPr lang="en-US" sz="1000" b="1" spc="200" kern="0" dirty="0">
+                <a:solidFill>
+                  <a:srgbClr val="0EA5E9"/>
+                </a:solidFill>
+                <a:latin typeface="Calibri" pitchFamily="34" charset="0"/>
+                <a:ea typeface="Calibri" pitchFamily="34" charset="-122"/>
+                <a:cs typeface="Calibri" pitchFamily="34" charset="-120"/>
+              </a:rPr>
+              <a:t>PILLAR MAPPING</a:t>
+            </a:r>
+            <a:endParaRPr lang="en-US" sz="1000" dirty="0"/>
+          </a:p>
+        </p:txBody>
+      </p:sp>
+      <p:sp>
+        <p:nvSpPr>
+          <p:cNvPr id="9" name="Text 7"/>
+          <p:cNvSpPr/>
+          <p:nvPr/>
+        </p:nvSpPr>
+        <p:spPr>
+          <a:xfrm>
+            <a:off x="960120" y="1828800"/>
+            <a:ext cx="3200400" cy="1097280"/>
+          </a:xfrm>
+          <a:prstGeom prst="rect">
+            <a:avLst/>
+          </a:prstGeom>
+          <a:noFill/>
+          <a:ln/>
+        </p:spPr>
+        <p:txBody>
+          <a:bodyPr wrap="square" lIns="0" tIns="0" rIns="0" bIns="0" rtlCol="0" anchor="ctr"/>
+          <a:lstStyle/>
+          <a:p>
+            <a:pPr indent="0" marL="0">
+              <a:lnSpc>
+                <a:spcPct val="130000"/>
+              </a:lnSpc>
+              <a:buNone/>
+            </a:pPr>
+            <a:r>
+              <a:rPr lang="en-US" sz="1200" dirty="0">
+                <a:solidFill>
+                  <a:srgbClr val="475569"/>
+                </a:solidFill>
+                <a:latin typeface="Calibri" pitchFamily="34" charset="0"/>
+                <a:ea typeface="Calibri" pitchFamily="34" charset="-122"/>
+                <a:cs typeface="Calibri" pitchFamily="34" charset="-120"/>
+              </a:rPr>
+              <a:t>"mcpServers" → Pillar 5 · "agents" → Pillar 3 · "skills" → Pillar 4 · triggers → Pillar 1 · SKILL.md + checks → Pillar 2</a:t>
+            </a:r>
+            <a:endParaRPr lang="en-US" sz="1200" dirty="0"/>
+          </a:p>
+        </p:txBody>
+      </p:sp>
+      <p:sp>
+        <p:nvSpPr>
+          <p:cNvPr id="10" name="Text 8"/>
+          <p:cNvSpPr/>
+          <p:nvPr/>
+        </p:nvSpPr>
+        <p:spPr>
+          <a:xfrm>
+            <a:off x="960120" y="2971800"/>
+            <a:ext cx="3200400" cy="228600"/>
+          </a:xfrm>
+          <a:prstGeom prst="rect">
+            <a:avLst/>
+          </a:prstGeom>
+          <a:noFill/>
+          <a:ln/>
+        </p:spPr>
+        <p:txBody>
+          <a:bodyPr wrap="square" lIns="0" tIns="0" rIns="0" bIns="0" rtlCol="0" anchor="ctr"/>
+          <a:lstStyle/>
+          <a:p>
+            <a:pPr indent="0" marL="0">
+              <a:buNone/>
+            </a:pPr>
+            <a:r>
+              <a:rPr lang="en-US" sz="1000" b="1" spc="200" kern="0" dirty="0">
+                <a:solidFill>
+                  <a:srgbClr val="0EA5E9"/>
+                </a:solidFill>
+                <a:latin typeface="Calibri" pitchFamily="34" charset="0"/>
+                <a:ea typeface="Calibri" pitchFamily="34" charset="-122"/>
+                <a:cs typeface="Calibri" pitchFamily="34" charset="-120"/>
+              </a:rPr>
+              <a:t>WHY IT CLICKS</a:t>
+            </a:r>
+            <a:endParaRPr lang="en-US" sz="1000" dirty="0"/>
+          </a:p>
+        </p:txBody>
+      </p:sp>
+      <p:sp>
+        <p:nvSpPr>
+          <p:cNvPr id="11" name="Text 9"/>
+          <p:cNvSpPr/>
+          <p:nvPr/>
+        </p:nvSpPr>
+        <p:spPr>
+          <a:xfrm>
+            <a:off x="960120" y="3246120"/>
+            <a:ext cx="3200400" cy="1143000"/>
+          </a:xfrm>
+          <a:prstGeom prst="rect">
+            <a:avLst/>
+          </a:prstGeom>
+          <a:noFill/>
+          <a:ln/>
+        </p:spPr>
+        <p:txBody>
+          <a:bodyPr wrap="square" lIns="0" tIns="0" rIns="0" bIns="0" rtlCol="0" anchor="ctr"/>
+          <a:lstStyle/>
+          <a:p>
+            <a:pPr indent="0" marL="0">
+              <a:lnSpc>
+                <a:spcPct val="130000"/>
+              </a:lnSpc>
+              <a:buNone/>
+            </a:pPr>
+            <a:r>
+              <a:rPr lang="en-US" sz="1200" dirty="0">
+                <a:solidFill>
+                  <a:srgbClr val="475569"/>
+                </a:solidFill>
+                <a:latin typeface="Calibri" pitchFamily="34" charset="0"/>
+                <a:ea typeface="Calibri" pitchFamily="34" charset="-122"/>
+                <a:cs typeface="Calibri" pitchFamily="34" charset="-120"/>
+              </a:rPr>
+              <a:t>Install this JSON → engineers get agent + skills + MCP in one action. That's distribution. Bundle once, ship to every teammate.</a:t>
+            </a:r>
+            <a:endParaRPr lang="en-US" sz="1200" dirty="0"/>
+          </a:p>
+        </p:txBody>
+      </p:sp>
+      <p:sp>
+        <p:nvSpPr>
+          <p:cNvPr id="12" name="Shape 10"/>
+          <p:cNvSpPr/>
+          <p:nvPr/>
+        </p:nvSpPr>
+        <p:spPr>
+          <a:xfrm>
+            <a:off x="4663440" y="1417320"/>
+            <a:ext cx="3749040" cy="3017520"/>
+          </a:xfrm>
+          <a:prstGeom prst="rect">
+            <a:avLst/>
+          </a:prstGeom>
+          <a:solidFill>
+            <a:srgbClr val="1E293B"/>
+          </a:solidFill>
+          <a:ln/>
+        </p:spPr>
+      </p:sp>
+      <p:sp>
+        <p:nvSpPr>
+          <p:cNvPr id="13" name="Text 11"/>
+          <p:cNvSpPr/>
+          <p:nvPr/>
+        </p:nvSpPr>
+        <p:spPr>
+          <a:xfrm>
+            <a:off x="4892040" y="1508760"/>
+            <a:ext cx="3200400" cy="228600"/>
+          </a:xfrm>
+          <a:prstGeom prst="rect">
+            <a:avLst/>
+          </a:prstGeom>
+          <a:noFill/>
+          <a:ln/>
+        </p:spPr>
+        <p:txBody>
+          <a:bodyPr wrap="square" lIns="0" tIns="0" rIns="0" bIns="0" rtlCol="0" anchor="ctr"/>
+          <a:lstStyle/>
+          <a:p>
+            <a:pPr indent="0" marL="0">
+              <a:buNone/>
+            </a:pPr>
+            <a:r>
+              <a:rPr lang="en-US" sz="1000" b="1" spc="200" kern="0" dirty="0">
+                <a:solidFill>
+                  <a:srgbClr val="38BDF8"/>
+                </a:solidFill>
+                <a:latin typeface="Calibri" pitchFamily="34" charset="0"/>
+                <a:ea typeface="Calibri" pitchFamily="34" charset="-122"/>
+                <a:cs typeface="Calibri" pitchFamily="34" charset="-120"/>
+              </a:rPr>
+              <a:t>plugin.json (real, from code-review plugin)</a:t>
+            </a:r>
+            <a:endParaRPr lang="en-US" sz="1000" dirty="0"/>
+          </a:p>
+        </p:txBody>
+      </p:sp>
+      <p:sp>
+        <p:nvSpPr>
+          <p:cNvPr id="14" name="Text 12"/>
+          <p:cNvSpPr/>
+          <p:nvPr/>
+        </p:nvSpPr>
+        <p:spPr>
+          <a:xfrm>
+            <a:off x="4892040" y="1783080"/>
+            <a:ext cx="3291840" cy="2560320"/>
+          </a:xfrm>
+          <a:prstGeom prst="rect">
+            <a:avLst/>
+          </a:prstGeom>
+          <a:noFill/>
+          <a:ln/>
+        </p:spPr>
+        <p:txBody>
+          <a:bodyPr wrap="square" lIns="0" tIns="0" rIns="0" bIns="0" rtlCol="0" anchor="ctr"/>
+          <a:lstStyle/>
+          <a:p>
+            <a:pPr indent="0" marL="0">
+              <a:lnSpc>
+                <a:spcPct val="120000"/>
+              </a:lnSpc>
+              <a:buNone/>
+            </a:pPr>
+            <a:r>
+              <a:rPr lang="en-US" sz="1100" dirty="0">
+                <a:solidFill>
+                  <a:srgbClr val="FFFFFF"/>
+                </a:solidFill>
+                <a:latin typeface="Consolas" pitchFamily="34" charset="0"/>
+                <a:ea typeface="Consolas" pitchFamily="34" charset="-122"/>
+                <a:cs typeface="Consolas" pitchFamily="34" charset="-120"/>
+              </a:rPr>
+              <a:t>{</a:t>
+            </a:r>
+            <a:endParaRPr lang="en-US" sz="1100" dirty="0"/>
+          </a:p>
+          <a:p>
+            <a:pPr indent="0" marL="0">
+              <a:lnSpc>
+                <a:spcPct val="120000"/>
+              </a:lnSpc>
+              <a:buNone/>
+            </a:pPr>
+            <a:r>
+              <a:rPr lang="en-US" sz="1100" b="1" dirty="0">
+                <a:solidFill>
+                  <a:srgbClr val="38BDF8"/>
+                </a:solidFill>
+                <a:latin typeface="Consolas" pitchFamily="34" charset="0"/>
+                <a:ea typeface="Consolas" pitchFamily="34" charset="-122"/>
+                <a:cs typeface="Consolas" pitchFamily="34" charset="-120"/>
+              </a:rPr>
+              <a:t xml:space="preserve">  "name": "code-review",</a:t>
+            </a:r>
+            <a:endParaRPr lang="en-US" sz="1100" dirty="0"/>
+          </a:p>
+          <a:p>
+            <a:pPr indent="0" marL="0">
+              <a:lnSpc>
+                <a:spcPct val="120000"/>
+              </a:lnSpc>
+              <a:buNone/>
+            </a:pPr>
+            <a:r>
+              <a:rPr lang="en-US" sz="900" i="1" dirty="0">
+                <a:solidFill>
+                  <a:srgbClr val="94A3B8"/>
+                </a:solidFill>
+                <a:latin typeface="Consolas" pitchFamily="34" charset="0"/>
+                <a:ea typeface="Consolas" pitchFamily="34" charset="-122"/>
+                <a:cs typeface="Consolas" pitchFamily="34" charset="-120"/>
+              </a:rPr>
+              <a:t xml:space="preserve">  "description": "Framework + policy plugins",</a:t>
+            </a:r>
+            <a:endParaRPr lang="en-US" sz="1100" dirty="0"/>
+          </a:p>
+          <a:p>
+            <a:pPr indent="0" marL="0">
+              <a:lnSpc>
+                <a:spcPct val="120000"/>
+              </a:lnSpc>
+              <a:buNone/>
+            </a:pPr>
+            <a:r>
+              <a:rPr lang="en-US" sz="1100" dirty="0">
+                <a:solidFill>
+                  <a:srgbClr val="FFFFFF"/>
+                </a:solidFill>
+                <a:latin typeface="Consolas" pitchFamily="34" charset="0"/>
+                <a:ea typeface="Consolas" pitchFamily="34" charset="-122"/>
+                <a:cs typeface="Consolas" pitchFamily="34" charset="-120"/>
+              </a:rPr>
+              <a:t xml:space="preserve">  "mcpServers": ".mcp.json",</a:t>
+            </a:r>
+            <a:endParaRPr lang="en-US" sz="1100" dirty="0"/>
+          </a:p>
+          <a:p>
+            <a:pPr indent="0" marL="0">
+              <a:lnSpc>
+                <a:spcPct val="120000"/>
+              </a:lnSpc>
+              <a:buNone/>
+            </a:pPr>
+            <a:r>
+              <a:rPr lang="en-US" sz="1100" dirty="0">
+                <a:solidFill>
+                  <a:srgbClr val="38BDF8"/>
+                </a:solidFill>
+                <a:latin typeface="Consolas" pitchFamily="34" charset="0"/>
+                <a:ea typeface="Consolas" pitchFamily="34" charset="-122"/>
+                <a:cs typeface="Consolas" pitchFamily="34" charset="-120"/>
+              </a:rPr>
+              <a:t xml:space="preserve">  "agents": [</a:t>
+            </a:r>
+            <a:endParaRPr lang="en-US" sz="1100" dirty="0"/>
+          </a:p>
+          <a:p>
+            <a:pPr indent="0" marL="0">
+              <a:lnSpc>
+                <a:spcPct val="120000"/>
+              </a:lnSpc>
+              <a:buNone/>
+            </a:pPr>
+            <a:r>
+              <a:rPr lang="en-US" sz="1100" dirty="0">
+                <a:solidFill>
+                  <a:srgbClr val="38BDF8"/>
+                </a:solidFill>
+                <a:latin typeface="Consolas" pitchFamily="34" charset="0"/>
+                <a:ea typeface="Consolas" pitchFamily="34" charset="-122"/>
+                <a:cs typeface="Consolas" pitchFamily="34" charset="-120"/>
+              </a:rPr>
+              <a:t xml:space="preserve">    "./agents/code-reviewer.agent.md"</a:t>
+            </a:r>
+            <a:endParaRPr lang="en-US" sz="1100" dirty="0"/>
+          </a:p>
+          <a:p>
+            <a:pPr indent="0" marL="0">
+              <a:lnSpc>
+                <a:spcPct val="120000"/>
+              </a:lnSpc>
+              <a:buNone/>
+            </a:pPr>
+            <a:r>
+              <a:rPr lang="en-US" sz="1100" dirty="0">
+                <a:solidFill>
+                  <a:srgbClr val="38BDF8"/>
+                </a:solidFill>
+                <a:latin typeface="Consolas" pitchFamily="34" charset="0"/>
+                <a:ea typeface="Consolas" pitchFamily="34" charset="-122"/>
+                <a:cs typeface="Consolas" pitchFamily="34" charset="-120"/>
+              </a:rPr>
+              <a:t xml:space="preserve">  ],</a:t>
+            </a:r>
+            <a:endParaRPr lang="en-US" sz="1100" dirty="0"/>
+          </a:p>
+          <a:p>
+            <a:pPr indent="0" marL="0">
+              <a:lnSpc>
+                <a:spcPct val="120000"/>
+              </a:lnSpc>
+              <a:buNone/>
+            </a:pPr>
+            <a:r>
+              <a:rPr lang="en-US" sz="1100" dirty="0">
+                <a:solidFill>
+                  <a:srgbClr val="38BDF8"/>
+                </a:solidFill>
+                <a:latin typeface="Consolas" pitchFamily="34" charset="0"/>
+                <a:ea typeface="Consolas" pitchFamily="34" charset="-122"/>
+                <a:cs typeface="Consolas" pitchFamily="34" charset="-120"/>
+              </a:rPr>
+              <a:t xml:space="preserve">  "skills": [</a:t>
+            </a:r>
+            <a:endParaRPr lang="en-US" sz="1100" dirty="0"/>
+          </a:p>
+          <a:p>
+            <a:pPr indent="0" marL="0">
+              <a:lnSpc>
+                <a:spcPct val="120000"/>
+              </a:lnSpc>
+              <a:buNone/>
+            </a:pPr>
+            <a:r>
+              <a:rPr lang="en-US" sz="1100" dirty="0">
+                <a:solidFill>
+                  <a:srgbClr val="38BDF8"/>
+                </a:solidFill>
+                <a:latin typeface="Consolas" pitchFamily="34" charset="0"/>
+                <a:ea typeface="Consolas" pitchFamily="34" charset="-122"/>
+                <a:cs typeface="Consolas" pitchFamily="34" charset="-120"/>
+              </a:rPr>
+              <a:t xml:space="preserve">    "./skills/design-patterns",</a:t>
+            </a:r>
+            <a:endParaRPr lang="en-US" sz="1100" dirty="0"/>
+          </a:p>
+          <a:p>
+            <a:pPr indent="0" marL="0">
+              <a:lnSpc>
+                <a:spcPct val="120000"/>
+              </a:lnSpc>
+              <a:buNone/>
+            </a:pPr>
+            <a:r>
+              <a:rPr lang="en-US" sz="1100" dirty="0">
+                <a:solidFill>
+                  <a:srgbClr val="94A3B8"/>
+                </a:solidFill>
+                <a:latin typeface="Consolas" pitchFamily="34" charset="0"/>
+                <a:ea typeface="Consolas" pitchFamily="34" charset="-122"/>
+                <a:cs typeface="Consolas" pitchFamily="34" charset="-120"/>
+              </a:rPr>
+              <a:t xml:space="preserve">    "./skills/hims-ads-policy", …</a:t>
+            </a:r>
+            <a:endParaRPr lang="en-US" sz="1100" dirty="0"/>
+          </a:p>
+          <a:p>
+            <a:pPr indent="0" marL="0">
+              <a:lnSpc>
+                <a:spcPct val="120000"/>
+              </a:lnSpc>
+              <a:buNone/>
+            </a:pPr>
+            <a:r>
+              <a:rPr lang="en-US" sz="1100" dirty="0">
+                <a:solidFill>
+                  <a:srgbClr val="94A3B8"/>
+                </a:solidFill>
+                <a:latin typeface="Consolas" pitchFamily="34" charset="0"/>
+                <a:ea typeface="Consolas" pitchFamily="34" charset="-122"/>
+                <a:cs typeface="Consolas" pitchFamily="34" charset="-120"/>
+              </a:rPr>
+              <a:t xml:space="preserve">  ]}</a:t>
+            </a:r>
+            <a:endParaRPr lang="en-US" sz="1100" dirty="0"/>
+          </a:p>
+        </p:txBody>
+      </p:sp>
+      <p:pic>
+        <p:nvPicPr>
+          <p:cNvPr id="15" name="Image 0" descr="preencoded.png"/>
+          <p:cNvPicPr>
+            <a:picLocks noChangeAspect="1"/>
+          </p:cNvPicPr>
+          <p:nvPr/>
+        </p:nvPicPr>
+        <p:blipFill>
+          <a:blip r:embed="rId1"/>
+          <a:stretch>
+            <a:fillRect/>
+          </a:stretch>
+        </p:blipFill>
+        <p:spPr>
+          <a:xfrm>
+            <a:off x="731520" y="4572000"/>
+            <a:ext cx="274320" cy="274320"/>
+          </a:xfrm>
+          <a:prstGeom prst="rect">
+            <a:avLst/>
+          </a:prstGeom>
+        </p:spPr>
+      </p:pic>
+      <p:sp>
+        <p:nvSpPr>
+          <p:cNvPr id="16" name="Text 13"/>
+          <p:cNvSpPr/>
+          <p:nvPr/>
+        </p:nvSpPr>
+        <p:spPr>
+          <a:xfrm>
+            <a:off x="1097280" y="4572000"/>
+            <a:ext cx="6858000" cy="320040"/>
+          </a:xfrm>
+          <a:prstGeom prst="rect">
+            <a:avLst/>
+          </a:prstGeom>
+          <a:noFill/>
+          <a:ln/>
+        </p:spPr>
+        <p:txBody>
+          <a:bodyPr wrap="square" lIns="0" tIns="0" rIns="0" bIns="0" rtlCol="0" anchor="ctr"/>
+          <a:lstStyle/>
+          <a:p>
+            <a:pPr indent="0" marL="0">
+              <a:buNone/>
+            </a:pPr>
+            <a:r>
+              <a:rPr lang="en-US" sz="1300" b="1" dirty="0">
+                <a:solidFill>
+                  <a:srgbClr val="0EA5E9"/>
+                </a:solidFill>
+                <a:latin typeface="Calibri" pitchFamily="34" charset="0"/>
+                <a:ea typeface="Calibri" pitchFamily="34" charset="-122"/>
+                <a:cs typeface="Calibri" pitchFamily="34" charset="-120"/>
+              </a:rPr>
+              <a:t>Install this JSON → everything shows up. That is distribution.</a:t>
+            </a:r>
+            <a:endParaRPr lang="en-US" sz="1300" dirty="0"/>
           </a:p>
         </p:txBody>
       </p:sp>
@@ -17708,7 +15726,7 @@
                           <a:ea typeface="Calibri" pitchFamily="34" charset="-122"/>
                           <a:cs typeface="Calibri" pitchFamily="34" charset="-120"/>
                         </a:rPr>
-                        <a:t>Live demo: work item → merged PR</a:t>
+                        <a:t>Install plugin → run code review PR live</a:t>
                       </a:r>
                       <a:endParaRPr lang="en-US" sz="1100" dirty="0">
                         <a:latin typeface="Calibri" charset="0"/>
@@ -17778,7 +15796,7 @@
                           <a:ea typeface="Calibri" pitchFamily="34" charset="-122"/>
                           <a:cs typeface="Calibri" pitchFamily="34" charset="-120"/>
                         </a:rPr>
-                        <a:t>12 min</a:t>
+                        <a:t>15 min</a:t>
                       </a:r>
                       <a:endParaRPr lang="en-US" sz="1100" dirty="0">
                         <a:latin typeface="Calibri" charset="0"/>
@@ -18190,7 +16208,7 @@
                           <a:ea typeface="Calibri" pitchFamily="34" charset="-122"/>
                           <a:cs typeface="Calibri" pitchFamily="34" charset="-120"/>
                         </a:rPr>
-                        <a:t>18 min</a:t>
+                        <a:t>20 min</a:t>
                       </a:r>
                       <a:endParaRPr lang="en-US" sz="1100" dirty="0">
                         <a:latin typeface="Calibri" charset="0"/>
@@ -18396,7 +16414,7 @@
                           <a:ea typeface="Calibri" pitchFamily="34" charset="-122"/>
                           <a:cs typeface="Calibri" pitchFamily="34" charset="-120"/>
                         </a:rPr>
-                        <a:t>35 min</a:t>
+                        <a:t>30 min</a:t>
                       </a:r>
                       <a:endParaRPr lang="en-US" sz="1100" dirty="0">
                         <a:latin typeface="Calibri" charset="0"/>
@@ -18532,7 +16550,7 @@
                           <a:ea typeface="Calibri" pitchFamily="34" charset="-122"/>
                           <a:cs typeface="Calibri" pitchFamily="34" charset="-120"/>
                         </a:rPr>
-                        <a:t>Skills — Why, What, Code Review, Checkmarx</a:t>
+                        <a:t>Skills — Why, What, Code Review Showcase</a:t>
                       </a:r>
                       <a:endParaRPr lang="en-US" sz="1100" dirty="0">
                         <a:latin typeface="Calibri" charset="0"/>
@@ -18808,7 +16826,7 @@
                           <a:ea typeface="Calibri" pitchFamily="34" charset="-122"/>
                           <a:cs typeface="Calibri" pitchFamily="34" charset="-120"/>
                         </a:rPr>
-                        <a:t>15 min</a:t>
+                        <a:t>10 min</a:t>
                       </a:r>
                       <a:endParaRPr lang="en-US" sz="1100" dirty="0">
                         <a:latin typeface="Calibri" charset="0"/>
@@ -18876,7 +16894,7 @@
                           <a:ea typeface="Calibri" pitchFamily="34" charset="-122"/>
                           <a:cs typeface="Calibri" pitchFamily="34" charset="-120"/>
                         </a:rPr>
-                        <a:t>Pillar 6</a:t>
+                        <a:t>Composition</a:t>
                       </a:r>
                       <a:endParaRPr lang="en-US" sz="1200" dirty="0">
                         <a:latin typeface="Calibri" charset="0"/>
@@ -18944,7 +16962,7 @@
                           <a:ea typeface="Calibri" pitchFamily="34" charset="-122"/>
                           <a:cs typeface="Calibri" pitchFamily="34" charset="-120"/>
                         </a:rPr>
-                        <a:t>Automation — Pipeline Example</a:t>
+                        <a:t>How a plugin ties it all together</a:t>
                       </a:r>
                       <a:endParaRPr lang="en-US" sz="1100" dirty="0">
                         <a:latin typeface="Calibri" charset="0"/>
@@ -19209,7 +17227,7 @@
                           <a:ea typeface="Calibri" pitchFamily="34" charset="-122"/>
                           <a:cs typeface="Calibri" pitchFamily="34" charset="-120"/>
                         </a:rPr>
-                        <a:t>50 min</a:t>
+                        <a:t>35 min</a:t>
                       </a:r>
                       <a:endParaRPr lang="en-US" sz="1100" dirty="0">
                         <a:latin typeface="Calibri" charset="0"/>
@@ -19345,7 +17363,7 @@
                           <a:ea typeface="Calibri" pitchFamily="34" charset="-122"/>
                           <a:cs typeface="Calibri" pitchFamily="34" charset="-120"/>
                         </a:rPr>
-                        <a:t>Design + Build a Skill Together</a:t>
+                        <a:t>Fork the template, ship 1 skill</a:t>
                       </a:r>
                       <a:endParaRPr lang="en-US" sz="1100" dirty="0">
                         <a:latin typeface="Calibri" charset="0"/>
@@ -19640,7 +17658,7 @@
                 <a:ea typeface="Calibri" pitchFamily="34" charset="-122"/>
                 <a:cs typeface="Calibri" pitchFamily="34" charset="-120"/>
               </a:rPr>
-              <a:t>Total: ~3 hours</a:t>
+              <a:t>Total: ~3h 10m</a:t>
             </a:r>
             <a:endParaRPr lang="en-US" sz="1400" dirty="0"/>
           </a:p>
@@ -19731,7 +17749,7 @@
                 <a:ea typeface="Arial Black" pitchFamily="34" charset="-122"/>
                 <a:cs typeface="Arial Black" pitchFamily="34" charset="-120"/>
               </a:rPr>
-              <a:t>Opening: The Vision</a:t>
+              <a:t>Opening: See It All At Once</a:t>
             </a:r>
             <a:endParaRPr lang="en-US" sz="3000" dirty="0"/>
           </a:p>
@@ -19770,7 +17788,7 @@
                 <a:ea typeface="Calibri" pitchFamily="34" charset="-122"/>
                 <a:cs typeface="Calibri" pitchFamily="34" charset="-120"/>
               </a:rPr>
-              <a:t>Live demo: work item → merged PR in one terminal session</a:t>
+              <a:t>Live demo: install a plugin, then run it</a:t>
             </a:r>
             <a:endParaRPr lang="en-US" sz="1400" dirty="0"/>
           </a:p>
@@ -19868,7 +17886,7 @@
                 <a:ea typeface="Calibri" pitchFamily="34" charset="-122"/>
                 <a:cs typeface="Calibri" pitchFamily="34" charset="-120"/>
               </a:rPr>
-              <a:t>Pull work item from ADO</a:t>
+              <a:t>Install 'code-review' plugin from VS Code</a:t>
             </a:r>
             <a:endParaRPr lang="en-US" sz="1300" dirty="0"/>
           </a:p>
@@ -19927,7 +17945,7 @@
                 <a:ea typeface="Consolas" pitchFamily="34" charset="-122"/>
                 <a:cs typeface="Consolas" pitchFamily="34" charset="-120"/>
               </a:rPr>
-              <a:t>"Show me work item #576684"</a:t>
+              <a:t>1 agent · 6 skills · ADO MCP</a:t>
             </a:r>
             <a:endParaRPr lang="en-US" sz="1100" dirty="0"/>
           </a:p>
@@ -20025,7 +18043,7 @@
                 <a:ea typeface="Calibri" pitchFamily="34" charset="-122"/>
                 <a:cs typeface="Calibri" pitchFamily="34" charset="-120"/>
               </a:rPr>
-              <a:t>Plan the approach</a:t>
+              <a:t>Start Copilot CLI</a:t>
             </a:r>
             <a:endParaRPr lang="en-US" sz="1300" dirty="0"/>
           </a:p>
@@ -20084,7 +18102,7 @@
                 <a:ea typeface="Consolas" pitchFamily="34" charset="-122"/>
                 <a:cs typeface="Consolas" pitchFamily="34" charset="-120"/>
               </a:rPr>
-              <a:t>/plan &lt;feature&gt;</a:t>
+              <a:t>copilot</a:t>
             </a:r>
             <a:endParaRPr lang="en-US" sz="1100" dirty="0"/>
           </a:p>
@@ -20182,7 +18200,7 @@
                 <a:ea typeface="Calibri" pitchFamily="34" charset="-122"/>
                 <a:cs typeface="Calibri" pitchFamily="34" charset="-120"/>
               </a:rPr>
-              <a:t>Switch to specialist agent</a:t>
+              <a:t>Invoke the code review agent</a:t>
             </a:r>
             <a:endParaRPr lang="en-US" sz="1300" dirty="0"/>
           </a:p>
@@ -20241,7 +18259,7 @@
                 <a:ea typeface="Consolas" pitchFamily="34" charset="-122"/>
                 <a:cs typeface="Consolas" pitchFamily="34" charset="-120"/>
               </a:rPr>
-              <a:t>/agent csharp-reviewer</a:t>
+              <a:t>&gt; code review PR #1234</a:t>
             </a:r>
             <a:endParaRPr lang="en-US" sz="1100" dirty="0"/>
           </a:p>
@@ -20339,7 +18357,7 @@
                 <a:ea typeface="Calibri" pitchFamily="34" charset="-122"/>
                 <a:cs typeface="Calibri" pitchFamily="34" charset="-120"/>
               </a:rPr>
-              <a:t>Implement with skill standards</a:t>
+              <a:t>Agent fetches PR via ADO MCP</a:t>
             </a:r>
             <a:endParaRPr lang="en-US" sz="1300" dirty="0"/>
           </a:p>
@@ -20398,7 +18416,7 @@
                 <a:ea typeface="Consolas" pitchFamily="34" charset="-122"/>
                 <a:cs typeface="Consolas" pitchFamily="34" charset="-120"/>
               </a:rPr>
-              <a:t>(auto-triggers)</a:t>
+              <a:t>(loads policies, inspects diff)</a:t>
             </a:r>
             <a:endParaRPr lang="en-US" sz="1100" dirty="0"/>
           </a:p>
@@ -20496,7 +18514,7 @@
                 <a:ea typeface="Calibri" pitchFamily="34" charset="-122"/>
                 <a:cs typeface="Calibri" pitchFamily="34" charset="-120"/>
               </a:rPr>
-              <a:t>Review</a:t>
+              <a:t>Sub-agents run in parallel</a:t>
             </a:r>
             <a:endParaRPr lang="en-US" sz="1300" dirty="0"/>
           </a:p>
@@ -20555,7 +18573,7 @@
                 <a:ea typeface="Consolas" pitchFamily="34" charset="-122"/>
                 <a:cs typeface="Consolas" pitchFamily="34" charset="-120"/>
               </a:rPr>
-              <a:t>/review</a:t>
+              <a:t>security · quality · performance</a:t>
             </a:r>
             <a:endParaRPr lang="en-US" sz="1100" dirty="0"/>
           </a:p>
@@ -20653,7 +18671,7 @@
                 <a:ea typeface="Calibri" pitchFamily="34" charset="-122"/>
                 <a:cs typeface="Calibri" pitchFamily="34" charset="-120"/>
               </a:rPr>
-              <a:t>Ship</a:t>
+              <a:t>Inline comments posted</a:t>
             </a:r>
             <a:endParaRPr lang="en-US" sz="1300" dirty="0"/>
           </a:p>
@@ -20712,7 +18730,7 @@
                 <a:ea typeface="Consolas" pitchFamily="34" charset="-122"/>
                 <a:cs typeface="Consolas" pitchFamily="34" charset="-120"/>
               </a:rPr>
-              <a:t>/pr create</a:t>
+              <a:t>threaded at file:line in ADO</a:t>
             </a:r>
             <a:endParaRPr lang="en-US" sz="1100" dirty="0"/>
           </a:p>
@@ -20771,7 +18789,7 @@
                 <a:ea typeface="Calibri" pitchFamily="34" charset="-122"/>
                 <a:cs typeface="Calibri" pitchFamily="34" charset="-120"/>
               </a:rPr>
-              <a:t>"Your engineers don't need to learn prompts. They need you to set up the system."</a:t>
+              <a:t>One install → one command → all six pillars in motion.</a:t>
             </a:r>
             <a:endParaRPr lang="en-US" sz="1200" dirty="0"/>
           </a:p>
@@ -22128,7 +20146,7 @@
                 <a:ea typeface="Arial Black" pitchFamily="34" charset="-122"/>
                 <a:cs typeface="Arial Black" pitchFamily="34" charset="-120"/>
               </a:rPr>
-              <a:t>Scaling with the Indexing Pattern</a:t>
+              <a:t>Real example: the design-patterns skill</a:t>
             </a:r>
             <a:endParaRPr lang="en-US" sz="2600" dirty="0"/>
           </a:p>
@@ -22167,7 +20185,7 @@
                 <a:ea typeface="Calibri" pitchFamily="34" charset="-122"/>
                 <a:cs typeface="Calibri" pitchFamily="34" charset="-120"/>
               </a:rPr>
-              <a:t>For complex projects: AGENTS.md as the table of contents, docs/ as the detail</a:t>
+              <a:t>The same pattern that scales complex repos also scales a single skill — here it is, live in the code-review plugin</a:t>
             </a:r>
             <a:endParaRPr lang="en-US" sz="1300" dirty="0"/>
           </a:p>
@@ -22295,7 +20313,7 @@
                 <a:ea typeface="Calibri" pitchFamily="34" charset="-122"/>
                 <a:cs typeface="Calibri" pitchFamily="34" charset="-120"/>
               </a:rPr>
-              <a:t>A single AGENTS.md can't capture everything about a real project — architecture, API conventions, deployment, security, domain logic.</a:t>
+              <a:t>A single SKILL.md can't hold every design-pattern check — creational, structural, behavioral, architectural. Too long → bloated context.</a:t>
             </a:r>
             <a:endParaRPr lang="en-US" sz="1200" dirty="0"/>
           </a:p>
@@ -22376,7 +20394,7 @@
                 <a:ea typeface="Calibri" pitchFamily="34" charset="-122"/>
                 <a:cs typeface="Calibri" pitchFamily="34" charset="-120"/>
               </a:rPr>
-              <a:t>AGENTS.md becomes an index — a short file that points to detailed docs in docs/. AI loads the index always, detail docs only when needed.</a:t>
+              <a:t>SKILL.md is the index — short, always loaded. checks/*.md files are details — loaded only when the skill runs. Same pattern scales at the repo level with AGENTS.md + docs/.</a:t>
             </a:r>
             <a:endParaRPr lang="en-US" sz="1200" dirty="0"/>
           </a:p>
@@ -22477,7 +20495,7 @@
                 <a:ea typeface="Consolas" pitchFamily="34" charset="-122"/>
                 <a:cs typeface="Consolas" pitchFamily="34" charset="-120"/>
               </a:rPr>
-              <a:t>📁 your-repo/</a:t>
+              <a:t>📁 code-review/skills/design-patterns/</a:t>
             </a:r>
             <a:endParaRPr lang="en-US" sz="1100" dirty="0"/>
           </a:p>
@@ -22497,7 +20515,7 @@
                 <a:ea typeface="Consolas" pitchFamily="34" charset="-122"/>
                 <a:cs typeface="Consolas" pitchFamily="34" charset="-120"/>
               </a:rPr>
-              <a:t>├── AGENTS.md</a:t>
+              <a:t>├── SKILL.md</a:t>
             </a:r>
             <a:endParaRPr lang="en-US" sz="1100" dirty="0"/>
           </a:p>
@@ -22517,7 +20535,7 @@
                 <a:ea typeface="Consolas" pitchFamily="34" charset="-122"/>
                 <a:cs typeface="Consolas" pitchFamily="34" charset="-120"/>
               </a:rPr>
-              <a:t>│   (index → points to docs)</a:t>
+              <a:t>│   (index: inputs, severity, checks)</a:t>
             </a:r>
             <a:endParaRPr lang="en-US" sz="1100" dirty="0"/>
           </a:p>
@@ -22537,7 +20555,7 @@
                 <a:ea typeface="Consolas" pitchFamily="34" charset="-122"/>
                 <a:cs typeface="Consolas" pitchFamily="34" charset="-120"/>
               </a:rPr>
-              <a:t>├── docs/</a:t>
+              <a:t>├── checks/</a:t>
             </a:r>
             <a:endParaRPr lang="en-US" sz="1100" dirty="0"/>
           </a:p>
@@ -22557,7 +20575,7 @@
                 <a:ea typeface="Consolas" pitchFamily="34" charset="-122"/>
                 <a:cs typeface="Consolas" pitchFamily="34" charset="-120"/>
               </a:rPr>
-              <a:t>│   ├── architecture.md</a:t>
+              <a:t>│   ├── dp-creational.md</a:t>
             </a:r>
             <a:endParaRPr lang="en-US" sz="1100" dirty="0"/>
           </a:p>
@@ -22577,7 +20595,7 @@
                 <a:ea typeface="Consolas" pitchFamily="34" charset="-122"/>
                 <a:cs typeface="Consolas" pitchFamily="34" charset="-120"/>
               </a:rPr>
-              <a:t>│   ├── csharp-conventions.md</a:t>
+              <a:t>│   ├── dp-structural.md</a:t>
             </a:r>
             <a:endParaRPr lang="en-US" sz="1100" dirty="0"/>
           </a:p>
@@ -22597,7 +20615,7 @@
                 <a:ea typeface="Consolas" pitchFamily="34" charset="-122"/>
                 <a:cs typeface="Consolas" pitchFamily="34" charset="-120"/>
               </a:rPr>
-              <a:t>│   ├── typescript-style.md</a:t>
+              <a:t>│   ├── dp-behavioral.md</a:t>
             </a:r>
             <a:endParaRPr lang="en-US" sz="1100" dirty="0"/>
           </a:p>
@@ -22617,7 +20635,7 @@
                 <a:ea typeface="Consolas" pitchFamily="34" charset="-122"/>
                 <a:cs typeface="Consolas" pitchFamily="34" charset="-120"/>
               </a:rPr>
-              <a:t>│   ├── api-design.md</a:t>
+              <a:t>│   ├── dp-architectural.md</a:t>
             </a:r>
             <a:endParaRPr lang="en-US" sz="1100" dirty="0"/>
           </a:p>
@@ -22637,7 +20655,7 @@
                 <a:ea typeface="Consolas" pitchFamily="34" charset="-122"/>
                 <a:cs typeface="Consolas" pitchFamily="34" charset="-120"/>
               </a:rPr>
-              <a:t>│   └── deployment.md</a:t>
+              <a:t>│   └── dp-anti-patterns.md</a:t>
             </a:r>
             <a:endParaRPr lang="en-US" sz="1100" dirty="0"/>
           </a:p>
@@ -22657,7 +20675,7 @@
                 <a:ea typeface="Consolas" pitchFamily="34" charset="-122"/>
                 <a:cs typeface="Consolas" pitchFamily="34" charset="-120"/>
               </a:rPr>
-              <a:t>├── src/</a:t>
+              <a:t>└── (1 SKILL + 5 checks)</a:t>
             </a:r>
             <a:endParaRPr lang="en-US" sz="1100" dirty="0"/>
           </a:p>
@@ -22677,7 +20695,7 @@
                 <a:ea typeface="Consolas" pitchFamily="34" charset="-122"/>
                 <a:cs typeface="Consolas" pitchFamily="34" charset="-120"/>
               </a:rPr>
-              <a:t>└── ...</a:t>
+              <a:t>(from the real code-review plugin)</a:t>
             </a:r>
             <a:endParaRPr lang="en-US" sz="1100" dirty="0"/>
           </a:p>
@@ -22740,7 +20758,7 @@
                 <a:ea typeface="Calibri" pitchFamily="34" charset="-122"/>
                 <a:cs typeface="Calibri" pitchFamily="34" charset="-120"/>
               </a:rPr>
-              <a:t>Keep AGENTS.md short. Let it point. Detail docs stay discoverable but don't bloat context.</a:t>
+              <a:t>From the code-review plugin — Pillar 2 in practice.</a:t>
             </a:r>
             <a:endParaRPr lang="en-US" sz="1300" dirty="0"/>
           </a:p>
@@ -23214,7 +21232,7 @@
                 <a:ea typeface="Calibri" pitchFamily="34" charset="-122"/>
                 <a:cs typeface="Calibri" pitchFamily="34" charset="-120"/>
               </a:rPr>
-              <a:t>/agent csharp-reviewer</a:t>
+              <a:t>&gt; code review PR #1234</a:t>
             </a:r>
             <a:endParaRPr lang="en-US" sz="1200" dirty="0"/>
           </a:p>
@@ -23234,7 +21252,7 @@
                 <a:ea typeface="Calibri" pitchFamily="34" charset="-122"/>
                 <a:cs typeface="Calibri" pitchFamily="34" charset="-120"/>
               </a:rPr>
-              <a:t>"Review @BooksController.cs"</a:t>
+              <a:t>Phase 1: Intake → Phase 2: Load policies</a:t>
             </a:r>
             <a:endParaRPr lang="en-US" sz="1200" dirty="0"/>
           </a:p>
@@ -23254,7 +21272,7 @@
                 <a:ea typeface="Calibri" pitchFamily="34" charset="-122"/>
                 <a:cs typeface="Calibri" pitchFamily="34" charset="-120"/>
               </a:rPr>
-              <a:t>→ Nullable checks, async/await,</a:t>
+              <a:t>Phase 3: Sub-agents run in parallel</a:t>
             </a:r>
             <a:endParaRPr lang="en-US" sz="1200" dirty="0"/>
           </a:p>
@@ -23274,7 +21292,7 @@
                 <a:ea typeface="Calibri" pitchFamily="34" charset="-122"/>
                 <a:cs typeface="Calibri" pitchFamily="34" charset="-120"/>
               </a:rPr>
-              <a:t xml:space="preserve">    dependency injection patterns</a:t>
+              <a:t xml:space="preserve">    Phase 4: Inline comments posted to ADO PR</a:t>
             </a:r>
             <a:endParaRPr lang="en-US" sz="1200" dirty="0"/>
           </a:p>
@@ -23431,7 +21449,7 @@
                 <a:ea typeface="Consolas" pitchFamily="34" charset="-122"/>
                 <a:cs typeface="Consolas" pitchFamily="34" charset="-120"/>
               </a:rPr>
-              <a:t>.github/agents/csharp-reviewer.agent.md</a:t>
+              <a:t>.github/agents/code-reviewer.agent.md</a:t>
             </a:r>
             <a:r>
               <a:rPr lang="en-US" sz="1000" i="1" dirty="0">
@@ -23459,7 +21477,7 @@
                 <a:ea typeface="Consolas" pitchFamily="34" charset="-122"/>
                 <a:cs typeface="Consolas" pitchFamily="34" charset="-120"/>
               </a:rPr>
-              <a:t>~/.copilot/agents/csharp-reviewer.agent.md</a:t>
+              <a:t>~/.copilot/agents/code-reviewer.agent.md</a:t>
             </a:r>
             <a:r>
               <a:rPr lang="en-US" sz="1000" i="1" dirty="0">
@@ -23493,7 +21511,7 @@
                 <a:ea typeface="Consolas" pitchFamily="34" charset="-122"/>
                 <a:cs typeface="Consolas" pitchFamily="34" charset="-120"/>
               </a:rPr>
-              <a:t>description: "Reviews C# for team conventions"</a:t>
+              <a:t>description: "Policy-driven code review"</a:t>
             </a:r>
             <a:endParaRPr lang="en-US" sz="1000" dirty="0"/>
           </a:p>
@@ -23510,7 +21528,7 @@
                 <a:ea typeface="Consolas" pitchFamily="34" charset="-122"/>
                 <a:cs typeface="Consolas" pitchFamily="34" charset="-120"/>
               </a:rPr>
-              <a:t>→ Enforces nullable refs, async patterns, DI</a:t>
+              <a:t>→ Triggers: "code review", "review PR", "review my changes"</a:t>
             </a:r>
             <a:endParaRPr lang="en-US" sz="1000" dirty="0"/>
           </a:p>

</xml_diff>